<commit_message>
Remove unverified claims: CRM-validated -> SA360-reported source of record, plus three same-class fixes (Renzo no-assumptions ruling)
Co-Authored-By: Claude Fable 5 <noreply@anthropic.com>
</commit_message>
<xml_diff>
--- a/reports/forex/ggmi/2026-07/output/GGMI_LATAM_July_2026_Performance_Review.pptx
+++ b/reports/forex/ggmi/2026-07/output/GGMI_LATAM_July_2026_Performance_Review.pptx
@@ -4211,7 +4211,7 @@
                 </a:solidFill>
                 <a:latin typeface="Calibri"/>
               </a:rPr>
-              <a:t>The channel figure is the stable read: $914.85 per vendor-reported application, in line with the account’s recent months.</a:t>
+              <a:t>The channel figure is the stable read: $914.85 per vendor-reported application, against $834 in June.</a:t>
             </a:r>
           </a:p>
           <a:p>
@@ -6255,7 +6255,7 @@
                 </a:solidFill>
                 <a:latin typeface="Calibri"/>
               </a:rPr>
-              <a:t>The platform reports 117 submitted-application pixel fires; that figure is Meta-reported and unvalidated, is not compared to Bing’s CRM-validated count, and carries no cost-per-application figure.</a:t>
+              <a:t>The platform reports 117 submitted-application pixel fires; that figure is Meta-reported and unvalidated, is not compared to Bing’s SA360-reported count, and carries no cost-per-application figure.</a:t>
             </a:r>
           </a:p>
         </p:txBody>
@@ -8520,7 +8520,7 @@
                 </a:solidFill>
                 <a:latin typeface="Calibri"/>
               </a:rPr>
-              <a:t>The submitted-application key event began counting correctly on July 31 and has held at full capture since. July is reported on the CRM count; August is the first month GA4 can corroborate it independently.</a:t>
+              <a:t>The submitted-application key event began counting correctly on July 31 and has held at full capture since. July is reported on the SA360 count; August is the first month GA4 can corroborate it independently.</a:t>
             </a:r>
           </a:p>
           <a:p>
@@ -8536,7 +8536,7 @@
                 </a:solidFill>
                 <a:latin typeface="Calibri"/>
               </a:rPr>
-              <a:t>The Bing-to-GA4 account link is in progress with the site team; the paid-search restatement June’s deck flagged lands once the connection is verified, expected alongside August’s corroboration.</a:t>
+              <a:t>Completion of the Bing-to-GA4 account link has not yet been verified; the paid-search restatement June’s deck flagged lands once it is, expected alongside August’s corroboration.</a:t>
             </a:r>
           </a:p>
         </p:txBody>
@@ -12039,7 +12039,7 @@
                 </a:solidFill>
                 <a:latin typeface="Calibri"/>
               </a:rPr>
-              <a:t>* Azerion applications are vendor-reported; Bing applications are CRM-validated. Conversions come from different systems per channel and are never summed; the combined Bing + Azerion view is the one sanctioned pairing. Meta clicks are link clicks. Spend per the client budget tracker.</a:t>
+              <a:t>* Azerion applications are vendor-reported; Bing applications are SA360-reported, the account’s conversion source of record. Conversions come from different systems per channel and are never summed; the combined Bing + Azerion view is the one sanctioned pairing. Meta clicks are link clicks. Spend per the client budget tracker.</a:t>
             </a:r>
           </a:p>
         </p:txBody>
@@ -14454,7 +14454,7 @@
                 </a:solidFill>
                 <a:latin typeface="Calibri"/>
               </a:rPr>
-              <a:t>CRM-validated</a:t>
+              <a:t>SA360 source of record</a:t>
             </a:r>
           </a:p>
         </p:txBody>
@@ -15896,7 +15896,7 @@
                 </a:solidFill>
                 <a:latin typeface="Calibri"/>
               </a:rPr>
-              <a:t>84% of legacy-campaign clicks landed on pages outside the application flow, and every one of the 207 application starts stopped at the second step. The rebuilt campaigns land on the Spanish-language site and convert. Landing destination and keyword intent changed together, so this is a strong signal rather than a proven single cause, and it matches the conclusion already reached on the account: the loss sits between a started and a submitted application.</a:t>
+              <a:t>84% of legacy-campaign clicks landed on pages outside the application flow, and every one of the 207 application starts stopped at the second step. The rebuilt campaigns land on the Spanish-language site and convert. Landing destination and keyword intent changed together, so this is a strong signal rather than a proven single cause. The step data itself is unambiguous: the loss sits between a started and a submitted application.</a:t>
             </a:r>
           </a:p>
           <a:p>
@@ -20282,7 +20282,7 @@
                 </a:solidFill>
                 <a:latin typeface="Calibri"/>
               </a:rPr>
-              <a:t>Applications are vendor-reported, not CRM-validated the way Bing’s count is; the distinction travels with the number.</a:t>
+              <a:t>Applications are reported by the vendor’s own tracking rather than by SA360, the source of record behind Bing’s count; the distinction travels with the number.</a:t>
             </a:r>
           </a:p>
           <a:p>

</xml_diff>

<commit_message>
Tone ruling: fact->impact->next formula into doctrine, deck headlines and strips revised
Co-Authored-By: Claude Fable 5 <noreply@anthropic.com>
</commit_message>
<xml_diff>
--- a/reports/forex/ggmi/2026-07/output/GGMI_LATAM_July_2026_Performance_Review.pptx
+++ b/reports/forex/ggmi/2026-07/output/GGMI_LATAM_July_2026_Performance_Review.pptx
@@ -7290,7 +7290,7 @@
                 </a:solidFill>
                 <a:latin typeface="Georgia"/>
               </a:rPr>
-              <a:t>Context, not conversion, and the measurement fix that unlocks August.</a:t>
+              <a:t>Context this month. The measurement fix makes August the first fully measured month.</a:t>
             </a:r>
           </a:p>
         </p:txBody>
@@ -8736,7 +8736,7 @@
                 </a:solidFill>
                 <a:latin typeface="Georgia"/>
               </a:rPr>
-              <a:t>Lock in the rebuild. Finish the measurement. Hold programmatic quality.</a:t>
+              <a:t>August priorities: targeting configuration, measurement completion, inventory quality.</a:t>
             </a:r>
           </a:p>
         </p:txBody>
@@ -9633,7 +9633,7 @@
                 </a:solidFill>
                 <a:latin typeface="Georgia"/>
               </a:rPr>
-              <a:t>July proved the rebuilt structure. August locks it in: configuration hardening, one landing destination, bidding signal on.</a:t>
+              <a:t>The rebuilt structure converted at $237.12 in July. In August: harden the targeting configuration, standardize the landing destination, enable the bidding signal.</a:t>
             </a:r>
           </a:p>
         </p:txBody>
@@ -12340,7 +12340,7 @@
                 </a:solidFill>
                 <a:latin typeface="Georgia"/>
               </a:rPr>
-              <a:t>THE STORY OF THE MONTH</a:t>
+              <a:t>THE REBUILT STRUCTURE</a:t>
             </a:r>
           </a:p>
         </p:txBody>
@@ -13360,7 +13360,7 @@
                 </a:solidFill>
                 <a:latin typeface="Georgia"/>
               </a:rPr>
-              <a:t>The rebuild is the story: $237.12 per submitted application on the new structure, with the configuration hardening next.</a:t>
+              <a:t>The rebuilt structure delivered $237.12 per submitted application. Next: harden the configuration so that holds at scale.</a:t>
             </a:r>
           </a:p>
         </p:txBody>
@@ -15606,7 +15606,7 @@
                 </a:solidFill>
                 <a:latin typeface="Georgia"/>
               </a:rPr>
-              <a:t>The rebuild superseded June’s campaign picks. Lock in what it fixed.</a:t>
+              <a:t>The rebuild superseded June’s campaign picks. Three actions carry it into August.</a:t>
             </a:r>
           </a:p>
         </p:txBody>

</xml_diff>

<commit_message>
Slide 2: June blended table carried forward with July column from client funnel file
Co-Authored-By: Claude Fable 5 <noreply@anthropic.com>
</commit_message>
<xml_diff>
--- a/reports/forex/ggmi/2026-07/output/GGMI_LATAM_July_2026_Performance_Review.pptx
+++ b/reports/forex/ggmi/2026-07/output/GGMI_LATAM_July_2026_Performance_Review.pptx
@@ -9833,7 +9833,7 @@
                 </a:solidFill>
                 <a:latin typeface="Georgia"/>
               </a:rPr>
-              <a:t>The client funnel, June actual beside July.</a:t>
+              <a:t>Submitted applications held near June on a 24% larger media month.</a:t>
             </a:r>
           </a:p>
         </p:txBody>
@@ -9952,17 +9952,84 @@
           </a:p>
         </p:txBody>
       </p:sp>
+      <p:sp>
+        <p:nvSpPr>
+          <p:cNvPr id="10" name="TextBox 9"/>
+          <p:cNvSpPr txBox="1"/>
+          <p:nvPr/>
+        </p:nvSpPr>
+        <p:spPr>
+          <a:xfrm>
+            <a:off x="457200" y="1600200"/>
+            <a:ext cx="11247120" cy="1371600"/>
+          </a:xfrm>
+          <a:prstGeom prst="rect">
+            <a:avLst/>
+          </a:prstGeom>
+          <a:noFill/>
+        </p:spPr>
+        <p:txBody>
+          <a:bodyPr wrap="square" anchor="t" lIns="0" rIns="0" tIns="0" bIns="0">
+            <a:spAutoFit/>
+          </a:bodyPr>
+          <a:lstStyle/>
+          <a:p>
+            <a:pPr algn="l"/>
+            <a:r>
+              <a:rPr sz="1000" b="0">
+                <a:solidFill>
+                  <a:srgbClr val="2B3147"/>
+                </a:solidFill>
+                <a:latin typeface="Calibri"/>
+              </a:rPr>
+              <a:t>•  July submitted applications came in at 653, down 5% MoM; the submit rate on application starts rose to 27%, the highest since January.</a:t>
+            </a:r>
+          </a:p>
+          <a:p>
+            <a:pPr algn="l">
+              <a:spcBef>
+                <a:spcPts val="400"/>
+              </a:spcBef>
+            </a:pPr>
+            <a:r>
+              <a:rPr sz="1000" b="0">
+                <a:solidFill>
+                  <a:srgbClr val="2B3147"/>
+                </a:solidFill>
+                <a:latin typeface="Calibri"/>
+              </a:rPr>
+              <a:t>•  New approved came in at 180 with the approval rate at 28%. New funded came in at 21 and the fund rate at 12%; the application-to-funding step remains the funnel constraint. New traded closed at 19.</a:t>
+            </a:r>
+          </a:p>
+          <a:p>
+            <a:pPr algn="l">
+              <a:spcBef>
+                <a:spcPts val="400"/>
+              </a:spcBef>
+            </a:pPr>
+            <a:r>
+              <a:rPr sz="1000" b="0">
+                <a:solidFill>
+                  <a:srgbClr val="2B3147"/>
+                </a:solidFill>
+                <a:latin typeface="Calibri"/>
+              </a:rPr>
+              <a:t>•  Working media reached $149,896 in July, up 24% MoM and the biggest month of 2026. Measured paid submitted applications (Bing plus Azerion) came in at 61.</a:t>
+            </a:r>
+          </a:p>
+        </p:txBody>
+      </p:sp>
       <p:graphicFrame>
         <p:nvGraphicFramePr>
-          <p:cNvPr id="10" name="Table 9"/>
+          <p:cNvPr id="11" name="Table 10"/>
           <p:cNvGraphicFramePr>
             <a:graphicFrameLocks noGrp="1"/>
           </p:cNvGraphicFramePr>
           <p:nvPr/>
         </p:nvGraphicFramePr>
         <p:xfrm>
-          <a:off x="457200" y="1828800"/>
-          <a:ext cx="6766560" cy="2377440"/>
+          <a:off x="457200" y="3063240"/>
+          <a:ext cx="10360150" cy="3017520"/>
         </p:xfrm>
         <a:graphic>
           <a:graphicData uri="http://schemas.openxmlformats.org/drawingml/2006/table">
@@ -9971,11 +10038,17 @@
                 <a:tableStyleId>{5C22544A-7EE6-4342-B048-85BDC9FD1C3A}</a:tableStyleId>
               </a:tblPr>
               <a:tblGrid>
-                <a:gridCol w="3566160"/>
-                <a:gridCol w="1600200"/>
-                <a:gridCol w="1600200"/>
+                <a:gridCol w="2386584"/>
+                <a:gridCol w="987552"/>
+                <a:gridCol w="987552"/>
+                <a:gridCol w="987552"/>
+                <a:gridCol w="987552"/>
+                <a:gridCol w="987552"/>
+                <a:gridCol w="1042415"/>
+                <a:gridCol w="1042415"/>
+                <a:gridCol w="950976"/>
               </a:tblGrid>
-              <a:tr h="475488">
+              <a:tr h="274320">
                 <a:tc>
                   <a:txBody>
                     <a:bodyPr/>
@@ -9989,7 +10062,7 @@
                           </a:solidFill>
                           <a:latin typeface="Calibri"/>
                         </a:rPr>
-                        <a:t>Stage (organic + paid)</a:t>
+                        <a:t>GGMI — blended</a:t>
                       </a:r>
                     </a:p>
                   </a:txBody>
@@ -10012,7 +10085,7 @@
                           </a:solidFill>
                           <a:latin typeface="Calibri"/>
                         </a:rPr>
-                        <a:t>June</a:t>
+                        <a:t>Jan</a:t>
                       </a:r>
                     </a:p>
                   </a:txBody>
@@ -10035,7 +10108,145 @@
                           </a:solidFill>
                           <a:latin typeface="Calibri"/>
                         </a:rPr>
-                        <a:t>July</a:t>
+                        <a:t>Feb</a:t>
+                      </a:r>
+                    </a:p>
+                  </a:txBody>
+                  <a:tcPr marL="54864" marR="54864" marT="27432" marB="27432">
+                    <a:solidFill>
+                      <a:srgbClr val="1E2761"/>
+                    </a:solidFill>
+                  </a:tcPr>
+                </a:tc>
+                <a:tc>
+                  <a:txBody>
+                    <a:bodyPr/>
+                    <a:lstStyle/>
+                    <a:p>
+                      <a:pPr algn="r"/>
+                      <a:r>
+                        <a:rPr sz="850" b="1">
+                          <a:solidFill>
+                            <a:srgbClr val="FFFFFF"/>
+                          </a:solidFill>
+                          <a:latin typeface="Calibri"/>
+                        </a:rPr>
+                        <a:t>Mar</a:t>
+                      </a:r>
+                    </a:p>
+                  </a:txBody>
+                  <a:tcPr marL="54864" marR="54864" marT="27432" marB="27432">
+                    <a:solidFill>
+                      <a:srgbClr val="1E2761"/>
+                    </a:solidFill>
+                  </a:tcPr>
+                </a:tc>
+                <a:tc>
+                  <a:txBody>
+                    <a:bodyPr/>
+                    <a:lstStyle/>
+                    <a:p>
+                      <a:pPr algn="r"/>
+                      <a:r>
+                        <a:rPr sz="850" b="1">
+                          <a:solidFill>
+                            <a:srgbClr val="FFFFFF"/>
+                          </a:solidFill>
+                          <a:latin typeface="Calibri"/>
+                        </a:rPr>
+                        <a:t>Apr</a:t>
+                      </a:r>
+                    </a:p>
+                  </a:txBody>
+                  <a:tcPr marL="54864" marR="54864" marT="27432" marB="27432">
+                    <a:solidFill>
+                      <a:srgbClr val="1E2761"/>
+                    </a:solidFill>
+                  </a:tcPr>
+                </a:tc>
+                <a:tc>
+                  <a:txBody>
+                    <a:bodyPr/>
+                    <a:lstStyle/>
+                    <a:p>
+                      <a:pPr algn="r"/>
+                      <a:r>
+                        <a:rPr sz="850" b="1">
+                          <a:solidFill>
+                            <a:srgbClr val="FFFFFF"/>
+                          </a:solidFill>
+                          <a:latin typeface="Calibri"/>
+                        </a:rPr>
+                        <a:t>May</a:t>
+                      </a:r>
+                    </a:p>
+                  </a:txBody>
+                  <a:tcPr marL="54864" marR="54864" marT="27432" marB="27432">
+                    <a:solidFill>
+                      <a:srgbClr val="1E2761"/>
+                    </a:solidFill>
+                  </a:tcPr>
+                </a:tc>
+                <a:tc>
+                  <a:txBody>
+                    <a:bodyPr/>
+                    <a:lstStyle/>
+                    <a:p>
+                      <a:pPr algn="r"/>
+                      <a:r>
+                        <a:rPr sz="850" b="1">
+                          <a:solidFill>
+                            <a:srgbClr val="FFFFFF"/>
+                          </a:solidFill>
+                          <a:latin typeface="Calibri"/>
+                        </a:rPr>
+                        <a:t>Jun</a:t>
+                      </a:r>
+                    </a:p>
+                  </a:txBody>
+                  <a:tcPr marL="54864" marR="54864" marT="27432" marB="27432">
+                    <a:solidFill>
+                      <a:srgbClr val="1E2761"/>
+                    </a:solidFill>
+                  </a:tcPr>
+                </a:tc>
+                <a:tc>
+                  <a:txBody>
+                    <a:bodyPr/>
+                    <a:lstStyle/>
+                    <a:p>
+                      <a:pPr algn="r"/>
+                      <a:r>
+                        <a:rPr sz="850" b="1">
+                          <a:solidFill>
+                            <a:srgbClr val="FFFFFF"/>
+                          </a:solidFill>
+                          <a:latin typeface="Calibri"/>
+                        </a:rPr>
+                        <a:t>Jul</a:t>
+                      </a:r>
+                    </a:p>
+                  </a:txBody>
+                  <a:tcPr marL="54864" marR="54864" marT="27432" marB="27432">
+                    <a:solidFill>
+                      <a:srgbClr val="1E2761"/>
+                    </a:solidFill>
+                  </a:tcPr>
+                </a:tc>
+                <a:tc>
+                  <a:txBody>
+                    <a:bodyPr/>
+                    <a:lstStyle/>
+                    <a:p>
+                      <a:pPr algn="r"/>
+                      <a:r>
+                        <a:rPr sz="850" b="1">
+                          <a:solidFill>
+                            <a:srgbClr val="FFFFFF"/>
+                          </a:solidFill>
+                          <a:latin typeface="Calibri"/>
+                        </a:rPr>
+                        <a:t>MoM</a:t>
                       </a:r>
                     </a:p>
                   </a:txBody>
@@ -10046,7 +10257,7 @@
                   </a:tcPr>
                 </a:tc>
               </a:tr>
-              <a:tr h="475488">
+              <a:tr h="274320">
                 <a:tc>
                   <a:txBody>
                     <a:bodyPr/>
@@ -10060,7 +10271,7 @@
                           </a:solidFill>
                           <a:latin typeface="Calibri"/>
                         </a:rPr>
-                        <a:t>Submitted applications</a:t>
+                        <a:t>Working Media Spend</a:t>
                       </a:r>
                     </a:p>
                   </a:txBody>
@@ -10083,7 +10294,7 @@
                           </a:solidFill>
                           <a:latin typeface="Calibri"/>
                         </a:rPr>
-                        <a:t>684</a:t>
+                        <a:t>$1,717</a:t>
                       </a:r>
                     </a:p>
                   </a:txBody>
@@ -10106,7 +10317,145 @@
                           </a:solidFill>
                           <a:latin typeface="Calibri"/>
                         </a:rPr>
-                        <a:t>—</a:t>
+                        <a:t>$20,578</a:t>
+                      </a:r>
+                    </a:p>
+                  </a:txBody>
+                  <a:tcPr marL="54864" marR="54864" marT="27432" marB="27432">
+                    <a:solidFill>
+                      <a:srgbClr val="FFFFFF"/>
+                    </a:solidFill>
+                  </a:tcPr>
+                </a:tc>
+                <a:tc>
+                  <a:txBody>
+                    <a:bodyPr/>
+                    <a:lstStyle/>
+                    <a:p>
+                      <a:pPr algn="r"/>
+                      <a:r>
+                        <a:rPr sz="850" b="0">
+                          <a:solidFill>
+                            <a:srgbClr val="2B3147"/>
+                          </a:solidFill>
+                          <a:latin typeface="Calibri"/>
+                        </a:rPr>
+                        <a:t>$42,424</a:t>
+                      </a:r>
+                    </a:p>
+                  </a:txBody>
+                  <a:tcPr marL="54864" marR="54864" marT="27432" marB="27432">
+                    <a:solidFill>
+                      <a:srgbClr val="FFFFFF"/>
+                    </a:solidFill>
+                  </a:tcPr>
+                </a:tc>
+                <a:tc>
+                  <a:txBody>
+                    <a:bodyPr/>
+                    <a:lstStyle/>
+                    <a:p>
+                      <a:pPr algn="r"/>
+                      <a:r>
+                        <a:rPr sz="850" b="0">
+                          <a:solidFill>
+                            <a:srgbClr val="2B3147"/>
+                          </a:solidFill>
+                          <a:latin typeface="Calibri"/>
+                        </a:rPr>
+                        <a:t>$46,294</a:t>
+                      </a:r>
+                    </a:p>
+                  </a:txBody>
+                  <a:tcPr marL="54864" marR="54864" marT="27432" marB="27432">
+                    <a:solidFill>
+                      <a:srgbClr val="FFFFFF"/>
+                    </a:solidFill>
+                  </a:tcPr>
+                </a:tc>
+                <a:tc>
+                  <a:txBody>
+                    <a:bodyPr/>
+                    <a:lstStyle/>
+                    <a:p>
+                      <a:pPr algn="r"/>
+                      <a:r>
+                        <a:rPr sz="850" b="0">
+                          <a:solidFill>
+                            <a:srgbClr val="2B3147"/>
+                          </a:solidFill>
+                          <a:latin typeface="Calibri"/>
+                        </a:rPr>
+                        <a:t>$78,790</a:t>
+                      </a:r>
+                    </a:p>
+                  </a:txBody>
+                  <a:tcPr marL="54864" marR="54864" marT="27432" marB="27432">
+                    <a:solidFill>
+                      <a:srgbClr val="FFFFFF"/>
+                    </a:solidFill>
+                  </a:tcPr>
+                </a:tc>
+                <a:tc>
+                  <a:txBody>
+                    <a:bodyPr/>
+                    <a:lstStyle/>
+                    <a:p>
+                      <a:pPr algn="r"/>
+                      <a:r>
+                        <a:rPr sz="850" b="0">
+                          <a:solidFill>
+                            <a:srgbClr val="2B3147"/>
+                          </a:solidFill>
+                          <a:latin typeface="Calibri"/>
+                        </a:rPr>
+                        <a:t>$120,393</a:t>
+                      </a:r>
+                    </a:p>
+                  </a:txBody>
+                  <a:tcPr marL="54864" marR="54864" marT="27432" marB="27432">
+                    <a:solidFill>
+                      <a:srgbClr val="FFFFFF"/>
+                    </a:solidFill>
+                  </a:tcPr>
+                </a:tc>
+                <a:tc>
+                  <a:txBody>
+                    <a:bodyPr/>
+                    <a:lstStyle/>
+                    <a:p>
+                      <a:pPr algn="r"/>
+                      <a:r>
+                        <a:rPr sz="850" b="0">
+                          <a:solidFill>
+                            <a:srgbClr val="2B3147"/>
+                          </a:solidFill>
+                          <a:latin typeface="Calibri"/>
+                        </a:rPr>
+                        <a:t>$149,896</a:t>
+                      </a:r>
+                    </a:p>
+                  </a:txBody>
+                  <a:tcPr marL="54864" marR="54864" marT="27432" marB="27432">
+                    <a:solidFill>
+                      <a:srgbClr val="FFFFFF"/>
+                    </a:solidFill>
+                  </a:tcPr>
+                </a:tc>
+                <a:tc>
+                  <a:txBody>
+                    <a:bodyPr/>
+                    <a:lstStyle/>
+                    <a:p>
+                      <a:pPr algn="r"/>
+                      <a:r>
+                        <a:rPr sz="850" b="0">
+                          <a:solidFill>
+                            <a:srgbClr val="2B3147"/>
+                          </a:solidFill>
+                          <a:latin typeface="Calibri"/>
+                        </a:rPr>
+                        <a:t>+24%</a:t>
                       </a:r>
                     </a:p>
                   </a:txBody>
@@ -10117,7 +10466,7 @@
                   </a:tcPr>
                 </a:tc>
               </a:tr>
-              <a:tr h="475488">
+              <a:tr h="274320">
                 <a:tc>
                   <a:txBody>
                     <a:bodyPr/>
@@ -10131,7 +10480,7 @@
                           </a:solidFill>
                           <a:latin typeface="Calibri"/>
                         </a:rPr>
-                        <a:t>Approved</a:t>
+                        <a:t>Submitted Applications</a:t>
                       </a:r>
                     </a:p>
                   </a:txBody>
@@ -10154,7 +10503,7 @@
                           </a:solidFill>
                           <a:latin typeface="Calibri"/>
                         </a:rPr>
-                        <a:t>209</a:t>
+                        <a:t>1,029</a:t>
                       </a:r>
                     </a:p>
                   </a:txBody>
@@ -10177,7 +10526,145 @@
                           </a:solidFill>
                           <a:latin typeface="Calibri"/>
                         </a:rPr>
-                        <a:t>—</a:t>
+                        <a:t>1,036</a:t>
+                      </a:r>
+                    </a:p>
+                  </a:txBody>
+                  <a:tcPr marL="54864" marR="54864" marT="27432" marB="27432">
+                    <a:solidFill>
+                      <a:srgbClr val="F9FAFC"/>
+                    </a:solidFill>
+                  </a:tcPr>
+                </a:tc>
+                <a:tc>
+                  <a:txBody>
+                    <a:bodyPr/>
+                    <a:lstStyle/>
+                    <a:p>
+                      <a:pPr algn="r"/>
+                      <a:r>
+                        <a:rPr sz="850" b="0">
+                          <a:solidFill>
+                            <a:srgbClr val="2B3147"/>
+                          </a:solidFill>
+                          <a:latin typeface="Calibri"/>
+                        </a:rPr>
+                        <a:t>900</a:t>
+                      </a:r>
+                    </a:p>
+                  </a:txBody>
+                  <a:tcPr marL="54864" marR="54864" marT="27432" marB="27432">
+                    <a:solidFill>
+                      <a:srgbClr val="F9FAFC"/>
+                    </a:solidFill>
+                  </a:tcPr>
+                </a:tc>
+                <a:tc>
+                  <a:txBody>
+                    <a:bodyPr/>
+                    <a:lstStyle/>
+                    <a:p>
+                      <a:pPr algn="r"/>
+                      <a:r>
+                        <a:rPr sz="850" b="0">
+                          <a:solidFill>
+                            <a:srgbClr val="2B3147"/>
+                          </a:solidFill>
+                          <a:latin typeface="Calibri"/>
+                        </a:rPr>
+                        <a:t>751</a:t>
+                      </a:r>
+                    </a:p>
+                  </a:txBody>
+                  <a:tcPr marL="54864" marR="54864" marT="27432" marB="27432">
+                    <a:solidFill>
+                      <a:srgbClr val="F9FAFC"/>
+                    </a:solidFill>
+                  </a:tcPr>
+                </a:tc>
+                <a:tc>
+                  <a:txBody>
+                    <a:bodyPr/>
+                    <a:lstStyle/>
+                    <a:p>
+                      <a:pPr algn="r"/>
+                      <a:r>
+                        <a:rPr sz="850" b="0">
+                          <a:solidFill>
+                            <a:srgbClr val="2B3147"/>
+                          </a:solidFill>
+                          <a:latin typeface="Calibri"/>
+                        </a:rPr>
+                        <a:t>732</a:t>
+                      </a:r>
+                    </a:p>
+                  </a:txBody>
+                  <a:tcPr marL="54864" marR="54864" marT="27432" marB="27432">
+                    <a:solidFill>
+                      <a:srgbClr val="F9FAFC"/>
+                    </a:solidFill>
+                  </a:tcPr>
+                </a:tc>
+                <a:tc>
+                  <a:txBody>
+                    <a:bodyPr/>
+                    <a:lstStyle/>
+                    <a:p>
+                      <a:pPr algn="r"/>
+                      <a:r>
+                        <a:rPr sz="850" b="0">
+                          <a:solidFill>
+                            <a:srgbClr val="2B3147"/>
+                          </a:solidFill>
+                          <a:latin typeface="Calibri"/>
+                        </a:rPr>
+                        <a:t>684</a:t>
+                      </a:r>
+                    </a:p>
+                  </a:txBody>
+                  <a:tcPr marL="54864" marR="54864" marT="27432" marB="27432">
+                    <a:solidFill>
+                      <a:srgbClr val="F9FAFC"/>
+                    </a:solidFill>
+                  </a:tcPr>
+                </a:tc>
+                <a:tc>
+                  <a:txBody>
+                    <a:bodyPr/>
+                    <a:lstStyle/>
+                    <a:p>
+                      <a:pPr algn="r"/>
+                      <a:r>
+                        <a:rPr sz="850" b="0">
+                          <a:solidFill>
+                            <a:srgbClr val="2B3147"/>
+                          </a:solidFill>
+                          <a:latin typeface="Calibri"/>
+                        </a:rPr>
+                        <a:t>653</a:t>
+                      </a:r>
+                    </a:p>
+                  </a:txBody>
+                  <a:tcPr marL="54864" marR="54864" marT="27432" marB="27432">
+                    <a:solidFill>
+                      <a:srgbClr val="F9FAFC"/>
+                    </a:solidFill>
+                  </a:tcPr>
+                </a:tc>
+                <a:tc>
+                  <a:txBody>
+                    <a:bodyPr/>
+                    <a:lstStyle/>
+                    <a:p>
+                      <a:pPr algn="r"/>
+                      <a:r>
+                        <a:rPr sz="850" b="0">
+                          <a:solidFill>
+                            <a:srgbClr val="2B3147"/>
+                          </a:solidFill>
+                          <a:latin typeface="Calibri"/>
+                        </a:rPr>
+                        <a:t>-5%</a:t>
                       </a:r>
                     </a:p>
                   </a:txBody>
@@ -10188,7 +10675,7 @@
                   </a:tcPr>
                 </a:tc>
               </a:tr>
-              <a:tr h="475488">
+              <a:tr h="274320">
                 <a:tc>
                   <a:txBody>
                     <a:bodyPr/>
@@ -10202,7 +10689,540 @@
                           </a:solidFill>
                           <a:latin typeface="Calibri"/>
                         </a:rPr>
-                        <a:t>Funded</a:t>
+                        <a:t>Approved Clients</a:t>
+                      </a:r>
+                    </a:p>
+                  </a:txBody>
+                  <a:tcPr marL="54864" marR="54864" marT="27432" marB="27432">
+                    <a:solidFill>
+                      <a:srgbClr val="FFFFFF"/>
+                    </a:solidFill>
+                  </a:tcPr>
+                </a:tc>
+                <a:tc>
+                  <a:txBody>
+                    <a:bodyPr/>
+                    <a:lstStyle/>
+                    <a:p>
+                      <a:pPr algn="r"/>
+                      <a:r>
+                        <a:rPr sz="850" b="0">
+                          <a:solidFill>
+                            <a:srgbClr val="2B3147"/>
+                          </a:solidFill>
+                          <a:latin typeface="Calibri"/>
+                        </a:rPr>
+                        <a:t>288</a:t>
+                      </a:r>
+                    </a:p>
+                  </a:txBody>
+                  <a:tcPr marL="54864" marR="54864" marT="27432" marB="27432">
+                    <a:solidFill>
+                      <a:srgbClr val="FFFFFF"/>
+                    </a:solidFill>
+                  </a:tcPr>
+                </a:tc>
+                <a:tc>
+                  <a:txBody>
+                    <a:bodyPr/>
+                    <a:lstStyle/>
+                    <a:p>
+                      <a:pPr algn="r"/>
+                      <a:r>
+                        <a:rPr sz="850" b="0">
+                          <a:solidFill>
+                            <a:srgbClr val="2B3147"/>
+                          </a:solidFill>
+                          <a:latin typeface="Calibri"/>
+                        </a:rPr>
+                        <a:t>337</a:t>
+                      </a:r>
+                    </a:p>
+                  </a:txBody>
+                  <a:tcPr marL="54864" marR="54864" marT="27432" marB="27432">
+                    <a:solidFill>
+                      <a:srgbClr val="FFFFFF"/>
+                    </a:solidFill>
+                  </a:tcPr>
+                </a:tc>
+                <a:tc>
+                  <a:txBody>
+                    <a:bodyPr/>
+                    <a:lstStyle/>
+                    <a:p>
+                      <a:pPr algn="r"/>
+                      <a:r>
+                        <a:rPr sz="850" b="0">
+                          <a:solidFill>
+                            <a:srgbClr val="2B3147"/>
+                          </a:solidFill>
+                          <a:latin typeface="Calibri"/>
+                        </a:rPr>
+                        <a:t>261</a:t>
+                      </a:r>
+                    </a:p>
+                  </a:txBody>
+                  <a:tcPr marL="54864" marR="54864" marT="27432" marB="27432">
+                    <a:solidFill>
+                      <a:srgbClr val="FFFFFF"/>
+                    </a:solidFill>
+                  </a:tcPr>
+                </a:tc>
+                <a:tc>
+                  <a:txBody>
+                    <a:bodyPr/>
+                    <a:lstStyle/>
+                    <a:p>
+                      <a:pPr algn="r"/>
+                      <a:r>
+                        <a:rPr sz="850" b="0">
+                          <a:solidFill>
+                            <a:srgbClr val="2B3147"/>
+                          </a:solidFill>
+                          <a:latin typeface="Calibri"/>
+                        </a:rPr>
+                        <a:t>202</a:t>
+                      </a:r>
+                    </a:p>
+                  </a:txBody>
+                  <a:tcPr marL="54864" marR="54864" marT="27432" marB="27432">
+                    <a:solidFill>
+                      <a:srgbClr val="FFFFFF"/>
+                    </a:solidFill>
+                  </a:tcPr>
+                </a:tc>
+                <a:tc>
+                  <a:txBody>
+                    <a:bodyPr/>
+                    <a:lstStyle/>
+                    <a:p>
+                      <a:pPr algn="r"/>
+                      <a:r>
+                        <a:rPr sz="850" b="0">
+                          <a:solidFill>
+                            <a:srgbClr val="2B3147"/>
+                          </a:solidFill>
+                          <a:latin typeface="Calibri"/>
+                        </a:rPr>
+                        <a:t>195</a:t>
+                      </a:r>
+                    </a:p>
+                  </a:txBody>
+                  <a:tcPr marL="54864" marR="54864" marT="27432" marB="27432">
+                    <a:solidFill>
+                      <a:srgbClr val="FFFFFF"/>
+                    </a:solidFill>
+                  </a:tcPr>
+                </a:tc>
+                <a:tc>
+                  <a:txBody>
+                    <a:bodyPr/>
+                    <a:lstStyle/>
+                    <a:p>
+                      <a:pPr algn="r"/>
+                      <a:r>
+                        <a:rPr sz="850" b="0">
+                          <a:solidFill>
+                            <a:srgbClr val="2B3147"/>
+                          </a:solidFill>
+                          <a:latin typeface="Calibri"/>
+                        </a:rPr>
+                        <a:t>209</a:t>
+                      </a:r>
+                    </a:p>
+                  </a:txBody>
+                  <a:tcPr marL="54864" marR="54864" marT="27432" marB="27432">
+                    <a:solidFill>
+                      <a:srgbClr val="FFFFFF"/>
+                    </a:solidFill>
+                  </a:tcPr>
+                </a:tc>
+                <a:tc>
+                  <a:txBody>
+                    <a:bodyPr/>
+                    <a:lstStyle/>
+                    <a:p>
+                      <a:pPr algn="r"/>
+                      <a:r>
+                        <a:rPr sz="850" b="0">
+                          <a:solidFill>
+                            <a:srgbClr val="2B3147"/>
+                          </a:solidFill>
+                          <a:latin typeface="Calibri"/>
+                        </a:rPr>
+                        <a:t>180</a:t>
+                      </a:r>
+                    </a:p>
+                  </a:txBody>
+                  <a:tcPr marL="54864" marR="54864" marT="27432" marB="27432">
+                    <a:solidFill>
+                      <a:srgbClr val="FFFFFF"/>
+                    </a:solidFill>
+                  </a:tcPr>
+                </a:tc>
+                <a:tc>
+                  <a:txBody>
+                    <a:bodyPr/>
+                    <a:lstStyle/>
+                    <a:p>
+                      <a:pPr algn="r"/>
+                      <a:r>
+                        <a:rPr sz="850" b="0">
+                          <a:solidFill>
+                            <a:srgbClr val="2B3147"/>
+                          </a:solidFill>
+                          <a:latin typeface="Calibri"/>
+                        </a:rPr>
+                        <a:t>-14%</a:t>
+                      </a:r>
+                    </a:p>
+                  </a:txBody>
+                  <a:tcPr marL="54864" marR="54864" marT="27432" marB="27432">
+                    <a:solidFill>
+                      <a:srgbClr val="FFFFFF"/>
+                    </a:solidFill>
+                  </a:tcPr>
+                </a:tc>
+              </a:tr>
+              <a:tr h="274320">
+                <a:tc>
+                  <a:txBody>
+                    <a:bodyPr/>
+                    <a:lstStyle/>
+                    <a:p>
+                      <a:pPr algn="l"/>
+                      <a:r>
+                        <a:rPr sz="850" b="1">
+                          <a:solidFill>
+                            <a:srgbClr val="2B3147"/>
+                          </a:solidFill>
+                          <a:latin typeface="Calibri"/>
+                        </a:rPr>
+                        <a:t>Approval Rate</a:t>
+                      </a:r>
+                    </a:p>
+                  </a:txBody>
+                  <a:tcPr marL="54864" marR="54864" marT="27432" marB="27432">
+                    <a:solidFill>
+                      <a:srgbClr val="F9FAFC"/>
+                    </a:solidFill>
+                  </a:tcPr>
+                </a:tc>
+                <a:tc>
+                  <a:txBody>
+                    <a:bodyPr/>
+                    <a:lstStyle/>
+                    <a:p>
+                      <a:pPr algn="r"/>
+                      <a:r>
+                        <a:rPr sz="850" b="0">
+                          <a:solidFill>
+                            <a:srgbClr val="2B3147"/>
+                          </a:solidFill>
+                          <a:latin typeface="Calibri"/>
+                        </a:rPr>
+                        <a:t>28%</a:t>
+                      </a:r>
+                    </a:p>
+                  </a:txBody>
+                  <a:tcPr marL="54864" marR="54864" marT="27432" marB="27432">
+                    <a:solidFill>
+                      <a:srgbClr val="F9FAFC"/>
+                    </a:solidFill>
+                  </a:tcPr>
+                </a:tc>
+                <a:tc>
+                  <a:txBody>
+                    <a:bodyPr/>
+                    <a:lstStyle/>
+                    <a:p>
+                      <a:pPr algn="r"/>
+                      <a:r>
+                        <a:rPr sz="850" b="0">
+                          <a:solidFill>
+                            <a:srgbClr val="2B3147"/>
+                          </a:solidFill>
+                          <a:latin typeface="Calibri"/>
+                        </a:rPr>
+                        <a:t>33%</a:t>
+                      </a:r>
+                    </a:p>
+                  </a:txBody>
+                  <a:tcPr marL="54864" marR="54864" marT="27432" marB="27432">
+                    <a:solidFill>
+                      <a:srgbClr val="F9FAFC"/>
+                    </a:solidFill>
+                  </a:tcPr>
+                </a:tc>
+                <a:tc>
+                  <a:txBody>
+                    <a:bodyPr/>
+                    <a:lstStyle/>
+                    <a:p>
+                      <a:pPr algn="r"/>
+                      <a:r>
+                        <a:rPr sz="850" b="0">
+                          <a:solidFill>
+                            <a:srgbClr val="2B3147"/>
+                          </a:solidFill>
+                          <a:latin typeface="Calibri"/>
+                        </a:rPr>
+                        <a:t>29%</a:t>
+                      </a:r>
+                    </a:p>
+                  </a:txBody>
+                  <a:tcPr marL="54864" marR="54864" marT="27432" marB="27432">
+                    <a:solidFill>
+                      <a:srgbClr val="F9FAFC"/>
+                    </a:solidFill>
+                  </a:tcPr>
+                </a:tc>
+                <a:tc>
+                  <a:txBody>
+                    <a:bodyPr/>
+                    <a:lstStyle/>
+                    <a:p>
+                      <a:pPr algn="r"/>
+                      <a:r>
+                        <a:rPr sz="850" b="0">
+                          <a:solidFill>
+                            <a:srgbClr val="2B3147"/>
+                          </a:solidFill>
+                          <a:latin typeface="Calibri"/>
+                        </a:rPr>
+                        <a:t>27%</a:t>
+                      </a:r>
+                    </a:p>
+                  </a:txBody>
+                  <a:tcPr marL="54864" marR="54864" marT="27432" marB="27432">
+                    <a:solidFill>
+                      <a:srgbClr val="F9FAFC"/>
+                    </a:solidFill>
+                  </a:tcPr>
+                </a:tc>
+                <a:tc>
+                  <a:txBody>
+                    <a:bodyPr/>
+                    <a:lstStyle/>
+                    <a:p>
+                      <a:pPr algn="r"/>
+                      <a:r>
+                        <a:rPr sz="850" b="0">
+                          <a:solidFill>
+                            <a:srgbClr val="2B3147"/>
+                          </a:solidFill>
+                          <a:latin typeface="Calibri"/>
+                        </a:rPr>
+                        <a:t>27%</a:t>
+                      </a:r>
+                    </a:p>
+                  </a:txBody>
+                  <a:tcPr marL="54864" marR="54864" marT="27432" marB="27432">
+                    <a:solidFill>
+                      <a:srgbClr val="F9FAFC"/>
+                    </a:solidFill>
+                  </a:tcPr>
+                </a:tc>
+                <a:tc>
+                  <a:txBody>
+                    <a:bodyPr/>
+                    <a:lstStyle/>
+                    <a:p>
+                      <a:pPr algn="r"/>
+                      <a:r>
+                        <a:rPr sz="850" b="0">
+                          <a:solidFill>
+                            <a:srgbClr val="2B3147"/>
+                          </a:solidFill>
+                          <a:latin typeface="Calibri"/>
+                        </a:rPr>
+                        <a:t>31%</a:t>
+                      </a:r>
+                    </a:p>
+                  </a:txBody>
+                  <a:tcPr marL="54864" marR="54864" marT="27432" marB="27432">
+                    <a:solidFill>
+                      <a:srgbClr val="F9FAFC"/>
+                    </a:solidFill>
+                  </a:tcPr>
+                </a:tc>
+                <a:tc>
+                  <a:txBody>
+                    <a:bodyPr/>
+                    <a:lstStyle/>
+                    <a:p>
+                      <a:pPr algn="r"/>
+                      <a:r>
+                        <a:rPr sz="850" b="0">
+                          <a:solidFill>
+                            <a:srgbClr val="2B3147"/>
+                          </a:solidFill>
+                          <a:latin typeface="Calibri"/>
+                        </a:rPr>
+                        <a:t>28%</a:t>
+                      </a:r>
+                    </a:p>
+                  </a:txBody>
+                  <a:tcPr marL="54864" marR="54864" marT="27432" marB="27432">
+                    <a:solidFill>
+                      <a:srgbClr val="F9FAFC"/>
+                    </a:solidFill>
+                  </a:tcPr>
+                </a:tc>
+                <a:tc>
+                  <a:txBody>
+                    <a:bodyPr/>
+                    <a:lstStyle/>
+                    <a:p>
+                      <a:pPr algn="r"/>
+                      <a:r>
+                        <a:rPr sz="850" b="0">
+                          <a:solidFill>
+                            <a:srgbClr val="2B3147"/>
+                          </a:solidFill>
+                          <a:latin typeface="Calibri"/>
+                        </a:rPr>
+                        <a:t>-3pp</a:t>
+                      </a:r>
+                    </a:p>
+                  </a:txBody>
+                  <a:tcPr marL="54864" marR="54864" marT="27432" marB="27432">
+                    <a:solidFill>
+                      <a:srgbClr val="F9FAFC"/>
+                    </a:solidFill>
+                  </a:tcPr>
+                </a:tc>
+              </a:tr>
+              <a:tr h="274320">
+                <a:tc>
+                  <a:txBody>
+                    <a:bodyPr/>
+                    <a:lstStyle/>
+                    <a:p>
+                      <a:pPr algn="l"/>
+                      <a:r>
+                        <a:rPr sz="850" b="1">
+                          <a:solidFill>
+                            <a:srgbClr val="2B3147"/>
+                          </a:solidFill>
+                          <a:latin typeface="Calibri"/>
+                        </a:rPr>
+                        <a:t>New Funded Clients</a:t>
+                      </a:r>
+                    </a:p>
+                  </a:txBody>
+                  <a:tcPr marL="54864" marR="54864" marT="27432" marB="27432">
+                    <a:solidFill>
+                      <a:srgbClr val="FFFFFF"/>
+                    </a:solidFill>
+                  </a:tcPr>
+                </a:tc>
+                <a:tc>
+                  <a:txBody>
+                    <a:bodyPr/>
+                    <a:lstStyle/>
+                    <a:p>
+                      <a:pPr algn="r"/>
+                      <a:r>
+                        <a:rPr sz="850" b="0">
+                          <a:solidFill>
+                            <a:srgbClr val="2B3147"/>
+                          </a:solidFill>
+                          <a:latin typeface="Calibri"/>
+                        </a:rPr>
+                        <a:t>66</a:t>
+                      </a:r>
+                    </a:p>
+                  </a:txBody>
+                  <a:tcPr marL="54864" marR="54864" marT="27432" marB="27432">
+                    <a:solidFill>
+                      <a:srgbClr val="FFFFFF"/>
+                    </a:solidFill>
+                  </a:tcPr>
+                </a:tc>
+                <a:tc>
+                  <a:txBody>
+                    <a:bodyPr/>
+                    <a:lstStyle/>
+                    <a:p>
+                      <a:pPr algn="r"/>
+                      <a:r>
+                        <a:rPr sz="850" b="0">
+                          <a:solidFill>
+                            <a:srgbClr val="2B3147"/>
+                          </a:solidFill>
+                          <a:latin typeface="Calibri"/>
+                        </a:rPr>
+                        <a:t>59</a:t>
+                      </a:r>
+                    </a:p>
+                  </a:txBody>
+                  <a:tcPr marL="54864" marR="54864" marT="27432" marB="27432">
+                    <a:solidFill>
+                      <a:srgbClr val="FFFFFF"/>
+                    </a:solidFill>
+                  </a:tcPr>
+                </a:tc>
+                <a:tc>
+                  <a:txBody>
+                    <a:bodyPr/>
+                    <a:lstStyle/>
+                    <a:p>
+                      <a:pPr algn="r"/>
+                      <a:r>
+                        <a:rPr sz="850" b="0">
+                          <a:solidFill>
+                            <a:srgbClr val="2B3147"/>
+                          </a:solidFill>
+                          <a:latin typeface="Calibri"/>
+                        </a:rPr>
+                        <a:t>63</a:t>
+                      </a:r>
+                    </a:p>
+                  </a:txBody>
+                  <a:tcPr marL="54864" marR="54864" marT="27432" marB="27432">
+                    <a:solidFill>
+                      <a:srgbClr val="FFFFFF"/>
+                    </a:solidFill>
+                  </a:tcPr>
+                </a:tc>
+                <a:tc>
+                  <a:txBody>
+                    <a:bodyPr/>
+                    <a:lstStyle/>
+                    <a:p>
+                      <a:pPr algn="r"/>
+                      <a:r>
+                        <a:rPr sz="850" b="0">
+                          <a:solidFill>
+                            <a:srgbClr val="2B3147"/>
+                          </a:solidFill>
+                          <a:latin typeface="Calibri"/>
+                        </a:rPr>
+                        <a:t>38</a:t>
+                      </a:r>
+                    </a:p>
+                  </a:txBody>
+                  <a:tcPr marL="54864" marR="54864" marT="27432" marB="27432">
+                    <a:solidFill>
+                      <a:srgbClr val="FFFFFF"/>
+                    </a:solidFill>
+                  </a:tcPr>
+                </a:tc>
+                <a:tc>
+                  <a:txBody>
+                    <a:bodyPr/>
+                    <a:lstStyle/>
+                    <a:p>
+                      <a:pPr algn="r"/>
+                      <a:r>
+                        <a:rPr sz="850" b="0">
+                          <a:solidFill>
+                            <a:srgbClr val="2B3147"/>
+                          </a:solidFill>
+                          <a:latin typeface="Calibri"/>
+                        </a:rPr>
+                        <a:t>36</a:t>
                       </a:r>
                     </a:p>
                   </a:txBody>
@@ -10248,7 +11268,30 @@
                           </a:solidFill>
                           <a:latin typeface="Calibri"/>
                         </a:rPr>
-                        <a:t>—</a:t>
+                        <a:t>21</a:t>
+                      </a:r>
+                    </a:p>
+                  </a:txBody>
+                  <a:tcPr marL="54864" marR="54864" marT="27432" marB="27432">
+                    <a:solidFill>
+                      <a:srgbClr val="FFFFFF"/>
+                    </a:solidFill>
+                  </a:tcPr>
+                </a:tc>
+                <a:tc>
+                  <a:txBody>
+                    <a:bodyPr/>
+                    <a:lstStyle/>
+                    <a:p>
+                      <a:pPr algn="r"/>
+                      <a:r>
+                        <a:rPr sz="850" b="0">
+                          <a:solidFill>
+                            <a:srgbClr val="2B3147"/>
+                          </a:solidFill>
+                          <a:latin typeface="Calibri"/>
+                        </a:rPr>
+                        <a:t>-34%</a:t>
                       </a:r>
                     </a:p>
                   </a:txBody>
@@ -10259,7 +11302,7 @@
                   </a:tcPr>
                 </a:tc>
               </a:tr>
-              <a:tr h="475488">
+              <a:tr h="274320">
                 <a:tc>
                   <a:txBody>
                     <a:bodyPr/>
@@ -10273,7 +11316,540 @@
                           </a:solidFill>
                           <a:latin typeface="Calibri"/>
                         </a:rPr>
-                        <a:t>Traded</a:t>
+                        <a:t>Fund Rate</a:t>
+                      </a:r>
+                    </a:p>
+                  </a:txBody>
+                  <a:tcPr marL="54864" marR="54864" marT="27432" marB="27432">
+                    <a:solidFill>
+                      <a:srgbClr val="F9FAFC"/>
+                    </a:solidFill>
+                  </a:tcPr>
+                </a:tc>
+                <a:tc>
+                  <a:txBody>
+                    <a:bodyPr/>
+                    <a:lstStyle/>
+                    <a:p>
+                      <a:pPr algn="r"/>
+                      <a:r>
+                        <a:rPr sz="850" b="0">
+                          <a:solidFill>
+                            <a:srgbClr val="2B3147"/>
+                          </a:solidFill>
+                          <a:latin typeface="Calibri"/>
+                        </a:rPr>
+                        <a:t>23%</a:t>
+                      </a:r>
+                    </a:p>
+                  </a:txBody>
+                  <a:tcPr marL="54864" marR="54864" marT="27432" marB="27432">
+                    <a:solidFill>
+                      <a:srgbClr val="F9FAFC"/>
+                    </a:solidFill>
+                  </a:tcPr>
+                </a:tc>
+                <a:tc>
+                  <a:txBody>
+                    <a:bodyPr/>
+                    <a:lstStyle/>
+                    <a:p>
+                      <a:pPr algn="r"/>
+                      <a:r>
+                        <a:rPr sz="850" b="0">
+                          <a:solidFill>
+                            <a:srgbClr val="2B3147"/>
+                          </a:solidFill>
+                          <a:latin typeface="Calibri"/>
+                        </a:rPr>
+                        <a:t>18%</a:t>
+                      </a:r>
+                    </a:p>
+                  </a:txBody>
+                  <a:tcPr marL="54864" marR="54864" marT="27432" marB="27432">
+                    <a:solidFill>
+                      <a:srgbClr val="F9FAFC"/>
+                    </a:solidFill>
+                  </a:tcPr>
+                </a:tc>
+                <a:tc>
+                  <a:txBody>
+                    <a:bodyPr/>
+                    <a:lstStyle/>
+                    <a:p>
+                      <a:pPr algn="r"/>
+                      <a:r>
+                        <a:rPr sz="850" b="0">
+                          <a:solidFill>
+                            <a:srgbClr val="2B3147"/>
+                          </a:solidFill>
+                          <a:latin typeface="Calibri"/>
+                        </a:rPr>
+                        <a:t>24%</a:t>
+                      </a:r>
+                    </a:p>
+                  </a:txBody>
+                  <a:tcPr marL="54864" marR="54864" marT="27432" marB="27432">
+                    <a:solidFill>
+                      <a:srgbClr val="F9FAFC"/>
+                    </a:solidFill>
+                  </a:tcPr>
+                </a:tc>
+                <a:tc>
+                  <a:txBody>
+                    <a:bodyPr/>
+                    <a:lstStyle/>
+                    <a:p>
+                      <a:pPr algn="r"/>
+                      <a:r>
+                        <a:rPr sz="850" b="0">
+                          <a:solidFill>
+                            <a:srgbClr val="2B3147"/>
+                          </a:solidFill>
+                          <a:latin typeface="Calibri"/>
+                        </a:rPr>
+                        <a:t>19%</a:t>
+                      </a:r>
+                    </a:p>
+                  </a:txBody>
+                  <a:tcPr marL="54864" marR="54864" marT="27432" marB="27432">
+                    <a:solidFill>
+                      <a:srgbClr val="F9FAFC"/>
+                    </a:solidFill>
+                  </a:tcPr>
+                </a:tc>
+                <a:tc>
+                  <a:txBody>
+                    <a:bodyPr/>
+                    <a:lstStyle/>
+                    <a:p>
+                      <a:pPr algn="r"/>
+                      <a:r>
+                        <a:rPr sz="850" b="0">
+                          <a:solidFill>
+                            <a:srgbClr val="2B3147"/>
+                          </a:solidFill>
+                          <a:latin typeface="Calibri"/>
+                        </a:rPr>
+                        <a:t>18%</a:t>
+                      </a:r>
+                    </a:p>
+                  </a:txBody>
+                  <a:tcPr marL="54864" marR="54864" marT="27432" marB="27432">
+                    <a:solidFill>
+                      <a:srgbClr val="F9FAFC"/>
+                    </a:solidFill>
+                  </a:tcPr>
+                </a:tc>
+                <a:tc>
+                  <a:txBody>
+                    <a:bodyPr/>
+                    <a:lstStyle/>
+                    <a:p>
+                      <a:pPr algn="r"/>
+                      <a:r>
+                        <a:rPr sz="850" b="0">
+                          <a:solidFill>
+                            <a:srgbClr val="2B3147"/>
+                          </a:solidFill>
+                          <a:latin typeface="Calibri"/>
+                        </a:rPr>
+                        <a:t>15%</a:t>
+                      </a:r>
+                    </a:p>
+                  </a:txBody>
+                  <a:tcPr marL="54864" marR="54864" marT="27432" marB="27432">
+                    <a:solidFill>
+                      <a:srgbClr val="F9FAFC"/>
+                    </a:solidFill>
+                  </a:tcPr>
+                </a:tc>
+                <a:tc>
+                  <a:txBody>
+                    <a:bodyPr/>
+                    <a:lstStyle/>
+                    <a:p>
+                      <a:pPr algn="r"/>
+                      <a:r>
+                        <a:rPr sz="850" b="0">
+                          <a:solidFill>
+                            <a:srgbClr val="2B3147"/>
+                          </a:solidFill>
+                          <a:latin typeface="Calibri"/>
+                        </a:rPr>
+                        <a:t>12%</a:t>
+                      </a:r>
+                    </a:p>
+                  </a:txBody>
+                  <a:tcPr marL="54864" marR="54864" marT="27432" marB="27432">
+                    <a:solidFill>
+                      <a:srgbClr val="F9FAFC"/>
+                    </a:solidFill>
+                  </a:tcPr>
+                </a:tc>
+                <a:tc>
+                  <a:txBody>
+                    <a:bodyPr/>
+                    <a:lstStyle/>
+                    <a:p>
+                      <a:pPr algn="r"/>
+                      <a:r>
+                        <a:rPr sz="850" b="0">
+                          <a:solidFill>
+                            <a:srgbClr val="2B3147"/>
+                          </a:solidFill>
+                          <a:latin typeface="Calibri"/>
+                        </a:rPr>
+                        <a:t>-3pp</a:t>
+                      </a:r>
+                    </a:p>
+                  </a:txBody>
+                  <a:tcPr marL="54864" marR="54864" marT="27432" marB="27432">
+                    <a:solidFill>
+                      <a:srgbClr val="F9FAFC"/>
+                    </a:solidFill>
+                  </a:tcPr>
+                </a:tc>
+              </a:tr>
+              <a:tr h="274320">
+                <a:tc>
+                  <a:txBody>
+                    <a:bodyPr/>
+                    <a:lstStyle/>
+                    <a:p>
+                      <a:pPr algn="l"/>
+                      <a:r>
+                        <a:rPr sz="850" b="1">
+                          <a:solidFill>
+                            <a:srgbClr val="2B3147"/>
+                          </a:solidFill>
+                          <a:latin typeface="Calibri"/>
+                        </a:rPr>
+                        <a:t>Cost per Funded Client</a:t>
+                      </a:r>
+                    </a:p>
+                  </a:txBody>
+                  <a:tcPr marL="54864" marR="54864" marT="27432" marB="27432">
+                    <a:solidFill>
+                      <a:srgbClr val="FFFFFF"/>
+                    </a:solidFill>
+                  </a:tcPr>
+                </a:tc>
+                <a:tc>
+                  <a:txBody>
+                    <a:bodyPr/>
+                    <a:lstStyle/>
+                    <a:p>
+                      <a:pPr algn="r"/>
+                      <a:r>
+                        <a:rPr sz="850" b="0">
+                          <a:solidFill>
+                            <a:srgbClr val="2B3147"/>
+                          </a:solidFill>
+                          <a:latin typeface="Calibri"/>
+                        </a:rPr>
+                        <a:t>$26</a:t>
+                      </a:r>
+                    </a:p>
+                  </a:txBody>
+                  <a:tcPr marL="54864" marR="54864" marT="27432" marB="27432">
+                    <a:solidFill>
+                      <a:srgbClr val="FFFFFF"/>
+                    </a:solidFill>
+                  </a:tcPr>
+                </a:tc>
+                <a:tc>
+                  <a:txBody>
+                    <a:bodyPr/>
+                    <a:lstStyle/>
+                    <a:p>
+                      <a:pPr algn="r"/>
+                      <a:r>
+                        <a:rPr sz="850" b="0">
+                          <a:solidFill>
+                            <a:srgbClr val="2B3147"/>
+                          </a:solidFill>
+                          <a:latin typeface="Calibri"/>
+                        </a:rPr>
+                        <a:t>$349</a:t>
+                      </a:r>
+                    </a:p>
+                  </a:txBody>
+                  <a:tcPr marL="54864" marR="54864" marT="27432" marB="27432">
+                    <a:solidFill>
+                      <a:srgbClr val="FFFFFF"/>
+                    </a:solidFill>
+                  </a:tcPr>
+                </a:tc>
+                <a:tc>
+                  <a:txBody>
+                    <a:bodyPr/>
+                    <a:lstStyle/>
+                    <a:p>
+                      <a:pPr algn="r"/>
+                      <a:r>
+                        <a:rPr sz="850" b="0">
+                          <a:solidFill>
+                            <a:srgbClr val="2B3147"/>
+                          </a:solidFill>
+                          <a:latin typeface="Calibri"/>
+                        </a:rPr>
+                        <a:t>$673</a:t>
+                      </a:r>
+                    </a:p>
+                  </a:txBody>
+                  <a:tcPr marL="54864" marR="54864" marT="27432" marB="27432">
+                    <a:solidFill>
+                      <a:srgbClr val="FFFFFF"/>
+                    </a:solidFill>
+                  </a:tcPr>
+                </a:tc>
+                <a:tc>
+                  <a:txBody>
+                    <a:bodyPr/>
+                    <a:lstStyle/>
+                    <a:p>
+                      <a:pPr algn="r"/>
+                      <a:r>
+                        <a:rPr sz="850" b="0">
+                          <a:solidFill>
+                            <a:srgbClr val="2B3147"/>
+                          </a:solidFill>
+                          <a:latin typeface="Calibri"/>
+                        </a:rPr>
+                        <a:t>$1,218</a:t>
+                      </a:r>
+                    </a:p>
+                  </a:txBody>
+                  <a:tcPr marL="54864" marR="54864" marT="27432" marB="27432">
+                    <a:solidFill>
+                      <a:srgbClr val="FFFFFF"/>
+                    </a:solidFill>
+                  </a:tcPr>
+                </a:tc>
+                <a:tc>
+                  <a:txBody>
+                    <a:bodyPr/>
+                    <a:lstStyle/>
+                    <a:p>
+                      <a:pPr algn="r"/>
+                      <a:r>
+                        <a:rPr sz="850" b="0">
+                          <a:solidFill>
+                            <a:srgbClr val="2B3147"/>
+                          </a:solidFill>
+                          <a:latin typeface="Calibri"/>
+                        </a:rPr>
+                        <a:t>$2,189</a:t>
+                      </a:r>
+                    </a:p>
+                  </a:txBody>
+                  <a:tcPr marL="54864" marR="54864" marT="27432" marB="27432">
+                    <a:solidFill>
+                      <a:srgbClr val="FFFFFF"/>
+                    </a:solidFill>
+                  </a:tcPr>
+                </a:tc>
+                <a:tc>
+                  <a:txBody>
+                    <a:bodyPr/>
+                    <a:lstStyle/>
+                    <a:p>
+                      <a:pPr algn="r"/>
+                      <a:r>
+                        <a:rPr sz="850" b="0">
+                          <a:solidFill>
+                            <a:srgbClr val="2B3147"/>
+                          </a:solidFill>
+                          <a:latin typeface="Calibri"/>
+                        </a:rPr>
+                        <a:t>$3,762</a:t>
+                      </a:r>
+                    </a:p>
+                  </a:txBody>
+                  <a:tcPr marL="54864" marR="54864" marT="27432" marB="27432">
+                    <a:solidFill>
+                      <a:srgbClr val="FFFFFF"/>
+                    </a:solidFill>
+                  </a:tcPr>
+                </a:tc>
+                <a:tc>
+                  <a:txBody>
+                    <a:bodyPr/>
+                    <a:lstStyle/>
+                    <a:p>
+                      <a:pPr algn="r"/>
+                      <a:r>
+                        <a:rPr sz="850" b="0">
+                          <a:solidFill>
+                            <a:srgbClr val="2B3147"/>
+                          </a:solidFill>
+                          <a:latin typeface="Calibri"/>
+                        </a:rPr>
+                        <a:t>$7,138</a:t>
+                      </a:r>
+                    </a:p>
+                  </a:txBody>
+                  <a:tcPr marL="54864" marR="54864" marT="27432" marB="27432">
+                    <a:solidFill>
+                      <a:srgbClr val="FFFFFF"/>
+                    </a:solidFill>
+                  </a:tcPr>
+                </a:tc>
+                <a:tc>
+                  <a:txBody>
+                    <a:bodyPr/>
+                    <a:lstStyle/>
+                    <a:p>
+                      <a:pPr algn="r"/>
+                      <a:r>
+                        <a:rPr sz="850" b="0">
+                          <a:solidFill>
+                            <a:srgbClr val="2B3147"/>
+                          </a:solidFill>
+                          <a:latin typeface="Calibri"/>
+                        </a:rPr>
+                        <a:t>+90%</a:t>
+                      </a:r>
+                    </a:p>
+                  </a:txBody>
+                  <a:tcPr marL="54864" marR="54864" marT="27432" marB="27432">
+                    <a:solidFill>
+                      <a:srgbClr val="FFFFFF"/>
+                    </a:solidFill>
+                  </a:tcPr>
+                </a:tc>
+              </a:tr>
+              <a:tr h="274320">
+                <a:tc>
+                  <a:txBody>
+                    <a:bodyPr/>
+                    <a:lstStyle/>
+                    <a:p>
+                      <a:pPr algn="l"/>
+                      <a:r>
+                        <a:rPr sz="850" b="1">
+                          <a:solidFill>
+                            <a:srgbClr val="2B3147"/>
+                          </a:solidFill>
+                          <a:latin typeface="Calibri"/>
+                        </a:rPr>
+                        <a:t>New Traded Clients</a:t>
+                      </a:r>
+                    </a:p>
+                  </a:txBody>
+                  <a:tcPr marL="54864" marR="54864" marT="27432" marB="27432">
+                    <a:solidFill>
+                      <a:srgbClr val="F9FAFC"/>
+                    </a:solidFill>
+                  </a:tcPr>
+                </a:tc>
+                <a:tc>
+                  <a:txBody>
+                    <a:bodyPr/>
+                    <a:lstStyle/>
+                    <a:p>
+                      <a:pPr algn="r"/>
+                      <a:r>
+                        <a:rPr sz="850" b="0">
+                          <a:solidFill>
+                            <a:srgbClr val="2B3147"/>
+                          </a:solidFill>
+                          <a:latin typeface="Calibri"/>
+                        </a:rPr>
+                        <a:t>56</a:t>
+                      </a:r>
+                    </a:p>
+                  </a:txBody>
+                  <a:tcPr marL="54864" marR="54864" marT="27432" marB="27432">
+                    <a:solidFill>
+                      <a:srgbClr val="F9FAFC"/>
+                    </a:solidFill>
+                  </a:tcPr>
+                </a:tc>
+                <a:tc>
+                  <a:txBody>
+                    <a:bodyPr/>
+                    <a:lstStyle/>
+                    <a:p>
+                      <a:pPr algn="r"/>
+                      <a:r>
+                        <a:rPr sz="850" b="0">
+                          <a:solidFill>
+                            <a:srgbClr val="2B3147"/>
+                          </a:solidFill>
+                          <a:latin typeface="Calibri"/>
+                        </a:rPr>
+                        <a:t>52</a:t>
+                      </a:r>
+                    </a:p>
+                  </a:txBody>
+                  <a:tcPr marL="54864" marR="54864" marT="27432" marB="27432">
+                    <a:solidFill>
+                      <a:srgbClr val="F9FAFC"/>
+                    </a:solidFill>
+                  </a:tcPr>
+                </a:tc>
+                <a:tc>
+                  <a:txBody>
+                    <a:bodyPr/>
+                    <a:lstStyle/>
+                    <a:p>
+                      <a:pPr algn="r"/>
+                      <a:r>
+                        <a:rPr sz="850" b="0">
+                          <a:solidFill>
+                            <a:srgbClr val="2B3147"/>
+                          </a:solidFill>
+                          <a:latin typeface="Calibri"/>
+                        </a:rPr>
+                        <a:t>57</a:t>
+                      </a:r>
+                    </a:p>
+                  </a:txBody>
+                  <a:tcPr marL="54864" marR="54864" marT="27432" marB="27432">
+                    <a:solidFill>
+                      <a:srgbClr val="F9FAFC"/>
+                    </a:solidFill>
+                  </a:tcPr>
+                </a:tc>
+                <a:tc>
+                  <a:txBody>
+                    <a:bodyPr/>
+                    <a:lstStyle/>
+                    <a:p>
+                      <a:pPr algn="r"/>
+                      <a:r>
+                        <a:rPr sz="850" b="0">
+                          <a:solidFill>
+                            <a:srgbClr val="2B3147"/>
+                          </a:solidFill>
+                          <a:latin typeface="Calibri"/>
+                        </a:rPr>
+                        <a:t>35</a:t>
+                      </a:r>
+                    </a:p>
+                  </a:txBody>
+                  <a:tcPr marL="54864" marR="54864" marT="27432" marB="27432">
+                    <a:solidFill>
+                      <a:srgbClr val="F9FAFC"/>
+                    </a:solidFill>
+                  </a:tcPr>
+                </a:tc>
+                <a:tc>
+                  <a:txBody>
+                    <a:bodyPr/>
+                    <a:lstStyle/>
+                    <a:p>
+                      <a:pPr algn="r"/>
+                      <a:r>
+                        <a:rPr sz="850" b="0">
+                          <a:solidFill>
+                            <a:srgbClr val="2B3147"/>
+                          </a:solidFill>
+                          <a:latin typeface="Calibri"/>
+                        </a:rPr>
+                        <a:t>36</a:t>
                       </a:r>
                     </a:p>
                   </a:txBody>
@@ -10319,6 +11895,447 @@
                           </a:solidFill>
                           <a:latin typeface="Calibri"/>
                         </a:rPr>
+                        <a:t>19</a:t>
+                      </a:r>
+                    </a:p>
+                  </a:txBody>
+                  <a:tcPr marL="54864" marR="54864" marT="27432" marB="27432">
+                    <a:solidFill>
+                      <a:srgbClr val="F9FAFC"/>
+                    </a:solidFill>
+                  </a:tcPr>
+                </a:tc>
+                <a:tc>
+                  <a:txBody>
+                    <a:bodyPr/>
+                    <a:lstStyle/>
+                    <a:p>
+                      <a:pPr algn="r"/>
+                      <a:r>
+                        <a:rPr sz="850" b="0">
+                          <a:solidFill>
+                            <a:srgbClr val="2B3147"/>
+                          </a:solidFill>
+                          <a:latin typeface="Calibri"/>
+                        </a:rPr>
+                        <a:t>-34%</a:t>
+                      </a:r>
+                    </a:p>
+                  </a:txBody>
+                  <a:tcPr marL="54864" marR="54864" marT="27432" marB="27432">
+                    <a:solidFill>
+                      <a:srgbClr val="F9FAFC"/>
+                    </a:solidFill>
+                  </a:tcPr>
+                </a:tc>
+              </a:tr>
+              <a:tr h="274320">
+                <a:tc>
+                  <a:txBody>
+                    <a:bodyPr/>
+                    <a:lstStyle/>
+                    <a:p>
+                      <a:pPr algn="l"/>
+                      <a:r>
+                        <a:rPr sz="850" b="1">
+                          <a:solidFill>
+                            <a:srgbClr val="2B3147"/>
+                          </a:solidFill>
+                          <a:latin typeface="Calibri"/>
+                        </a:rPr>
+                        <a:t>Cost per Traded Client</a:t>
+                      </a:r>
+                    </a:p>
+                  </a:txBody>
+                  <a:tcPr marL="54864" marR="54864" marT="27432" marB="27432">
+                    <a:solidFill>
+                      <a:srgbClr val="FFFFFF"/>
+                    </a:solidFill>
+                  </a:tcPr>
+                </a:tc>
+                <a:tc>
+                  <a:txBody>
+                    <a:bodyPr/>
+                    <a:lstStyle/>
+                    <a:p>
+                      <a:pPr algn="r"/>
+                      <a:r>
+                        <a:rPr sz="850" b="0">
+                          <a:solidFill>
+                            <a:srgbClr val="2B3147"/>
+                          </a:solidFill>
+                          <a:latin typeface="Calibri"/>
+                        </a:rPr>
+                        <a:t>$31</a:t>
+                      </a:r>
+                    </a:p>
+                  </a:txBody>
+                  <a:tcPr marL="54864" marR="54864" marT="27432" marB="27432">
+                    <a:solidFill>
+                      <a:srgbClr val="FFFFFF"/>
+                    </a:solidFill>
+                  </a:tcPr>
+                </a:tc>
+                <a:tc>
+                  <a:txBody>
+                    <a:bodyPr/>
+                    <a:lstStyle/>
+                    <a:p>
+                      <a:pPr algn="r"/>
+                      <a:r>
+                        <a:rPr sz="850" b="0">
+                          <a:solidFill>
+                            <a:srgbClr val="2B3147"/>
+                          </a:solidFill>
+                          <a:latin typeface="Calibri"/>
+                        </a:rPr>
+                        <a:t>$396</a:t>
+                      </a:r>
+                    </a:p>
+                  </a:txBody>
+                  <a:tcPr marL="54864" marR="54864" marT="27432" marB="27432">
+                    <a:solidFill>
+                      <a:srgbClr val="FFFFFF"/>
+                    </a:solidFill>
+                  </a:tcPr>
+                </a:tc>
+                <a:tc>
+                  <a:txBody>
+                    <a:bodyPr/>
+                    <a:lstStyle/>
+                    <a:p>
+                      <a:pPr algn="r"/>
+                      <a:r>
+                        <a:rPr sz="850" b="0">
+                          <a:solidFill>
+                            <a:srgbClr val="2B3147"/>
+                          </a:solidFill>
+                          <a:latin typeface="Calibri"/>
+                        </a:rPr>
+                        <a:t>$744</a:t>
+                      </a:r>
+                    </a:p>
+                  </a:txBody>
+                  <a:tcPr marL="54864" marR="54864" marT="27432" marB="27432">
+                    <a:solidFill>
+                      <a:srgbClr val="FFFFFF"/>
+                    </a:solidFill>
+                  </a:tcPr>
+                </a:tc>
+                <a:tc>
+                  <a:txBody>
+                    <a:bodyPr/>
+                    <a:lstStyle/>
+                    <a:p>
+                      <a:pPr algn="r"/>
+                      <a:r>
+                        <a:rPr sz="850" b="0">
+                          <a:solidFill>
+                            <a:srgbClr val="2B3147"/>
+                          </a:solidFill>
+                          <a:latin typeface="Calibri"/>
+                        </a:rPr>
+                        <a:t>$1,323</a:t>
+                      </a:r>
+                    </a:p>
+                  </a:txBody>
+                  <a:tcPr marL="54864" marR="54864" marT="27432" marB="27432">
+                    <a:solidFill>
+                      <a:srgbClr val="FFFFFF"/>
+                    </a:solidFill>
+                  </a:tcPr>
+                </a:tc>
+                <a:tc>
+                  <a:txBody>
+                    <a:bodyPr/>
+                    <a:lstStyle/>
+                    <a:p>
+                      <a:pPr algn="r"/>
+                      <a:r>
+                        <a:rPr sz="850" b="0">
+                          <a:solidFill>
+                            <a:srgbClr val="2B3147"/>
+                          </a:solidFill>
+                          <a:latin typeface="Calibri"/>
+                        </a:rPr>
+                        <a:t>$2,189</a:t>
+                      </a:r>
+                    </a:p>
+                  </a:txBody>
+                  <a:tcPr marL="54864" marR="54864" marT="27432" marB="27432">
+                    <a:solidFill>
+                      <a:srgbClr val="FFFFFF"/>
+                    </a:solidFill>
+                  </a:tcPr>
+                </a:tc>
+                <a:tc>
+                  <a:txBody>
+                    <a:bodyPr/>
+                    <a:lstStyle/>
+                    <a:p>
+                      <a:pPr algn="r"/>
+                      <a:r>
+                        <a:rPr sz="850" b="0">
+                          <a:solidFill>
+                            <a:srgbClr val="2B3147"/>
+                          </a:solidFill>
+                          <a:latin typeface="Calibri"/>
+                        </a:rPr>
+                        <a:t>$4,151</a:t>
+                      </a:r>
+                    </a:p>
+                  </a:txBody>
+                  <a:tcPr marL="54864" marR="54864" marT="27432" marB="27432">
+                    <a:solidFill>
+                      <a:srgbClr val="FFFFFF"/>
+                    </a:solidFill>
+                  </a:tcPr>
+                </a:tc>
+                <a:tc>
+                  <a:txBody>
+                    <a:bodyPr/>
+                    <a:lstStyle/>
+                    <a:p>
+                      <a:pPr algn="r"/>
+                      <a:r>
+                        <a:rPr sz="850" b="0">
+                          <a:solidFill>
+                            <a:srgbClr val="2B3147"/>
+                          </a:solidFill>
+                          <a:latin typeface="Calibri"/>
+                        </a:rPr>
+                        <a:t>$7,889</a:t>
+                      </a:r>
+                    </a:p>
+                  </a:txBody>
+                  <a:tcPr marL="54864" marR="54864" marT="27432" marB="27432">
+                    <a:solidFill>
+                      <a:srgbClr val="FFFFFF"/>
+                    </a:solidFill>
+                  </a:tcPr>
+                </a:tc>
+                <a:tc>
+                  <a:txBody>
+                    <a:bodyPr/>
+                    <a:lstStyle/>
+                    <a:p>
+                      <a:pPr algn="r"/>
+                      <a:r>
+                        <a:rPr sz="850" b="0">
+                          <a:solidFill>
+                            <a:srgbClr val="2B3147"/>
+                          </a:solidFill>
+                          <a:latin typeface="Calibri"/>
+                        </a:rPr>
+                        <a:t>+90%</a:t>
+                      </a:r>
+                    </a:p>
+                  </a:txBody>
+                  <a:tcPr marL="54864" marR="54864" marT="27432" marB="27432">
+                    <a:solidFill>
+                      <a:srgbClr val="FFFFFF"/>
+                    </a:solidFill>
+                  </a:tcPr>
+                </a:tc>
+              </a:tr>
+              <a:tr h="274320">
+                <a:tc>
+                  <a:txBody>
+                    <a:bodyPr/>
+                    <a:lstStyle/>
+                    <a:p>
+                      <a:pPr algn="l"/>
+                      <a:r>
+                        <a:rPr sz="850" b="1">
+                          <a:solidFill>
+                            <a:srgbClr val="2B3147"/>
+                          </a:solidFill>
+                          <a:latin typeface="Calibri"/>
+                        </a:rPr>
+                        <a:t>Trading Volume</a:t>
+                      </a:r>
+                    </a:p>
+                  </a:txBody>
+                  <a:tcPr marL="54864" marR="54864" marT="27432" marB="27432">
+                    <a:solidFill>
+                      <a:srgbClr val="F9FAFC"/>
+                    </a:solidFill>
+                  </a:tcPr>
+                </a:tc>
+                <a:tc>
+                  <a:txBody>
+                    <a:bodyPr/>
+                    <a:lstStyle/>
+                    <a:p>
+                      <a:pPr algn="r"/>
+                      <a:r>
+                        <a:rPr sz="850" b="0">
+                          <a:solidFill>
+                            <a:srgbClr val="2B3147"/>
+                          </a:solidFill>
+                          <a:latin typeface="Calibri"/>
+                        </a:rPr>
+                        <a:t>$5.1B</a:t>
+                      </a:r>
+                    </a:p>
+                  </a:txBody>
+                  <a:tcPr marL="54864" marR="54864" marT="27432" marB="27432">
+                    <a:solidFill>
+                      <a:srgbClr val="F9FAFC"/>
+                    </a:solidFill>
+                  </a:tcPr>
+                </a:tc>
+                <a:tc>
+                  <a:txBody>
+                    <a:bodyPr/>
+                    <a:lstStyle/>
+                    <a:p>
+                      <a:pPr algn="r"/>
+                      <a:r>
+                        <a:rPr sz="850" b="0">
+                          <a:solidFill>
+                            <a:srgbClr val="2B3147"/>
+                          </a:solidFill>
+                          <a:latin typeface="Calibri"/>
+                        </a:rPr>
+                        <a:t>$2.5B</a:t>
+                      </a:r>
+                    </a:p>
+                  </a:txBody>
+                  <a:tcPr marL="54864" marR="54864" marT="27432" marB="27432">
+                    <a:solidFill>
+                      <a:srgbClr val="F9FAFC"/>
+                    </a:solidFill>
+                  </a:tcPr>
+                </a:tc>
+                <a:tc>
+                  <a:txBody>
+                    <a:bodyPr/>
+                    <a:lstStyle/>
+                    <a:p>
+                      <a:pPr algn="r"/>
+                      <a:r>
+                        <a:rPr sz="850" b="0">
+                          <a:solidFill>
+                            <a:srgbClr val="2B3147"/>
+                          </a:solidFill>
+                          <a:latin typeface="Calibri"/>
+                        </a:rPr>
+                        <a:t>$2.3B</a:t>
+                      </a:r>
+                    </a:p>
+                  </a:txBody>
+                  <a:tcPr marL="54864" marR="54864" marT="27432" marB="27432">
+                    <a:solidFill>
+                      <a:srgbClr val="F9FAFC"/>
+                    </a:solidFill>
+                  </a:tcPr>
+                </a:tc>
+                <a:tc>
+                  <a:txBody>
+                    <a:bodyPr/>
+                    <a:lstStyle/>
+                    <a:p>
+                      <a:pPr algn="r"/>
+                      <a:r>
+                        <a:rPr sz="850" b="0">
+                          <a:solidFill>
+                            <a:srgbClr val="2B3147"/>
+                          </a:solidFill>
+                          <a:latin typeface="Calibri"/>
+                        </a:rPr>
+                        <a:t>$2.1B</a:t>
+                      </a:r>
+                    </a:p>
+                  </a:txBody>
+                  <a:tcPr marL="54864" marR="54864" marT="27432" marB="27432">
+                    <a:solidFill>
+                      <a:srgbClr val="F9FAFC"/>
+                    </a:solidFill>
+                  </a:tcPr>
+                </a:tc>
+                <a:tc>
+                  <a:txBody>
+                    <a:bodyPr/>
+                    <a:lstStyle/>
+                    <a:p>
+                      <a:pPr algn="r"/>
+                      <a:r>
+                        <a:rPr sz="850" b="0">
+                          <a:solidFill>
+                            <a:srgbClr val="2B3147"/>
+                          </a:solidFill>
+                          <a:latin typeface="Calibri"/>
+                        </a:rPr>
+                        <a:t>$1.1B</a:t>
+                      </a:r>
+                    </a:p>
+                  </a:txBody>
+                  <a:tcPr marL="54864" marR="54864" marT="27432" marB="27432">
+                    <a:solidFill>
+                      <a:srgbClr val="F9FAFC"/>
+                    </a:solidFill>
+                  </a:tcPr>
+                </a:tc>
+                <a:tc>
+                  <a:txBody>
+                    <a:bodyPr/>
+                    <a:lstStyle/>
+                    <a:p>
+                      <a:pPr algn="r"/>
+                      <a:r>
+                        <a:rPr sz="850" b="0">
+                          <a:solidFill>
+                            <a:srgbClr val="2B3147"/>
+                          </a:solidFill>
+                          <a:latin typeface="Calibri"/>
+                        </a:rPr>
+                        <a:t>$1.1B</a:t>
+                      </a:r>
+                    </a:p>
+                  </a:txBody>
+                  <a:tcPr marL="54864" marR="54864" marT="27432" marB="27432">
+                    <a:solidFill>
+                      <a:srgbClr val="F9FAFC"/>
+                    </a:solidFill>
+                  </a:tcPr>
+                </a:tc>
+                <a:tc>
+                  <a:txBody>
+                    <a:bodyPr/>
+                    <a:lstStyle/>
+                    <a:p>
+                      <a:pPr algn="r"/>
+                      <a:r>
+                        <a:rPr sz="850" b="0">
+                          <a:solidFill>
+                            <a:srgbClr val="2B3147"/>
+                          </a:solidFill>
+                          <a:latin typeface="Calibri"/>
+                        </a:rPr>
+                        <a:t>—</a:t>
+                      </a:r>
+                    </a:p>
+                  </a:txBody>
+                  <a:tcPr marL="54864" marR="54864" marT="27432" marB="27432">
+                    <a:solidFill>
+                      <a:srgbClr val="F9FAFC"/>
+                    </a:solidFill>
+                  </a:tcPr>
+                </a:tc>
+                <a:tc>
+                  <a:txBody>
+                    <a:bodyPr/>
+                    <a:lstStyle/>
+                    <a:p>
+                      <a:pPr algn="r"/>
+                      <a:r>
+                        <a:rPr sz="850" b="0">
+                          <a:solidFill>
+                            <a:srgbClr val="2B3147"/>
+                          </a:solidFill>
+                          <a:latin typeface="Calibri"/>
+                        </a:rPr>
                         <a:t>—</a:t>
                       </a:r>
                     </a:p>
@@ -10336,14 +12353,14 @@
       </p:graphicFrame>
       <p:sp>
         <p:nvSpPr>
-          <p:cNvPr id="11" name="TextBox 10"/>
+          <p:cNvPr id="12" name="TextBox 11"/>
           <p:cNvSpPr txBox="1"/>
           <p:nvPr/>
         </p:nvSpPr>
         <p:spPr>
           <a:xfrm>
-            <a:off x="457200" y="4343400"/>
-            <a:ext cx="6766560" cy="548640"/>
+            <a:off x="457200" y="6144768"/>
+            <a:ext cx="11247120" cy="274320"/>
           </a:xfrm>
           <a:prstGeom prst="rect">
             <a:avLst/>
@@ -10364,183 +12381,7 @@
                 </a:solidFill>
                 <a:latin typeface="Calibri"/>
               </a:rPr>
-              <a:t>Funnel metrics are blended organic + paid, from the client dashboard. July rows land with the client dashboard refresh, before this deck is presented. Approval, funding and trading are the application-review and account-activation journey, reported as provided.</a:t>
-            </a:r>
-          </a:p>
-        </p:txBody>
-      </p:sp>
-      <p:sp>
-        <p:nvSpPr>
-          <p:cNvPr id="12" name="Rectangle 11"/>
-          <p:cNvSpPr/>
-          <p:nvPr/>
-        </p:nvSpPr>
-        <p:spPr>
-          <a:xfrm>
-            <a:off x="7406640" y="1828800"/>
-            <a:ext cx="4297680" cy="2926080"/>
-          </a:xfrm>
-          <a:prstGeom prst="rect">
-            <a:avLst/>
-          </a:prstGeom>
-          <a:solidFill>
-            <a:srgbClr val="FFFFFF"/>
-          </a:solidFill>
-          <a:ln w="9525">
-            <a:solidFill>
-              <a:srgbClr val="D0D4DC"/>
-            </a:solidFill>
-          </a:ln>
-          <a:effectLst/>
-        </p:spPr>
-        <p:style>
-          <a:lnRef idx="1">
-            <a:schemeClr val="accent1"/>
-          </a:lnRef>
-          <a:fillRef idx="3">
-            <a:schemeClr val="accent1"/>
-          </a:fillRef>
-          <a:effectRef idx="2">
-            <a:schemeClr val="accent1"/>
-          </a:effectRef>
-          <a:fontRef idx="minor">
-            <a:schemeClr val="lt1"/>
-          </a:fontRef>
-        </p:style>
-        <p:txBody>
-          <a:bodyPr rtlCol="0" anchor="ctr"/>
-          <a:lstStyle/>
-          <a:p>
-            <a:pPr algn="ctr"/>
-          </a:p>
-        </p:txBody>
-      </p:sp>
-      <p:sp>
-        <p:nvSpPr>
-          <p:cNvPr id="13" name="Rectangle 12"/>
-          <p:cNvSpPr/>
-          <p:nvPr/>
-        </p:nvSpPr>
-        <p:spPr>
-          <a:xfrm>
-            <a:off x="7406640" y="1828800"/>
-            <a:ext cx="64008" cy="2926080"/>
-          </a:xfrm>
-          <a:prstGeom prst="rect">
-            <a:avLst/>
-          </a:prstGeom>
-          <a:solidFill>
-            <a:srgbClr val="0F1535"/>
-          </a:solidFill>
-          <a:ln>
-            <a:noFill/>
-          </a:ln>
-          <a:effectLst/>
-        </p:spPr>
-        <p:style>
-          <a:lnRef idx="1">
-            <a:schemeClr val="accent1"/>
-          </a:lnRef>
-          <a:fillRef idx="3">
-            <a:schemeClr val="accent1"/>
-          </a:fillRef>
-          <a:effectRef idx="2">
-            <a:schemeClr val="accent1"/>
-          </a:effectRef>
-          <a:fontRef idx="minor">
-            <a:schemeClr val="lt1"/>
-          </a:fontRef>
-        </p:style>
-        <p:txBody>
-          <a:bodyPr rtlCol="0" anchor="ctr"/>
-          <a:lstStyle/>
-          <a:p>
-            <a:pPr algn="ctr"/>
-          </a:p>
-        </p:txBody>
-      </p:sp>
-      <p:sp>
-        <p:nvSpPr>
-          <p:cNvPr id="14" name="TextBox 13"/>
-          <p:cNvSpPr txBox="1"/>
-          <p:nvPr/>
-        </p:nvSpPr>
-        <p:spPr>
-          <a:xfrm>
-            <a:off x="7626096" y="1993392"/>
-            <a:ext cx="3895344" cy="274320"/>
-          </a:xfrm>
-          <a:prstGeom prst="rect">
-            <a:avLst/>
-          </a:prstGeom>
-          <a:noFill/>
-        </p:spPr>
-        <p:txBody>
-          <a:bodyPr wrap="square" anchor="t" lIns="0" rIns="0" tIns="0" bIns="0">
-            <a:spAutoFit/>
-          </a:bodyPr>
-          <a:lstStyle/>
-          <a:p>
-            <a:pPr algn="l"/>
-            <a:r>
-              <a:rPr sz="1000" b="1">
-                <a:solidFill>
-                  <a:srgbClr val="1E2761"/>
-                </a:solidFill>
-                <a:latin typeface="Georgia"/>
-              </a:rPr>
-              <a:t>HOW TO READ THIS</a:t>
-            </a:r>
-          </a:p>
-        </p:txBody>
-      </p:sp>
-      <p:sp>
-        <p:nvSpPr>
-          <p:cNvPr id="15" name="TextBox 14"/>
-          <p:cNvSpPr txBox="1"/>
-          <p:nvPr/>
-        </p:nvSpPr>
-        <p:spPr>
-          <a:xfrm>
-            <a:off x="7626096" y="2331720"/>
-            <a:ext cx="3895344" cy="2240280"/>
-          </a:xfrm>
-          <a:prstGeom prst="rect">
-            <a:avLst/>
-          </a:prstGeom>
-          <a:noFill/>
-        </p:spPr>
-        <p:txBody>
-          <a:bodyPr wrap="square" anchor="t" lIns="0" rIns="0" tIns="0" bIns="0">
-            <a:spAutoFit/>
-          </a:bodyPr>
-          <a:lstStyle/>
-          <a:p>
-            <a:pPr algn="l"/>
-            <a:r>
-              <a:rPr sz="950" b="0">
-                <a:solidFill>
-                  <a:srgbClr val="2B3147"/>
-                </a:solidFill>
-                <a:latin typeface="Calibri"/>
-              </a:rPr>
-              <a:t>The stages below submitted applications are the account review and activation journey, shown for the full blended base.</a:t>
-            </a:r>
-          </a:p>
-          <a:p>
-            <a:pPr algn="l">
-              <a:spcBef>
-                <a:spcPts val="600"/>
-              </a:spcBef>
-            </a:pPr>
-            <a:r>
-              <a:rPr sz="950" b="0">
-                <a:solidFill>
-                  <a:srgbClr val="2B3147"/>
-                </a:solidFill>
-                <a:latin typeface="Calibri"/>
-              </a:rPr>
-              <a:t>Paid-media performance per channel starts on the next slide; its submitted-application figures are channel-sourced and are not this blended count.</a:t>
+              <a:t>Funnel metrics are blended organic + paid, from the client dashboard. Working media per the budget tracker. MoM = July vs June. January cost figures reflect a near-zero media base ($1,717). July trading volume follows with the next dashboard refresh.</a:t>
             </a:r>
           </a:p>
         </p:txBody>

</xml_diff>

<commit_message>
Slide 2: Mexico mention on window-safe ratios; client question reframed to period confirmation
Co-Authored-By: Claude Fable 5 <noreply@anthropic.com>
</commit_message>
<xml_diff>
--- a/reports/forex/ggmi/2026-07/output/GGMI_LATAM_July_2026_Performance_Review.pptx
+++ b/reports/forex/ggmi/2026-07/output/GGMI_LATAM_July_2026_Performance_Review.pptx
@@ -10015,6 +10015,22 @@
                 <a:latin typeface="Calibri"/>
               </a:rPr>
               <a:t>•  Working media reached $149,896 in July, up 24% MoM and the biggest month of 2026. Measured paid submitted applications (Bing plus Azerion) came in at 61.</a:t>
+            </a:r>
+          </a:p>
+          <a:p>
+            <a:pPr algn="l">
+              <a:spcBef>
+                <a:spcPts val="400"/>
+              </a:spcBef>
+            </a:pPr>
+            <a:r>
+              <a:rPr sz="1000" b="0">
+                <a:solidFill>
+                  <a:srgbClr val="2B3147"/>
+                </a:solidFill>
+                <a:latin typeface="Calibri"/>
+              </a:rPr>
+              <a:t>•  Mexico, the only market with paid media behind it, is the strongest converter in the client’s country data: a 40% approval rate against the 28% blended average, and roughly one in four of all funded accounts.</a:t>
             </a:r>
           </a:p>
         </p:txBody>

</xml_diff>

<commit_message>
Adversarial review rulings: rebuild framing, Meta policy line, mix-shift decomposition; bidding exclusion re-verified live
Co-Authored-By: Claude Fable 5 <noreply@anthropic.com>
</commit_message>
<xml_diff>
--- a/reports/forex/ggmi/2026-07/output/GGMI_LATAM_July_2026_Performance_Review.pptx
+++ b/reports/forex/ggmi/2026-07/output/GGMI_LATAM_July_2026_Performance_Review.pptx
@@ -6079,7 +6079,7 @@
                 </a:solidFill>
                 <a:latin typeface="Calibri"/>
               </a:rPr>
-              <a:t>The other June ask, narrowing targeting away from the 55-and-over audience, was not implemented; targeting still runs 18–65 with audience expansion on.</a:t>
+              <a:t>On the June ask to narrow targeting to 25 and over: Meta restricts demographic targeting for financial-services advertisers, so that refinement is not available in this vertical; delivery runs on the platform’s full 18–65 range.</a:t>
             </a:r>
           </a:p>
         </p:txBody>
@@ -8344,7 +8344,7 @@
                 </a:solidFill>
                 <a:latin typeface="Calibri"/>
               </a:rPr>
-              <a:t>A large share of July’s session dip tracks Bing’s own month: dark for ten days, then a non-converting legacy structure for eleven. Property-wide, one unattributed bucket collapsed sharply; sessions outside it grew.</a:t>
+              <a:t>A large share of July’s session dip tracks Bing’s own month: ten days of rebuild, then the transition window. Property-wide, sessions without source attribution (largely untagged paid search) fell sharply; attributed sessions grew.</a:t>
             </a:r>
           </a:p>
           <a:p>
@@ -8360,7 +8360,7 @@
                 </a:solidFill>
                 <a:latin typeface="Calibri"/>
               </a:rPr>
-              <a:t>Venezuela’s session volume fell sharply with the same legacy-campaign pause behind Bing’s in-market concentration, a campaign-mix effect this month.</a:t>
+              <a:t>Venezuela’s session volume fell sharply as the prior campaigns retired, the same campaign-mix effect behind Bing’s in-market concentration this month.</a:t>
             </a:r>
           </a:p>
         </p:txBody>
@@ -10014,7 +10014,7 @@
                 </a:solidFill>
                 <a:latin typeface="Calibri"/>
               </a:rPr>
-              <a:t>•  Working media reached $149,896 in July, up 24% MoM and the biggest month of 2026. Measured paid submitted applications (Bing plus Azerion) came in at 61.</a:t>
+              <a:t>•  Working media reached $149,896 in July, up 24% MoM and the biggest month of 2026. The growth sits in the new Native and DOOH lines; the four continuing channels spent $95,401 against June’s total of $120,393, and paid submitted applications with a measured source (Bing plus Azerion) came in at 61.</a:t>
             </a:r>
           </a:p>
           <a:p>
@@ -14072,7 +14072,7 @@
                 </a:solidFill>
                 <a:latin typeface="Calibri"/>
               </a:rPr>
-              <a:t>The rise traces to Bing, dark for a third of the month and non-converting for another third, not to Azerion, which held steady.</a:t>
+              <a:t>The rise traces to Bing, which spent the first third of July rebuilding its campaign structure and the next third transitioning to it, not to Azerion, which held steady.</a:t>
             </a:r>
           </a:p>
         </p:txBody>
@@ -14930,7 +14930,7 @@
                 </a:solidFill>
                 <a:latin typeface="Calibri"/>
               </a:rPr>
-              <a:t>84% of legacy-campaign clicks landed on pages outside the application flow; none of the 207 application starts behind them became a submission.</a:t>
+              <a:t>84% of the prior structure’s clicks landed on pages outside the application flow; none of the 207 application starts behind them became a submission.</a:t>
             </a:r>
           </a:p>
           <a:p>
@@ -15726,7 +15726,7 @@
                 </a:solidFill>
                 <a:latin typeface="Calibri"/>
               </a:rPr>
-              <a:t>per the shared budget view</a:t>
+              <a:t>Jul 1–31</a:t>
             </a:r>
           </a:p>
         </p:txBody>
@@ -16733,7 +16733,7 @@
         <p:spPr>
           <a:xfrm>
             <a:off x="731520" y="3291840"/>
-            <a:ext cx="2011680" cy="274320"/>
+            <a:ext cx="2194560" cy="274320"/>
           </a:xfrm>
           <a:prstGeom prst="rect">
             <a:avLst/>
@@ -16754,7 +16754,7 @@
                 </a:solidFill>
                 <a:latin typeface="Calibri"/>
               </a:rPr>
-              <a:t>Jul 1–10 · dark</a:t>
+              <a:t>Jul 1–10 · rebuild</a:t>
             </a:r>
           </a:p>
         </p:txBody>
@@ -16768,7 +16768,7 @@
         <p:spPr>
           <a:xfrm>
             <a:off x="3108960" y="3291840"/>
-            <a:ext cx="2377440" cy="274320"/>
+            <a:ext cx="2651760" cy="274320"/>
           </a:xfrm>
           <a:prstGeom prst="rect">
             <a:avLst/>
@@ -16789,7 +16789,7 @@
                 </a:solidFill>
                 <a:latin typeface="Calibri"/>
               </a:rPr>
-              <a:t>Jul 11–22 · legacy</a:t>
+              <a:t>Jul 11–22 · prior structure</a:t>
             </a:r>
           </a:p>
         </p:txBody>
@@ -16802,8 +16802,8 @@
         </p:nvSpPr>
         <p:spPr>
           <a:xfrm>
-            <a:off x="5669280" y="3291840"/>
-            <a:ext cx="2011680" cy="274320"/>
+            <a:off x="5943600" y="3291840"/>
+            <a:ext cx="2194560" cy="274320"/>
           </a:xfrm>
           <a:prstGeom prst="rect">
             <a:avLst/>
@@ -16824,7 +16824,7 @@
                 </a:solidFill>
                 <a:latin typeface="Calibri"/>
               </a:rPr>
-              <a:t>Jul 22–31 · rebuilt</a:t>
+              <a:t>Jul 22–31 · new structure</a:t>
             </a:r>
           </a:p>
         </p:txBody>
@@ -16961,7 +16961,7 @@
                           </a:solidFill>
                           <a:latin typeface="Calibri"/>
                         </a:rPr>
-                        <a:t>Jul 1–10  dark</a:t>
+                        <a:t>Jul 1–10  rebuild</a:t>
                       </a:r>
                     </a:p>
                   </a:txBody>
@@ -17055,7 +17055,7 @@
                           </a:solidFill>
                           <a:latin typeface="Calibri"/>
                         </a:rPr>
-                        <a:t>Jul 11–22  legacy</a:t>
+                        <a:t>Jul 11–22  prior structure</a:t>
                       </a:r>
                     </a:p>
                   </a:txBody>
@@ -17149,7 +17149,7 @@
                           </a:solidFill>
                           <a:latin typeface="Calibri"/>
                         </a:rPr>
-                        <a:t>Jul 22–31  rebuilt</a:t>
+                        <a:t>Jul 22–31  new structure</a:t>
                       </a:r>
                     </a:p>
                   </a:txBody>
@@ -17263,7 +17263,7 @@
                 </a:solidFill>
                 <a:latin typeface="Calibri"/>
               </a:rPr>
-              <a:t>Two campaigns produced every July conversion: the TradingView theme (18 of 20) and one further new campaign (2). The full-month CPA blends nine dark days and eleven zero-conversion days into the ten that delivered.</a:t>
+              <a:t>July was a planned rebuild: the first ten days went to constructing the new Mexico-only structure, the prior campaigns ran through the transition, and the new structure went live July 22. Two campaigns produced every July conversion: the TradingView theme (18 of 20) and one further new campaign (2).</a:t>
             </a:r>
           </a:p>
         </p:txBody>
@@ -17737,7 +17737,7 @@
                 </a:solidFill>
                 <a:latin typeface="Calibri"/>
               </a:rPr>
-              <a:t>June’s deck named Platform Intercept the efficiency leader at $285 and recommended rebalancing toward it. Both named June campaigns produced zero July applications in the legacy window and retired into the July 22 rebuild; the TradingView campaign is now the leader with 18 of 20 applications and 13.4% start-to-submission.</a:t>
+              <a:t>June’s deck named Platform Intercept the efficiency leader at $285 and recommended rebalancing toward it. Both named June campaigns produced zero July applications in the transition window and retired when the new structure launched July 22; the TradingView campaign is now the leader with 18 of 20 applications and 13.4% start-to-submission.</a:t>
             </a:r>
           </a:p>
           <a:p>
@@ -17753,7 +17753,7 @@
                 </a:solidFill>
                 <a:latin typeface="Calibri"/>
               </a:rPr>
-              <a:t>84% of legacy-campaign clicks landed on pages outside the application flow, and every one of the 207 application starts stopped at the second step. The rebuilt campaigns land on the Spanish-language site and convert. Landing destination and keyword intent changed together, so this is a strong signal rather than a proven single cause. The step data itself is unambiguous: the loss sits between a started and a submitted application.</a:t>
+              <a:t>84% of the prior structure’s clicks landed on pages outside the application flow, and every one of the 207 application starts stopped at the second step. The rebuilt campaigns land on the Spanish-language site and convert. Landing destination and keyword intent changed together, so this is a strong signal rather than a proven single cause. The step data itself is unambiguous: the loss sits between a started and a submitted application.</a:t>
             </a:r>
           </a:p>
           <a:p>

</xml_diff>

<commit_message>
Bidding rec moved to SA360 layer (native goal flags expected under SA360 management); verified MANUAL_CPC at SA360
Co-Authored-By: Claude Fable 5 <noreply@anthropic.com>
</commit_message>
<xml_diff>
--- a/reports/forex/ggmi/2026-07/output/GGMI_LATAM_July_2026_Performance_Review.pptx
+++ b/reports/forex/ggmi/2026-07/output/GGMI_LATAM_July_2026_Performance_Review.pptx
@@ -9186,7 +9186,7 @@
                 </a:solidFill>
                 <a:latin typeface="Calibri"/>
               </a:rPr>
-              <a:t>Turn on bidding feedback for the Bing conversion goals; July’s $237.12 was earned with no automated signal.</a:t>
+              <a:t>Move Bing bidding onto SA360’s conversion-based strategies; July’s $237.12 was earned on manual CPC.</a:t>
             </a:r>
           </a:p>
           <a:p>
@@ -9633,7 +9633,7 @@
                 </a:solidFill>
                 <a:latin typeface="Georgia"/>
               </a:rPr>
-              <a:t>The rebuilt structure converted at $237.12 in July. In August: harden the targeting configuration, standardize the landing destination, enable the bidding signal.</a:t>
+              <a:t>The rebuilt structure converted at $237.12 in July. In August: harden the targeting configuration, standardize the landing destination, activate conversion-based bidding in SA360.</a:t>
             </a:r>
           </a:p>
         </p:txBody>
@@ -17961,7 +17961,7 @@
                 </a:solidFill>
                 <a:latin typeface="Calibri"/>
               </a:rPr>
-              <a:t>Turn on bidding feedback: every conversion goal is still excluded from bidding and every campaign runs manual bids, so July’s $237.12 was earned with no automated signal. Enabling the goals lets the platform improve on it without manual tuning.</a:t>
+              <a:t>Move bidding onto SA360’s conversion-based strategies. Bing is optimized through SA360, where every conversion point is captured, and the enabled campaigns currently run manual CPC there. July’s $237.12 was earned on manual bids; a conversion-based strategy lets that data drive bidding.</a:t>
             </a:r>
           </a:p>
         </p:txBody>

</xml_diff>

<commit_message>
Scope ruling: account mechanics out of the client deck; performance-only framing on slides 4/6/11/14
Co-Authored-By: Claude Fable 5 <noreply@anthropic.com>
</commit_message>
<xml_diff>
--- a/reports/forex/ggmi/2026-07/output/GGMI_LATAM_July_2026_Performance_Review.pptx
+++ b/reports/forex/ggmi/2026-07/output/GGMI_LATAM_July_2026_Performance_Review.pptx
@@ -6066,22 +6066,6 @@
               <a:t>Placement mix shifted toward Instagram: 10.2% of July delivery, up from 0.3%, answering the specific ask from the June review. Facebook carried 89.2%.</a:t>
             </a:r>
           </a:p>
-          <a:p>
-            <a:pPr algn="l">
-              <a:spcBef>
-                <a:spcPts val="600"/>
-              </a:spcBef>
-            </a:pPr>
-            <a:r>
-              <a:rPr sz="950" b="0">
-                <a:solidFill>
-                  <a:srgbClr val="2B3147"/>
-                </a:solidFill>
-                <a:latin typeface="Calibri"/>
-              </a:rPr>
-              <a:t>On the June ask to narrow targeting to 25 and over: Meta restricts demographic targeting for financial-services advertisers, so that refinement is not available in this vertical; delivery runs on the platform’s full 18–65 range.</a:t>
-            </a:r>
-          </a:p>
         </p:txBody>
       </p:sp>
       <p:sp>
@@ -8736,7 +8720,7 @@
                 </a:solidFill>
                 <a:latin typeface="Georgia"/>
               </a:rPr>
-              <a:t>August priorities: targeting configuration, measurement completion, inventory quality.</a:t>
+              <a:t>August priorities: scale the rebuilt structure, complete measurement, hold inventory quality.</a:t>
             </a:r>
           </a:p>
         </p:txBody>
@@ -9010,23 +8994,7 @@
                 </a:solidFill>
                 <a:latin typeface="Calibri"/>
               </a:rPr>
-              <a:t>Harden the Mexico configuration: presence-only targeting and an expanded exclusion list on every enabled campaign.</a:t>
-            </a:r>
-          </a:p>
-          <a:p>
-            <a:pPr algn="l">
-              <a:spcBef>
-                <a:spcPts val="600"/>
-              </a:spcBef>
-            </a:pPr>
-            <a:r>
-              <a:rPr sz="900" b="0">
-                <a:solidFill>
-                  <a:srgbClr val="2B3147"/>
-                </a:solidFill>
-                <a:latin typeface="Calibri"/>
-              </a:rPr>
-              <a:t>Standardize every Bing campaign on the converting landing destination.</a:t>
+              <a:t>Scale the rebuilt Bing structure on the July close of $237.12; August is tracking at $243 across three products.</a:t>
             </a:r>
           </a:p>
         </p:txBody>
@@ -9186,23 +9154,7 @@
                 </a:solidFill>
                 <a:latin typeface="Calibri"/>
               </a:rPr>
-              <a:t>Move Bing bidding onto SA360’s conversion-based strategies; July’s $237.12 was earned on manual CPC.</a:t>
-            </a:r>
-          </a:p>
-          <a:p>
-            <a:pPr algn="l">
-              <a:spcBef>
-                <a:spcPts val="600"/>
-              </a:spcBef>
-            </a:pPr>
-            <a:r>
-              <a:rPr sz="900" b="0">
-                <a:solidFill>
-                  <a:srgbClr val="2B3147"/>
-                </a:solidFill>
-                <a:latin typeface="Calibri"/>
-              </a:rPr>
-              <a:t>Apply the 66-site Quantcast disallow list, led by tvazteca.com, and implement the viewability floor.</a:t>
+              <a:t>Apply the 66-site Quantcast disallow list, led by tvazteca.com, and hold delivery to the 70% viewability standard.</a:t>
             </a:r>
           </a:p>
         </p:txBody>
@@ -9362,7 +9314,7 @@
                 </a:solidFill>
                 <a:latin typeface="Calibri"/>
               </a:rPr>
-              <a:t>Complete the Bing-to-GA4 link; the flagged restatement lands with August’s key-event corroboration.</a:t>
+              <a:t>August is the first month GA4 can corroborate the submitted-application count.</a:t>
             </a:r>
           </a:p>
           <a:p>
@@ -9554,7 +9506,7 @@
                 </a:solidFill>
                 <a:latin typeface="Calibri"/>
               </a:rPr>
-              <a:t>Read Bing on the rebuilt structure’s $237.12, with August tracking at $243 across three products.</a:t>
+              <a:t>Native and DOOH report in full with a second month of data.</a:t>
             </a:r>
           </a:p>
         </p:txBody>
@@ -9633,7 +9585,7 @@
                 </a:solidFill>
                 <a:latin typeface="Georgia"/>
               </a:rPr>
-              <a:t>The rebuilt structure converted at $237.12 in July. In August: harden the targeting configuration, standardize the landing destination, activate conversion-based bidding in SA360.</a:t>
+              <a:t>The rebuilt structure converted at $237.12 in July. August scales it, holds programmatic quality, and brings GA4 corroboration online.</a:t>
             </a:r>
           </a:p>
         </p:txBody>
@@ -14722,7 +14674,7 @@
                 </a:solidFill>
                 <a:latin typeface="Calibri"/>
               </a:rPr>
-              <a:t>Harden the Mexico targeting configuration as the rebuilt campaigns scale.</a:t>
+              <a:t>Scale the rebuilt Bing structure. It closed July at $237.12 per submitted application, less than half June’s $513.17.</a:t>
             </a:r>
           </a:p>
           <a:p>
@@ -14738,7 +14690,7 @@
                 </a:solidFill>
                 <a:latin typeface="Calibri"/>
               </a:rPr>
-              <a:t>June’s correction held through July: delivery concentrated in-market on every one of the six new campaigns.</a:t>
+              <a:t>August’s first days track at $243, with three products converting.</a:t>
             </a:r>
           </a:p>
           <a:p>
@@ -14754,7 +14706,7 @@
                 </a:solidFill>
                 <a:latin typeface="Calibri"/>
               </a:rPr>
-              <a:t>Next: presence-only targeting and an expanded location-exclusion list, so the concentration holds on its own rather than depending on the current campaign mix.</a:t>
+              <a:t>June’s Mexico commitment held: delivery concentrated in-market across the month.</a:t>
             </a:r>
           </a:p>
         </p:txBody>
@@ -14914,7 +14866,7 @@
                 </a:solidFill>
                 <a:latin typeface="Calibri"/>
               </a:rPr>
-              <a:t>Standardize every Bing campaign on the converting landing destination.</a:t>
+              <a:t>Hold programmatic quality on Quantcast. Viewability improved 3.15 points to 54.45% and still sits under the 70% standard.</a:t>
             </a:r>
           </a:p>
           <a:p>
@@ -14930,23 +14882,7 @@
                 </a:solidFill>
                 <a:latin typeface="Calibri"/>
               </a:rPr>
-              <a:t>84% of the prior structure’s clicks landed on pages outside the application flow; none of the 207 application starts behind them became a submission.</a:t>
-            </a:r>
-          </a:p>
-          <a:p>
-            <a:pPr algn="l">
-              <a:spcBef>
-                <a:spcPts val="600"/>
-              </a:spcBef>
-            </a:pPr>
-            <a:r>
-              <a:rPr sz="900" b="0">
-                <a:solidFill>
-                  <a:srgbClr val="2B3147"/>
-                </a:solidFill>
-                <a:latin typeface="Calibri"/>
-              </a:rPr>
-              <a:t>The rebuilt campaigns landing on the Spanish-language site carried 13.4% of starts through to submission.</a:t>
+              <a:t>The refreshed 66-site disallow list is the direct lever, led by tvazteca.com.</a:t>
             </a:r>
           </a:p>
         </p:txBody>
@@ -15217,7 +15153,7 @@
                 </a:solidFill>
                 <a:latin typeface="Georgia"/>
               </a:rPr>
-              <a:t>The rebuilt structure delivered $237.12 per submitted application. Next: harden the configuration so that holds at scale.</a:t>
+              <a:t>The rebuilt structure delivered $237.12 per submitted application. August scales it.</a:t>
             </a:r>
           </a:p>
         </p:txBody>
@@ -17463,7 +17399,7 @@
                 </a:solidFill>
                 <a:latin typeface="Georgia"/>
               </a:rPr>
-              <a:t>The rebuild superseded June’s campaign picks. Three actions carry it into August.</a:t>
+              <a:t>The rebuild superseded June’s campaign picks. August scales what works.</a:t>
             </a:r>
           </a:p>
         </p:txBody>
@@ -17929,7 +17865,7 @@
                 </a:solidFill>
                 <a:latin typeface="Calibri"/>
               </a:rPr>
-              <a:t>Harden the Mexico configuration as volume scales: presence-only targeting and an expanded location-exclusion list on every enabled campaign.</a:t>
+              <a:t>Scale the rebuilt structure behind the TradingView theme, holding the July close of $237.12 as volume grows. August’s first days track at $243, with three products converting.</a:t>
             </a:r>
           </a:p>
           <a:p>
@@ -17945,23 +17881,7 @@
                 </a:solidFill>
                 <a:latin typeface="Calibri"/>
               </a:rPr>
-              <a:t>Standardize every campaign on the converting landing destination, and review the handoff from the older landing pages into the application flow.</a:t>
-            </a:r>
-          </a:p>
-          <a:p>
-            <a:pPr algn="l">
-              <a:spcBef>
-                <a:spcPts val="600"/>
-              </a:spcBef>
-            </a:pPr>
-            <a:r>
-              <a:rPr sz="950" b="0">
-                <a:solidFill>
-                  <a:srgbClr val="2B3147"/>
-                </a:solidFill>
-                <a:latin typeface="Calibri"/>
-              </a:rPr>
-              <a:t>Move bidding onto SA360’s conversion-based strategies. Bing is optimized through SA360, where every conversion point is captured, and the enabled campaigns currently run manual CPC there. July’s $237.12 was earned on manual bids; a conversion-based strategy lets that data drive bidding.</a:t>
+              <a:t>Read the account on the rebuilt structure’s results rather than the full-month average; the second half of July is the account’s current state.</a:t>
             </a:r>
           </a:p>
         </p:txBody>

</xml_diff>

<commit_message>
DOOH slides added from Perion consolidado, June DOOH report format; deck now 16 slides
Co-Authored-By: Claude Fable 5 <noreply@anthropic.com>
</commit_message>
<xml_diff>
--- a/reports/forex/ggmi/2026-07/output/GGMI_LATAM_July_2026_Performance_Review.pptx
+++ b/reports/forex/ggmi/2026-07/output/GGMI_LATAM_July_2026_Performance_Review.pptx
@@ -19,6 +19,8 @@
     <p:sldId id="267" r:id="rId18"/>
     <p:sldId id="268" r:id="rId19"/>
     <p:sldId id="269" r:id="rId20"/>
+    <p:sldId id="270" r:id="rId21"/>
+    <p:sldId id="271" r:id="rId22"/>
   </p:sldIdLst>
   <p:sldSz cx="12191695" cy="6858000" type="screen4x3"/>
   <p:notesSz cx="6858000" cy="9144000"/>
@@ -4051,7 +4053,7 @@
                 </a:solidFill>
                 <a:latin typeface="Calibri"/>
               </a:rPr>
-              <a:t>10 / 14</a:t>
+              <a:t>10 / 16</a:t>
             </a:r>
           </a:p>
         </p:txBody>
@@ -4717,7 +4719,7 @@
                 </a:solidFill>
                 <a:latin typeface="Calibri"/>
               </a:rPr>
-              <a:t>11 / 14</a:t>
+              <a:t>11 / 16</a:t>
             </a:r>
           </a:p>
         </p:txBody>
@@ -6553,7 +6555,7 @@
                 </a:solidFill>
                 <a:latin typeface="Calibri"/>
               </a:rPr>
-              <a:t>12 / 14</a:t>
+              <a:t>12 / 16</a:t>
             </a:r>
           </a:p>
         </p:txBody>
@@ -6898,7 +6900,7 @@
                 </a:solidFill>
                 <a:latin typeface="Calibri"/>
               </a:rPr>
-              <a:t>Native combines Quantcast’s dedicated native placement and Azerion’s native inventory. Azerion native viewability: 77.34%, clear of the 70% floor. DOOH reports spend only this cycle.</a:t>
+              <a:t>Native combines Quantcast’s dedicated native placement and Azerion’s native inventory. Azerion native viewability: 77.34%, clear of the 70% floor. DOOH delivery follows on the next slides.</a:t>
             </a:r>
           </a:p>
         </p:txBody>
@@ -7058,7 +7060,7 @@
                 </a:solidFill>
                 <a:latin typeface="Calibri"/>
               </a:rPr>
-              <a:t>Both are upper-funnel. Native carries a spend and delivery line with no conversion claim; DOOH carries spend only, with delivery detail out of scope this cycle.</a:t>
+              <a:t>Both are upper-funnel. Native carries a spend and delivery line with no conversion claim; DOOH delivery is reported on the two slides that follow.</a:t>
             </a:r>
           </a:p>
           <a:p>
@@ -7074,7 +7076,7 @@
                 </a:solidFill>
                 <a:latin typeface="Calibri"/>
               </a:rPr>
-              <a:t>Both report in full once a second month of data gives them something to compare against.</a:t>
+              <a:t>Both gain a month-over-month read with a second month of data.</a:t>
             </a:r>
           </a:p>
         </p:txBody>
@@ -7215,7 +7217,7 @@
                 </a:solidFill>
                 <a:latin typeface="Georgia"/>
               </a:rPr>
-              <a:t>SITE TRAFFIC  ·  GA4 (MEXICO)</a:t>
+              <a:t>DIGITAL OUT-OF-HOME  ·  CAMPAIGN OVERVIEW</a:t>
             </a:r>
           </a:p>
         </p:txBody>
@@ -7274,7 +7276,7 @@
                 </a:solidFill>
                 <a:latin typeface="Georgia"/>
               </a:rPr>
-              <a:t>Context this month. The measurement fix makes August the first fully measured month.</a:t>
+              <a:t>One DOOH campaign across Mexico City, Guadalajara and Monterrey.</a:t>
             </a:r>
           </a:p>
         </p:txBody>
@@ -7388,7 +7390,7 @@
                 </a:solidFill>
                 <a:latin typeface="Calibri"/>
               </a:rPr>
-              <a:t>13 / 14</a:t>
+              <a:t>13 / 16</a:t>
             </a:r>
           </a:p>
         </p:txBody>
@@ -7513,7 +7515,7 @@
                 </a:solidFill>
                 <a:latin typeface="Calibri"/>
               </a:rPr>
-              <a:t>MEXICO SESSIONS</a:t>
+              <a:t>TOTAL IMPRESSIONS</a:t>
             </a:r>
           </a:p>
         </p:txBody>
@@ -7548,7 +7550,7 @@
                 </a:solidFill>
                 <a:latin typeface="Calibri"/>
               </a:rPr>
-              <a:t>7,310</a:t>
+              <a:t>1,406,105</a:t>
             </a:r>
           </a:p>
         </p:txBody>
@@ -7583,7 +7585,7 @@
                 </a:solidFill>
                 <a:latin typeface="Calibri"/>
               </a:rPr>
-              <a:t>June: 9,236</a:t>
+              <a:t>opportunities to see</a:t>
             </a:r>
           </a:p>
         </p:txBody>
@@ -7708,7 +7710,7 @@
                 </a:solidFill>
                 <a:latin typeface="Calibri"/>
               </a:rPr>
-              <a:t>UNIQUE VISITORS</a:t>
+              <a:t>ESTIMATED REACH</a:t>
             </a:r>
           </a:p>
         </p:txBody>
@@ -7743,7 +7745,7 @@
                 </a:solidFill>
                 <a:latin typeface="Calibri"/>
               </a:rPr>
-              <a:t>3,981</a:t>
+              <a:t>781,169</a:t>
             </a:r>
           </a:p>
         </p:txBody>
@@ -7778,7 +7780,7 @@
                 </a:solidFill>
                 <a:latin typeface="Calibri"/>
               </a:rPr>
-              <a:t>Mexico</a:t>
+              <a:t>unique audience, modeled</a:t>
             </a:r>
           </a:p>
         </p:txBody>
@@ -7903,7 +7905,7 @@
                 </a:solidFill>
                 <a:latin typeface="Calibri"/>
               </a:rPr>
-              <a:t>KEY-EVENT CAPTURE</a:t>
+              <a:t>INVESTMENT</a:t>
             </a:r>
           </a:p>
         </p:txBody>
@@ -7938,7 +7940,7 @@
                 </a:solidFill>
                 <a:latin typeface="Calibri"/>
               </a:rPr>
-              <a:t>Fixed</a:t>
+              <a:t>$26,865</a:t>
             </a:r>
           </a:p>
         </p:txBody>
@@ -7973,7 +7975,7 @@
                 </a:solidFill>
                 <a:latin typeface="Calibri"/>
               </a:rPr>
-              <a:t>live since Jul 31</a:t>
+              <a:t>Jul 1–31</a:t>
             </a:r>
           </a:p>
         </p:txBody>
@@ -8098,7 +8100,7 @@
                 </a:solidFill>
                 <a:latin typeface="Calibri"/>
               </a:rPr>
-              <a:t>GA4 CORROBORATION</a:t>
+              <a:t>CPM</a:t>
             </a:r>
           </a:p>
         </p:txBody>
@@ -8133,7 +8135,7 @@
                 </a:solidFill>
                 <a:latin typeface="Calibri"/>
               </a:rPr>
-              <a:t>August</a:t>
+              <a:t>$19</a:t>
             </a:r>
           </a:p>
         </p:txBody>
@@ -8168,7 +8170,7 @@
                 </a:solidFill>
                 <a:latin typeface="Calibri"/>
               </a:rPr>
-              <a:t>first full month</a:t>
+              <a:t>USD per thousand</a:t>
             </a:r>
           </a:p>
         </p:txBody>
@@ -8181,8 +8183,8 @@
         </p:nvSpPr>
         <p:spPr>
           <a:xfrm>
-            <a:off x="457200" y="3017520"/>
-            <a:ext cx="5577840" cy="3108960"/>
+            <a:off x="8065008" y="1691640"/>
+            <a:ext cx="1783080" cy="1005840"/>
           </a:xfrm>
           <a:prstGeom prst="rect">
             <a:avLst/>
@@ -8227,14 +8229,14 @@
         </p:nvSpPr>
         <p:spPr>
           <a:xfrm>
-            <a:off x="457200" y="3017520"/>
-            <a:ext cx="64008" cy="3108960"/>
+            <a:off x="8065008" y="1691640"/>
+            <a:ext cx="54864" cy="1005840"/>
           </a:xfrm>
           <a:prstGeom prst="rect">
             <a:avLst/>
           </a:prstGeom>
           <a:solidFill>
-            <a:srgbClr val="2E7D57"/>
+            <a:srgbClr val="F96167"/>
           </a:solidFill>
           <a:ln>
             <a:noFill/>
@@ -8271,8 +8273,8 @@
         </p:nvSpPr>
         <p:spPr>
           <a:xfrm>
-            <a:off x="676656" y="3182112"/>
-            <a:ext cx="5175503" cy="274320"/>
+            <a:off x="8247888" y="1737360"/>
+            <a:ext cx="1508760" cy="274320"/>
           </a:xfrm>
           <a:prstGeom prst="rect">
             <a:avLst/>
@@ -8287,13 +8289,13 @@
           <a:p>
             <a:pPr algn="l"/>
             <a:r>
-              <a:rPr sz="1000" b="1">
-                <a:solidFill>
-                  <a:srgbClr val="1E2761"/>
-                </a:solidFill>
-                <a:latin typeface="Georgia"/>
-              </a:rPr>
-              <a:t>WHAT THE DATA SHOWS</a:t>
+              <a:rPr sz="800" b="1">
+                <a:solidFill>
+                  <a:srgbClr val="5A6072"/>
+                </a:solidFill>
+                <a:latin typeface="Calibri"/>
+              </a:rPr>
+              <a:t>AD PLAYS</a:t>
             </a:r>
           </a:p>
         </p:txBody>
@@ -8306,8 +8308,8 @@
         </p:nvSpPr>
         <p:spPr>
           <a:xfrm>
-            <a:off x="676656" y="3520439"/>
-            <a:ext cx="5175503" cy="2423160"/>
+            <a:off x="8247888" y="1984248"/>
+            <a:ext cx="1508760" cy="457200"/>
           </a:xfrm>
           <a:prstGeom prst="rect">
             <a:avLst/>
@@ -8322,43 +8324,376 @@
           <a:p>
             <a:pPr algn="l"/>
             <a:r>
-              <a:rPr sz="950" b="0">
-                <a:solidFill>
-                  <a:srgbClr val="2B3147"/>
+              <a:rPr sz="1500" b="1">
+                <a:solidFill>
+                  <a:srgbClr val="1E2761"/>
                 </a:solidFill>
                 <a:latin typeface="Calibri"/>
               </a:rPr>
-              <a:t>A large share of July’s session dip tracks Bing’s own month: ten days of rebuild, then the transition window. Property-wide, sessions without source attribution (largely untagged paid search) fell sharply; attributed sessions grew.</a:t>
-            </a:r>
-          </a:p>
-          <a:p>
-            <a:pPr algn="l">
-              <a:spcBef>
-                <a:spcPts val="600"/>
-              </a:spcBef>
-            </a:pPr>
-            <a:r>
-              <a:rPr sz="950" b="0">
-                <a:solidFill>
-                  <a:srgbClr val="2B3147"/>
+              <a:t>126,121</a:t>
+            </a:r>
+          </a:p>
+        </p:txBody>
+      </p:sp>
+      <p:sp>
+        <p:nvSpPr>
+          <p:cNvPr id="34" name="TextBox 33"/>
+          <p:cNvSpPr txBox="1"/>
+          <p:nvPr/>
+        </p:nvSpPr>
+        <p:spPr>
+          <a:xfrm>
+            <a:off x="8247888" y="2441448"/>
+            <a:ext cx="1508760" cy="219456"/>
+          </a:xfrm>
+          <a:prstGeom prst="rect">
+            <a:avLst/>
+          </a:prstGeom>
+          <a:noFill/>
+        </p:spPr>
+        <p:txBody>
+          <a:bodyPr wrap="square" anchor="t" lIns="0" rIns="0" tIns="0" bIns="0">
+            <a:spAutoFit/>
+          </a:bodyPr>
+          <a:lstStyle/>
+          <a:p>
+            <a:pPr algn="l"/>
+            <a:r>
+              <a:rPr sz="800" b="0">
+                <a:solidFill>
+                  <a:srgbClr val="5A6072"/>
                 </a:solidFill>
                 <a:latin typeface="Calibri"/>
               </a:rPr>
-              <a:t>Venezuela’s session volume fell sharply as the prior campaigns retired, the same campaign-mix effect behind Bing’s in-market concentration this month.</a:t>
-            </a:r>
-          </a:p>
-        </p:txBody>
-      </p:sp>
-      <p:sp>
-        <p:nvSpPr>
-          <p:cNvPr id="34" name="Rectangle 33"/>
+              <a:t>all 31 days</a:t>
+            </a:r>
+          </a:p>
+        </p:txBody>
+      </p:sp>
+      <p:graphicFrame>
+        <p:nvGraphicFramePr>
+          <p:cNvPr id="35" name="Table 34"/>
+          <p:cNvGraphicFramePr>
+            <a:graphicFrameLocks noGrp="1"/>
+          </p:cNvGraphicFramePr>
+          <p:nvPr/>
+        </p:nvGraphicFramePr>
+        <p:xfrm>
+          <a:off x="457200" y="3063240"/>
+          <a:ext cx="5577840" cy="2286000"/>
+        </p:xfrm>
+        <a:graphic>
+          <a:graphicData uri="http://schemas.openxmlformats.org/drawingml/2006/table">
+            <a:tbl>
+              <a:tblPr>
+                <a:tableStyleId>{5C22544A-7EE6-4342-B048-85BDC9FD1C3A}</a:tableStyleId>
+              </a:tblPr>
+              <a:tblGrid>
+                <a:gridCol w="1554480"/>
+                <a:gridCol w="4023360"/>
+              </a:tblGrid>
+              <a:tr h="381000">
+                <a:tc>
+                  <a:txBody>
+                    <a:bodyPr/>
+                    <a:lstStyle/>
+                    <a:p>
+                      <a:pPr algn="l"/>
+                      <a:r>
+                        <a:rPr sz="850" b="1">
+                          <a:solidFill>
+                            <a:srgbClr val="FFFFFF"/>
+                          </a:solidFill>
+                          <a:latin typeface="Calibri"/>
+                        </a:rPr>
+                        <a:t>Parameter</a:t>
+                      </a:r>
+                    </a:p>
+                  </a:txBody>
+                  <a:tcPr marL="54864" marR="54864" marT="27432" marB="27432">
+                    <a:solidFill>
+                      <a:srgbClr val="1E2761"/>
+                    </a:solidFill>
+                  </a:tcPr>
+                </a:tc>
+                <a:tc>
+                  <a:txBody>
+                    <a:bodyPr/>
+                    <a:lstStyle/>
+                    <a:p>
+                      <a:pPr algn="r"/>
+                      <a:r>
+                        <a:rPr sz="850" b="1">
+                          <a:solidFill>
+                            <a:srgbClr val="FFFFFF"/>
+                          </a:solidFill>
+                          <a:latin typeface="Calibri"/>
+                        </a:rPr>
+                        <a:t>Detail</a:t>
+                      </a:r>
+                    </a:p>
+                  </a:txBody>
+                  <a:tcPr marL="54864" marR="54864" marT="27432" marB="27432">
+                    <a:solidFill>
+                      <a:srgbClr val="1E2761"/>
+                    </a:solidFill>
+                  </a:tcPr>
+                </a:tc>
+              </a:tr>
+              <a:tr h="381000">
+                <a:tc>
+                  <a:txBody>
+                    <a:bodyPr/>
+                    <a:lstStyle/>
+                    <a:p>
+                      <a:pPr algn="l"/>
+                      <a:r>
+                        <a:rPr sz="850" b="1">
+                          <a:solidFill>
+                            <a:srgbClr val="2B3147"/>
+                          </a:solidFill>
+                          <a:latin typeface="Calibri"/>
+                        </a:rPr>
+                        <a:t>Markets</a:t>
+                      </a:r>
+                    </a:p>
+                  </a:txBody>
+                  <a:tcPr marL="54864" marR="54864" marT="27432" marB="27432">
+                    <a:solidFill>
+                      <a:srgbClr val="FFFFFF"/>
+                    </a:solidFill>
+                  </a:tcPr>
+                </a:tc>
+                <a:tc>
+                  <a:txBody>
+                    <a:bodyPr/>
+                    <a:lstStyle/>
+                    <a:p>
+                      <a:pPr algn="r"/>
+                      <a:r>
+                        <a:rPr sz="850" b="0">
+                          <a:solidFill>
+                            <a:srgbClr val="2B3147"/>
+                          </a:solidFill>
+                          <a:latin typeface="Calibri"/>
+                        </a:rPr>
+                        <a:t>Mexico City, Guadalajara, Monterrey</a:t>
+                      </a:r>
+                    </a:p>
+                  </a:txBody>
+                  <a:tcPr marL="54864" marR="54864" marT="27432" marB="27432">
+                    <a:solidFill>
+                      <a:srgbClr val="FFFFFF"/>
+                    </a:solidFill>
+                  </a:tcPr>
+                </a:tc>
+              </a:tr>
+              <a:tr h="381000">
+                <a:tc>
+                  <a:txBody>
+                    <a:bodyPr/>
+                    <a:lstStyle/>
+                    <a:p>
+                      <a:pPr algn="l"/>
+                      <a:r>
+                        <a:rPr sz="850" b="1">
+                          <a:solidFill>
+                            <a:srgbClr val="2B3147"/>
+                          </a:solidFill>
+                          <a:latin typeface="Calibri"/>
+                        </a:rPr>
+                        <a:t>Flight</a:t>
+                      </a:r>
+                    </a:p>
+                  </a:txBody>
+                  <a:tcPr marL="54864" marR="54864" marT="27432" marB="27432">
+                    <a:solidFill>
+                      <a:srgbClr val="F9FAFC"/>
+                    </a:solidFill>
+                  </a:tcPr>
+                </a:tc>
+                <a:tc>
+                  <a:txBody>
+                    <a:bodyPr/>
+                    <a:lstStyle/>
+                    <a:p>
+                      <a:pPr algn="r"/>
+                      <a:r>
+                        <a:rPr sz="850" b="0">
+                          <a:solidFill>
+                            <a:srgbClr val="2B3147"/>
+                          </a:solidFill>
+                          <a:latin typeface="Calibri"/>
+                        </a:rPr>
+                        <a:t>July 1–31, 2026</a:t>
+                      </a:r>
+                    </a:p>
+                  </a:txBody>
+                  <a:tcPr marL="54864" marR="54864" marT="27432" marB="27432">
+                    <a:solidFill>
+                      <a:srgbClr val="F9FAFC"/>
+                    </a:solidFill>
+                  </a:tcPr>
+                </a:tc>
+              </a:tr>
+              <a:tr h="381000">
+                <a:tc>
+                  <a:txBody>
+                    <a:bodyPr/>
+                    <a:lstStyle/>
+                    <a:p>
+                      <a:pPr algn="l"/>
+                      <a:r>
+                        <a:rPr sz="850" b="1">
+                          <a:solidFill>
+                            <a:srgbClr val="2B3147"/>
+                          </a:solidFill>
+                          <a:latin typeface="Calibri"/>
+                        </a:rPr>
+                        <a:t>Media</a:t>
+                      </a:r>
+                    </a:p>
+                  </a:txBody>
+                  <a:tcPr marL="54864" marR="54864" marT="27432" marB="27432">
+                    <a:solidFill>
+                      <a:srgbClr val="FFFFFF"/>
+                    </a:solidFill>
+                  </a:tcPr>
+                </a:tc>
+                <a:tc>
+                  <a:txBody>
+                    <a:bodyPr/>
+                    <a:lstStyle/>
+                    <a:p>
+                      <a:pPr algn="r"/>
+                      <a:r>
+                        <a:rPr sz="850" b="0">
+                          <a:solidFill>
+                            <a:srgbClr val="2B3147"/>
+                          </a:solidFill>
+                          <a:latin typeface="Calibri"/>
+                        </a:rPr>
+                        <a:t>Digital screens and bulletins</a:t>
+                      </a:r>
+                    </a:p>
+                  </a:txBody>
+                  <a:tcPr marL="54864" marR="54864" marT="27432" marB="27432">
+                    <a:solidFill>
+                      <a:srgbClr val="FFFFFF"/>
+                    </a:solidFill>
+                  </a:tcPr>
+                </a:tc>
+              </a:tr>
+              <a:tr h="381000">
+                <a:tc>
+                  <a:txBody>
+                    <a:bodyPr/>
+                    <a:lstStyle/>
+                    <a:p>
+                      <a:pPr algn="l"/>
+                      <a:r>
+                        <a:rPr sz="850" b="1">
+                          <a:solidFill>
+                            <a:srgbClr val="2B3147"/>
+                          </a:solidFill>
+                          <a:latin typeface="Calibri"/>
+                        </a:rPr>
+                        <a:t>Creative</a:t>
+                      </a:r>
+                    </a:p>
+                  </a:txBody>
+                  <a:tcPr marL="54864" marR="54864" marT="27432" marB="27432">
+                    <a:solidFill>
+                      <a:srgbClr val="F9FAFC"/>
+                    </a:solidFill>
+                  </a:tcPr>
+                </a:tc>
+                <a:tc>
+                  <a:txBody>
+                    <a:bodyPr/>
+                    <a:lstStyle/>
+                    <a:p>
+                      <a:pPr algn="r"/>
+                      <a:r>
+                        <a:rPr sz="850" b="0">
+                          <a:solidFill>
+                            <a:srgbClr val="2B3147"/>
+                          </a:solidFill>
+                          <a:latin typeface="Calibri"/>
+                        </a:rPr>
+                        <a:t>Commodities theme, Spanish</a:t>
+                      </a:r>
+                    </a:p>
+                  </a:txBody>
+                  <a:tcPr marL="54864" marR="54864" marT="27432" marB="27432">
+                    <a:solidFill>
+                      <a:srgbClr val="F9FAFC"/>
+                    </a:solidFill>
+                  </a:tcPr>
+                </a:tc>
+              </a:tr>
+              <a:tr h="381000">
+                <a:tc>
+                  <a:txBody>
+                    <a:bodyPr/>
+                    <a:lstStyle/>
+                    <a:p>
+                      <a:pPr algn="l"/>
+                      <a:r>
+                        <a:rPr sz="850" b="1">
+                          <a:solidFill>
+                            <a:srgbClr val="2B3147"/>
+                          </a:solidFill>
+                          <a:latin typeface="Calibri"/>
+                        </a:rPr>
+                        <a:t>Formats</a:t>
+                      </a:r>
+                    </a:p>
+                  </a:txBody>
+                  <a:tcPr marL="54864" marR="54864" marT="27432" marB="27432">
+                    <a:solidFill>
+                      <a:srgbClr val="FFFFFF"/>
+                    </a:solidFill>
+                  </a:tcPr>
+                </a:tc>
+                <a:tc>
+                  <a:txBody>
+                    <a:bodyPr/>
+                    <a:lstStyle/>
+                    <a:p>
+                      <a:pPr algn="r"/>
+                      <a:r>
+                        <a:rPr sz="850" b="0">
+                          <a:solidFill>
+                            <a:srgbClr val="2B3147"/>
+                          </a:solidFill>
+                          <a:latin typeface="Calibri"/>
+                        </a:rPr>
+                        <a:t>10s and 15s video, static image</a:t>
+                      </a:r>
+                    </a:p>
+                  </a:txBody>
+                  <a:tcPr marL="54864" marR="54864" marT="27432" marB="27432">
+                    <a:solidFill>
+                      <a:srgbClr val="FFFFFF"/>
+                    </a:solidFill>
+                  </a:tcPr>
+                </a:tc>
+              </a:tr>
+            </a:tbl>
+          </a:graphicData>
+        </a:graphic>
+      </p:graphicFrame>
+      <p:sp>
+        <p:nvSpPr>
+          <p:cNvPr id="36" name="Rectangle 35"/>
           <p:cNvSpPr/>
           <p:nvPr/>
         </p:nvSpPr>
         <p:spPr>
           <a:xfrm>
-            <a:off x="6309360" y="3017520"/>
-            <a:ext cx="5394960" cy="3108960"/>
+            <a:off x="6309360" y="3063240"/>
+            <a:ext cx="5394960" cy="3017520"/>
           </a:xfrm>
           <a:prstGeom prst="rect">
             <a:avLst/>
@@ -8397,14 +8732,14 @@
       </p:sp>
       <p:sp>
         <p:nvSpPr>
-          <p:cNvPr id="35" name="Rectangle 34"/>
+          <p:cNvPr id="37" name="Rectangle 36"/>
           <p:cNvSpPr/>
           <p:nvPr/>
         </p:nvSpPr>
         <p:spPr>
           <a:xfrm>
-            <a:off x="6309360" y="3017520"/>
-            <a:ext cx="64008" cy="3108960"/>
+            <a:off x="6309360" y="3063240"/>
+            <a:ext cx="64008" cy="3017520"/>
           </a:xfrm>
           <a:prstGeom prst="rect">
             <a:avLst/>
@@ -8441,13 +8776,13 @@
       </p:sp>
       <p:sp>
         <p:nvSpPr>
-          <p:cNvPr id="36" name="TextBox 35"/>
+          <p:cNvPr id="38" name="TextBox 37"/>
           <p:cNvSpPr txBox="1"/>
           <p:nvPr/>
         </p:nvSpPr>
         <p:spPr>
           <a:xfrm>
-            <a:off x="6528816" y="3182112"/>
+            <a:off x="6528816" y="3227832"/>
             <a:ext cx="4992624" cy="274320"/>
           </a:xfrm>
           <a:prstGeom prst="rect">
@@ -8469,21 +8804,21 @@
                 </a:solidFill>
                 <a:latin typeface="Georgia"/>
               </a:rPr>
-              <a:t>MEASUREMENT TO CLOSE</a:t>
-            </a:r>
-          </a:p>
-        </p:txBody>
-      </p:sp>
-      <p:sp>
-        <p:nvSpPr>
-          <p:cNvPr id="37" name="TextBox 36"/>
+              <a:t>CAMPAIGN TAKEAWAY</a:t>
+            </a:r>
+          </a:p>
+        </p:txBody>
+      </p:sp>
+      <p:sp>
+        <p:nvSpPr>
+          <p:cNvPr id="39" name="TextBox 38"/>
           <p:cNvSpPr txBox="1"/>
           <p:nvPr/>
         </p:nvSpPr>
         <p:spPr>
           <a:xfrm>
-            <a:off x="6528816" y="3520439"/>
-            <a:ext cx="4992624" cy="2423160"/>
+            <a:off x="6528816" y="3566160"/>
+            <a:ext cx="4992624" cy="2331720"/>
           </a:xfrm>
           <a:prstGeom prst="rect">
             <a:avLst/>
@@ -8504,7 +8839,7 @@
                 </a:solidFill>
                 <a:latin typeface="Calibri"/>
               </a:rPr>
-              <a:t>The submitted-application key event began counting correctly on July 31 and has held at full capture since. July is reported on the SA360 count; August is the first month GA4 can corroborate it independently.</a:t>
+              <a:t>The campaign ran all 31 days across the same three markets as June, on the commodities creative theme in Spanish.</a:t>
             </a:r>
           </a:p>
           <a:p>
@@ -8520,7 +8855,23 @@
                 </a:solidFill>
                 <a:latin typeface="Calibri"/>
               </a:rPr>
-              <a:t>Completion of the Bing-to-GA4 account link has not yet been verified; the paid-search restatement June’s deck flagged lands once it is, expected alongside August’s corroboration.</a:t>
+              <a:t>Mexico City carried 59% of delivery, with Guadalajara and Monterrey splitting the balance.</a:t>
+            </a:r>
+          </a:p>
+          <a:p>
+            <a:pPr algn="l">
+              <a:spcBef>
+                <a:spcPts val="600"/>
+              </a:spcBef>
+            </a:pPr>
+            <a:r>
+              <a:rPr sz="950" b="0">
+                <a:solidFill>
+                  <a:srgbClr val="2B3147"/>
+                </a:solidFill>
+                <a:latin typeface="Calibri"/>
+              </a:rPr>
+              <a:t>A second full month of delivery gives the line its first month-over-month read in the August report.</a:t>
             </a:r>
           </a:p>
         </p:txBody>
@@ -8661,7 +9012,7 @@
                 </a:solidFill>
                 <a:latin typeface="Georgia"/>
               </a:rPr>
-              <a:t>CROSS-CHANNEL PRIORITIES + NEXT STEPS</a:t>
+              <a:t>DIGITAL OUT-OF-HOME  ·  DELIVERY BY CITY</a:t>
             </a:r>
           </a:p>
         </p:txBody>
@@ -8720,7 +9071,7 @@
                 </a:solidFill>
                 <a:latin typeface="Georgia"/>
               </a:rPr>
-              <a:t>August priorities: scale the rebuilt structure, complete measurement, hold inventory quality.</a:t>
+              <a:t>Mexico City carried 59% of July delivery.</a:t>
             </a:r>
           </a:p>
         </p:txBody>
@@ -8834,7 +9185,3372 @@
                 </a:solidFill>
                 <a:latin typeface="Calibri"/>
               </a:rPr>
-              <a:t>14 / 14</a:t>
+              <a:t>14 / 16</a:t>
+            </a:r>
+          </a:p>
+        </p:txBody>
+      </p:sp>
+      <p:sp>
+        <p:nvSpPr>
+          <p:cNvPr id="10" name="Rectangle 9"/>
+          <p:cNvSpPr/>
+          <p:nvPr/>
+        </p:nvSpPr>
+        <p:spPr>
+          <a:xfrm>
+            <a:off x="457200" y="1691640"/>
+            <a:ext cx="1783080" cy="1005840"/>
+          </a:xfrm>
+          <a:prstGeom prst="rect">
+            <a:avLst/>
+          </a:prstGeom>
+          <a:solidFill>
+            <a:srgbClr val="FFFFFF"/>
+          </a:solidFill>
+          <a:ln w="9525">
+            <a:solidFill>
+              <a:srgbClr val="D0D4DC"/>
+            </a:solidFill>
+          </a:ln>
+          <a:effectLst/>
+        </p:spPr>
+        <p:style>
+          <a:lnRef idx="1">
+            <a:schemeClr val="accent1"/>
+          </a:lnRef>
+          <a:fillRef idx="3">
+            <a:schemeClr val="accent1"/>
+          </a:fillRef>
+          <a:effectRef idx="2">
+            <a:schemeClr val="accent1"/>
+          </a:effectRef>
+          <a:fontRef idx="minor">
+            <a:schemeClr val="lt1"/>
+          </a:fontRef>
+        </p:style>
+        <p:txBody>
+          <a:bodyPr rtlCol="0" anchor="ctr"/>
+          <a:lstStyle/>
+          <a:p>
+            <a:pPr algn="ctr"/>
+          </a:p>
+        </p:txBody>
+      </p:sp>
+      <p:sp>
+        <p:nvSpPr>
+          <p:cNvPr id="11" name="Rectangle 10"/>
+          <p:cNvSpPr/>
+          <p:nvPr/>
+        </p:nvSpPr>
+        <p:spPr>
+          <a:xfrm>
+            <a:off x="457200" y="1691640"/>
+            <a:ext cx="54864" cy="1005840"/>
+          </a:xfrm>
+          <a:prstGeom prst="rect">
+            <a:avLst/>
+          </a:prstGeom>
+          <a:solidFill>
+            <a:srgbClr val="F96167"/>
+          </a:solidFill>
+          <a:ln>
+            <a:noFill/>
+          </a:ln>
+          <a:effectLst/>
+        </p:spPr>
+        <p:style>
+          <a:lnRef idx="1">
+            <a:schemeClr val="accent1"/>
+          </a:lnRef>
+          <a:fillRef idx="3">
+            <a:schemeClr val="accent1"/>
+          </a:fillRef>
+          <a:effectRef idx="2">
+            <a:schemeClr val="accent1"/>
+          </a:effectRef>
+          <a:fontRef idx="minor">
+            <a:schemeClr val="lt1"/>
+          </a:fontRef>
+        </p:style>
+        <p:txBody>
+          <a:bodyPr rtlCol="0" anchor="ctr"/>
+          <a:lstStyle/>
+          <a:p>
+            <a:pPr algn="ctr"/>
+          </a:p>
+        </p:txBody>
+      </p:sp>
+      <p:sp>
+        <p:nvSpPr>
+          <p:cNvPr id="12" name="TextBox 11"/>
+          <p:cNvSpPr txBox="1"/>
+          <p:nvPr/>
+        </p:nvSpPr>
+        <p:spPr>
+          <a:xfrm>
+            <a:off x="640080" y="1737360"/>
+            <a:ext cx="1508760" cy="274320"/>
+          </a:xfrm>
+          <a:prstGeom prst="rect">
+            <a:avLst/>
+          </a:prstGeom>
+          <a:noFill/>
+        </p:spPr>
+        <p:txBody>
+          <a:bodyPr wrap="square" anchor="t" lIns="0" rIns="0" tIns="0" bIns="0">
+            <a:spAutoFit/>
+          </a:bodyPr>
+          <a:lstStyle/>
+          <a:p>
+            <a:pPr algn="l"/>
+            <a:r>
+              <a:rPr sz="800" b="1">
+                <a:solidFill>
+                  <a:srgbClr val="5A6072"/>
+                </a:solidFill>
+                <a:latin typeface="Calibri"/>
+              </a:rPr>
+              <a:t>MEXICO CITY</a:t>
+            </a:r>
+          </a:p>
+        </p:txBody>
+      </p:sp>
+      <p:sp>
+        <p:nvSpPr>
+          <p:cNvPr id="13" name="TextBox 12"/>
+          <p:cNvSpPr txBox="1"/>
+          <p:nvPr/>
+        </p:nvSpPr>
+        <p:spPr>
+          <a:xfrm>
+            <a:off x="640080" y="1984248"/>
+            <a:ext cx="1508760" cy="457200"/>
+          </a:xfrm>
+          <a:prstGeom prst="rect">
+            <a:avLst/>
+          </a:prstGeom>
+          <a:noFill/>
+        </p:spPr>
+        <p:txBody>
+          <a:bodyPr wrap="square" anchor="t" lIns="0" rIns="0" tIns="0" bIns="0">
+            <a:spAutoFit/>
+          </a:bodyPr>
+          <a:lstStyle/>
+          <a:p>
+            <a:pPr algn="l"/>
+            <a:r>
+              <a:rPr sz="1500" b="1">
+                <a:solidFill>
+                  <a:srgbClr val="1E2761"/>
+                </a:solidFill>
+                <a:latin typeface="Calibri"/>
+              </a:rPr>
+              <a:t>825,383</a:t>
+            </a:r>
+          </a:p>
+        </p:txBody>
+      </p:sp>
+      <p:sp>
+        <p:nvSpPr>
+          <p:cNvPr id="14" name="TextBox 13"/>
+          <p:cNvSpPr txBox="1"/>
+          <p:nvPr/>
+        </p:nvSpPr>
+        <p:spPr>
+          <a:xfrm>
+            <a:off x="640080" y="2441448"/>
+            <a:ext cx="1508760" cy="219456"/>
+          </a:xfrm>
+          <a:prstGeom prst="rect">
+            <a:avLst/>
+          </a:prstGeom>
+          <a:noFill/>
+        </p:spPr>
+        <p:txBody>
+          <a:bodyPr wrap="square" anchor="t" lIns="0" rIns="0" tIns="0" bIns="0">
+            <a:spAutoFit/>
+          </a:bodyPr>
+          <a:lstStyle/>
+          <a:p>
+            <a:pPr algn="l"/>
+            <a:r>
+              <a:rPr sz="800" b="0">
+                <a:solidFill>
+                  <a:srgbClr val="5A6072"/>
+                </a:solidFill>
+                <a:latin typeface="Calibri"/>
+              </a:rPr>
+              <a:t>459K reach · 59%</a:t>
+            </a:r>
+          </a:p>
+        </p:txBody>
+      </p:sp>
+      <p:sp>
+        <p:nvSpPr>
+          <p:cNvPr id="15" name="Rectangle 14"/>
+          <p:cNvSpPr/>
+          <p:nvPr/>
+        </p:nvSpPr>
+        <p:spPr>
+          <a:xfrm>
+            <a:off x="2359152" y="1691640"/>
+            <a:ext cx="1783080" cy="1005840"/>
+          </a:xfrm>
+          <a:prstGeom prst="rect">
+            <a:avLst/>
+          </a:prstGeom>
+          <a:solidFill>
+            <a:srgbClr val="FFFFFF"/>
+          </a:solidFill>
+          <a:ln w="9525">
+            <a:solidFill>
+              <a:srgbClr val="D0D4DC"/>
+            </a:solidFill>
+          </a:ln>
+          <a:effectLst/>
+        </p:spPr>
+        <p:style>
+          <a:lnRef idx="1">
+            <a:schemeClr val="accent1"/>
+          </a:lnRef>
+          <a:fillRef idx="3">
+            <a:schemeClr val="accent1"/>
+          </a:fillRef>
+          <a:effectRef idx="2">
+            <a:schemeClr val="accent1"/>
+          </a:effectRef>
+          <a:fontRef idx="minor">
+            <a:schemeClr val="lt1"/>
+          </a:fontRef>
+        </p:style>
+        <p:txBody>
+          <a:bodyPr rtlCol="0" anchor="ctr"/>
+          <a:lstStyle/>
+          <a:p>
+            <a:pPr algn="ctr"/>
+          </a:p>
+        </p:txBody>
+      </p:sp>
+      <p:sp>
+        <p:nvSpPr>
+          <p:cNvPr id="16" name="Rectangle 15"/>
+          <p:cNvSpPr/>
+          <p:nvPr/>
+        </p:nvSpPr>
+        <p:spPr>
+          <a:xfrm>
+            <a:off x="2359152" y="1691640"/>
+            <a:ext cx="54864" cy="1005840"/>
+          </a:xfrm>
+          <a:prstGeom prst="rect">
+            <a:avLst/>
+          </a:prstGeom>
+          <a:solidFill>
+            <a:srgbClr val="F96167"/>
+          </a:solidFill>
+          <a:ln>
+            <a:noFill/>
+          </a:ln>
+          <a:effectLst/>
+        </p:spPr>
+        <p:style>
+          <a:lnRef idx="1">
+            <a:schemeClr val="accent1"/>
+          </a:lnRef>
+          <a:fillRef idx="3">
+            <a:schemeClr val="accent1"/>
+          </a:fillRef>
+          <a:effectRef idx="2">
+            <a:schemeClr val="accent1"/>
+          </a:effectRef>
+          <a:fontRef idx="minor">
+            <a:schemeClr val="lt1"/>
+          </a:fontRef>
+        </p:style>
+        <p:txBody>
+          <a:bodyPr rtlCol="0" anchor="ctr"/>
+          <a:lstStyle/>
+          <a:p>
+            <a:pPr algn="ctr"/>
+          </a:p>
+        </p:txBody>
+      </p:sp>
+      <p:sp>
+        <p:nvSpPr>
+          <p:cNvPr id="17" name="TextBox 16"/>
+          <p:cNvSpPr txBox="1"/>
+          <p:nvPr/>
+        </p:nvSpPr>
+        <p:spPr>
+          <a:xfrm>
+            <a:off x="2542032" y="1737360"/>
+            <a:ext cx="1508760" cy="274320"/>
+          </a:xfrm>
+          <a:prstGeom prst="rect">
+            <a:avLst/>
+          </a:prstGeom>
+          <a:noFill/>
+        </p:spPr>
+        <p:txBody>
+          <a:bodyPr wrap="square" anchor="t" lIns="0" rIns="0" tIns="0" bIns="0">
+            <a:spAutoFit/>
+          </a:bodyPr>
+          <a:lstStyle/>
+          <a:p>
+            <a:pPr algn="l"/>
+            <a:r>
+              <a:rPr sz="800" b="1">
+                <a:solidFill>
+                  <a:srgbClr val="5A6072"/>
+                </a:solidFill>
+                <a:latin typeface="Calibri"/>
+              </a:rPr>
+              <a:t>GUADALAJARA</a:t>
+            </a:r>
+          </a:p>
+        </p:txBody>
+      </p:sp>
+      <p:sp>
+        <p:nvSpPr>
+          <p:cNvPr id="18" name="TextBox 17"/>
+          <p:cNvSpPr txBox="1"/>
+          <p:nvPr/>
+        </p:nvSpPr>
+        <p:spPr>
+          <a:xfrm>
+            <a:off x="2542032" y="1984248"/>
+            <a:ext cx="1508760" cy="457200"/>
+          </a:xfrm>
+          <a:prstGeom prst="rect">
+            <a:avLst/>
+          </a:prstGeom>
+          <a:noFill/>
+        </p:spPr>
+        <p:txBody>
+          <a:bodyPr wrap="square" anchor="t" lIns="0" rIns="0" tIns="0" bIns="0">
+            <a:spAutoFit/>
+          </a:bodyPr>
+          <a:lstStyle/>
+          <a:p>
+            <a:pPr algn="l"/>
+            <a:r>
+              <a:rPr sz="1500" b="1">
+                <a:solidFill>
+                  <a:srgbClr val="1E2761"/>
+                </a:solidFill>
+                <a:latin typeface="Calibri"/>
+              </a:rPr>
+              <a:t>314,817</a:t>
+            </a:r>
+          </a:p>
+        </p:txBody>
+      </p:sp>
+      <p:sp>
+        <p:nvSpPr>
+          <p:cNvPr id="19" name="TextBox 18"/>
+          <p:cNvSpPr txBox="1"/>
+          <p:nvPr/>
+        </p:nvSpPr>
+        <p:spPr>
+          <a:xfrm>
+            <a:off x="2542032" y="2441448"/>
+            <a:ext cx="1508760" cy="219456"/>
+          </a:xfrm>
+          <a:prstGeom prst="rect">
+            <a:avLst/>
+          </a:prstGeom>
+          <a:noFill/>
+        </p:spPr>
+        <p:txBody>
+          <a:bodyPr wrap="square" anchor="t" lIns="0" rIns="0" tIns="0" bIns="0">
+            <a:spAutoFit/>
+          </a:bodyPr>
+          <a:lstStyle/>
+          <a:p>
+            <a:pPr algn="l"/>
+            <a:r>
+              <a:rPr sz="800" b="0">
+                <a:solidFill>
+                  <a:srgbClr val="5A6072"/>
+                </a:solidFill>
+                <a:latin typeface="Calibri"/>
+              </a:rPr>
+              <a:t>175K reach · 22%</a:t>
+            </a:r>
+          </a:p>
+        </p:txBody>
+      </p:sp>
+      <p:sp>
+        <p:nvSpPr>
+          <p:cNvPr id="20" name="Rectangle 19"/>
+          <p:cNvSpPr/>
+          <p:nvPr/>
+        </p:nvSpPr>
+        <p:spPr>
+          <a:xfrm>
+            <a:off x="4261104" y="1691640"/>
+            <a:ext cx="1783080" cy="1005840"/>
+          </a:xfrm>
+          <a:prstGeom prst="rect">
+            <a:avLst/>
+          </a:prstGeom>
+          <a:solidFill>
+            <a:srgbClr val="FFFFFF"/>
+          </a:solidFill>
+          <a:ln w="9525">
+            <a:solidFill>
+              <a:srgbClr val="D0D4DC"/>
+            </a:solidFill>
+          </a:ln>
+          <a:effectLst/>
+        </p:spPr>
+        <p:style>
+          <a:lnRef idx="1">
+            <a:schemeClr val="accent1"/>
+          </a:lnRef>
+          <a:fillRef idx="3">
+            <a:schemeClr val="accent1"/>
+          </a:fillRef>
+          <a:effectRef idx="2">
+            <a:schemeClr val="accent1"/>
+          </a:effectRef>
+          <a:fontRef idx="minor">
+            <a:schemeClr val="lt1"/>
+          </a:fontRef>
+        </p:style>
+        <p:txBody>
+          <a:bodyPr rtlCol="0" anchor="ctr"/>
+          <a:lstStyle/>
+          <a:p>
+            <a:pPr algn="ctr"/>
+          </a:p>
+        </p:txBody>
+      </p:sp>
+      <p:sp>
+        <p:nvSpPr>
+          <p:cNvPr id="21" name="Rectangle 20"/>
+          <p:cNvSpPr/>
+          <p:nvPr/>
+        </p:nvSpPr>
+        <p:spPr>
+          <a:xfrm>
+            <a:off x="4261104" y="1691640"/>
+            <a:ext cx="54864" cy="1005840"/>
+          </a:xfrm>
+          <a:prstGeom prst="rect">
+            <a:avLst/>
+          </a:prstGeom>
+          <a:solidFill>
+            <a:srgbClr val="F96167"/>
+          </a:solidFill>
+          <a:ln>
+            <a:noFill/>
+          </a:ln>
+          <a:effectLst/>
+        </p:spPr>
+        <p:style>
+          <a:lnRef idx="1">
+            <a:schemeClr val="accent1"/>
+          </a:lnRef>
+          <a:fillRef idx="3">
+            <a:schemeClr val="accent1"/>
+          </a:fillRef>
+          <a:effectRef idx="2">
+            <a:schemeClr val="accent1"/>
+          </a:effectRef>
+          <a:fontRef idx="minor">
+            <a:schemeClr val="lt1"/>
+          </a:fontRef>
+        </p:style>
+        <p:txBody>
+          <a:bodyPr rtlCol="0" anchor="ctr"/>
+          <a:lstStyle/>
+          <a:p>
+            <a:pPr algn="ctr"/>
+          </a:p>
+        </p:txBody>
+      </p:sp>
+      <p:sp>
+        <p:nvSpPr>
+          <p:cNvPr id="22" name="TextBox 21"/>
+          <p:cNvSpPr txBox="1"/>
+          <p:nvPr/>
+        </p:nvSpPr>
+        <p:spPr>
+          <a:xfrm>
+            <a:off x="4443984" y="1737360"/>
+            <a:ext cx="1508760" cy="274320"/>
+          </a:xfrm>
+          <a:prstGeom prst="rect">
+            <a:avLst/>
+          </a:prstGeom>
+          <a:noFill/>
+        </p:spPr>
+        <p:txBody>
+          <a:bodyPr wrap="square" anchor="t" lIns="0" rIns="0" tIns="0" bIns="0">
+            <a:spAutoFit/>
+          </a:bodyPr>
+          <a:lstStyle/>
+          <a:p>
+            <a:pPr algn="l"/>
+            <a:r>
+              <a:rPr sz="800" b="1">
+                <a:solidFill>
+                  <a:srgbClr val="5A6072"/>
+                </a:solidFill>
+                <a:latin typeface="Calibri"/>
+              </a:rPr>
+              <a:t>MONTERREY</a:t>
+            </a:r>
+          </a:p>
+        </p:txBody>
+      </p:sp>
+      <p:sp>
+        <p:nvSpPr>
+          <p:cNvPr id="23" name="TextBox 22"/>
+          <p:cNvSpPr txBox="1"/>
+          <p:nvPr/>
+        </p:nvSpPr>
+        <p:spPr>
+          <a:xfrm>
+            <a:off x="4443984" y="1984248"/>
+            <a:ext cx="1508760" cy="457200"/>
+          </a:xfrm>
+          <a:prstGeom prst="rect">
+            <a:avLst/>
+          </a:prstGeom>
+          <a:noFill/>
+        </p:spPr>
+        <p:txBody>
+          <a:bodyPr wrap="square" anchor="t" lIns="0" rIns="0" tIns="0" bIns="0">
+            <a:spAutoFit/>
+          </a:bodyPr>
+          <a:lstStyle/>
+          <a:p>
+            <a:pPr algn="l"/>
+            <a:r>
+              <a:rPr sz="1500" b="1">
+                <a:solidFill>
+                  <a:srgbClr val="1E2761"/>
+                </a:solidFill>
+                <a:latin typeface="Calibri"/>
+              </a:rPr>
+              <a:t>265,905</a:t>
+            </a:r>
+          </a:p>
+        </p:txBody>
+      </p:sp>
+      <p:sp>
+        <p:nvSpPr>
+          <p:cNvPr id="24" name="TextBox 23"/>
+          <p:cNvSpPr txBox="1"/>
+          <p:nvPr/>
+        </p:nvSpPr>
+        <p:spPr>
+          <a:xfrm>
+            <a:off x="4443984" y="2441448"/>
+            <a:ext cx="1508760" cy="219456"/>
+          </a:xfrm>
+          <a:prstGeom prst="rect">
+            <a:avLst/>
+          </a:prstGeom>
+          <a:noFill/>
+        </p:spPr>
+        <p:txBody>
+          <a:bodyPr wrap="square" anchor="t" lIns="0" rIns="0" tIns="0" bIns="0">
+            <a:spAutoFit/>
+          </a:bodyPr>
+          <a:lstStyle/>
+          <a:p>
+            <a:pPr algn="l"/>
+            <a:r>
+              <a:rPr sz="800" b="0">
+                <a:solidFill>
+                  <a:srgbClr val="5A6072"/>
+                </a:solidFill>
+                <a:latin typeface="Calibri"/>
+              </a:rPr>
+              <a:t>148K reach · 19%</a:t>
+            </a:r>
+          </a:p>
+        </p:txBody>
+      </p:sp>
+      <p:sp>
+        <p:nvSpPr>
+          <p:cNvPr id="25" name="Rectangle 24"/>
+          <p:cNvSpPr/>
+          <p:nvPr/>
+        </p:nvSpPr>
+        <p:spPr>
+          <a:xfrm>
+            <a:off x="6163056" y="1691640"/>
+            <a:ext cx="1783080" cy="1005840"/>
+          </a:xfrm>
+          <a:prstGeom prst="rect">
+            <a:avLst/>
+          </a:prstGeom>
+          <a:solidFill>
+            <a:srgbClr val="FFFFFF"/>
+          </a:solidFill>
+          <a:ln w="9525">
+            <a:solidFill>
+              <a:srgbClr val="D0D4DC"/>
+            </a:solidFill>
+          </a:ln>
+          <a:effectLst/>
+        </p:spPr>
+        <p:style>
+          <a:lnRef idx="1">
+            <a:schemeClr val="accent1"/>
+          </a:lnRef>
+          <a:fillRef idx="3">
+            <a:schemeClr val="accent1"/>
+          </a:fillRef>
+          <a:effectRef idx="2">
+            <a:schemeClr val="accent1"/>
+          </a:effectRef>
+          <a:fontRef idx="minor">
+            <a:schemeClr val="lt1"/>
+          </a:fontRef>
+        </p:style>
+        <p:txBody>
+          <a:bodyPr rtlCol="0" anchor="ctr"/>
+          <a:lstStyle/>
+          <a:p>
+            <a:pPr algn="ctr"/>
+          </a:p>
+        </p:txBody>
+      </p:sp>
+      <p:sp>
+        <p:nvSpPr>
+          <p:cNvPr id="26" name="Rectangle 25"/>
+          <p:cNvSpPr/>
+          <p:nvPr/>
+        </p:nvSpPr>
+        <p:spPr>
+          <a:xfrm>
+            <a:off x="6163056" y="1691640"/>
+            <a:ext cx="54864" cy="1005840"/>
+          </a:xfrm>
+          <a:prstGeom prst="rect">
+            <a:avLst/>
+          </a:prstGeom>
+          <a:solidFill>
+            <a:srgbClr val="F96167"/>
+          </a:solidFill>
+          <a:ln>
+            <a:noFill/>
+          </a:ln>
+          <a:effectLst/>
+        </p:spPr>
+        <p:style>
+          <a:lnRef idx="1">
+            <a:schemeClr val="accent1"/>
+          </a:lnRef>
+          <a:fillRef idx="3">
+            <a:schemeClr val="accent1"/>
+          </a:fillRef>
+          <a:effectRef idx="2">
+            <a:schemeClr val="accent1"/>
+          </a:effectRef>
+          <a:fontRef idx="minor">
+            <a:schemeClr val="lt1"/>
+          </a:fontRef>
+        </p:style>
+        <p:txBody>
+          <a:bodyPr rtlCol="0" anchor="ctr"/>
+          <a:lstStyle/>
+          <a:p>
+            <a:pPr algn="ctr"/>
+          </a:p>
+        </p:txBody>
+      </p:sp>
+      <p:sp>
+        <p:nvSpPr>
+          <p:cNvPr id="27" name="TextBox 26"/>
+          <p:cNvSpPr txBox="1"/>
+          <p:nvPr/>
+        </p:nvSpPr>
+        <p:spPr>
+          <a:xfrm>
+            <a:off x="6345936" y="1737360"/>
+            <a:ext cx="1508760" cy="274320"/>
+          </a:xfrm>
+          <a:prstGeom prst="rect">
+            <a:avLst/>
+          </a:prstGeom>
+          <a:noFill/>
+        </p:spPr>
+        <p:txBody>
+          <a:bodyPr wrap="square" anchor="t" lIns="0" rIns="0" tIns="0" bIns="0">
+            <a:spAutoFit/>
+          </a:bodyPr>
+          <a:lstStyle/>
+          <a:p>
+            <a:pPr algn="l"/>
+            <a:r>
+              <a:rPr sz="800" b="1">
+                <a:solidFill>
+                  <a:srgbClr val="5A6072"/>
+                </a:solidFill>
+                <a:latin typeface="Calibri"/>
+              </a:rPr>
+              <a:t>TOTAL</a:t>
+            </a:r>
+          </a:p>
+        </p:txBody>
+      </p:sp>
+      <p:sp>
+        <p:nvSpPr>
+          <p:cNvPr id="28" name="TextBox 27"/>
+          <p:cNvSpPr txBox="1"/>
+          <p:nvPr/>
+        </p:nvSpPr>
+        <p:spPr>
+          <a:xfrm>
+            <a:off x="6345936" y="1984248"/>
+            <a:ext cx="1508760" cy="457200"/>
+          </a:xfrm>
+          <a:prstGeom prst="rect">
+            <a:avLst/>
+          </a:prstGeom>
+          <a:noFill/>
+        </p:spPr>
+        <p:txBody>
+          <a:bodyPr wrap="square" anchor="t" lIns="0" rIns="0" tIns="0" bIns="0">
+            <a:spAutoFit/>
+          </a:bodyPr>
+          <a:lstStyle/>
+          <a:p>
+            <a:pPr algn="l"/>
+            <a:r>
+              <a:rPr sz="1500" b="1">
+                <a:solidFill>
+                  <a:srgbClr val="1E2761"/>
+                </a:solidFill>
+                <a:latin typeface="Calibri"/>
+              </a:rPr>
+              <a:t>1,406,105</a:t>
+            </a:r>
+          </a:p>
+        </p:txBody>
+      </p:sp>
+      <p:sp>
+        <p:nvSpPr>
+          <p:cNvPr id="29" name="TextBox 28"/>
+          <p:cNvSpPr txBox="1"/>
+          <p:nvPr/>
+        </p:nvSpPr>
+        <p:spPr>
+          <a:xfrm>
+            <a:off x="6345936" y="2441448"/>
+            <a:ext cx="1508760" cy="219456"/>
+          </a:xfrm>
+          <a:prstGeom prst="rect">
+            <a:avLst/>
+          </a:prstGeom>
+          <a:noFill/>
+        </p:spPr>
+        <p:txBody>
+          <a:bodyPr wrap="square" anchor="t" lIns="0" rIns="0" tIns="0" bIns="0">
+            <a:spAutoFit/>
+          </a:bodyPr>
+          <a:lstStyle/>
+          <a:p>
+            <a:pPr algn="l"/>
+            <a:r>
+              <a:rPr sz="800" b="0">
+                <a:solidFill>
+                  <a:srgbClr val="5A6072"/>
+                </a:solidFill>
+                <a:latin typeface="Calibri"/>
+              </a:rPr>
+              <a:t>781K reach · 100%</a:t>
+            </a:r>
+          </a:p>
+        </p:txBody>
+      </p:sp>
+      <p:graphicFrame>
+        <p:nvGraphicFramePr>
+          <p:cNvPr id="30" name="Table 29"/>
+          <p:cNvGraphicFramePr>
+            <a:graphicFrameLocks noGrp="1"/>
+          </p:cNvGraphicFramePr>
+          <p:nvPr/>
+        </p:nvGraphicFramePr>
+        <p:xfrm>
+          <a:off x="457200" y="3063240"/>
+          <a:ext cx="6766560" cy="2011680"/>
+        </p:xfrm>
+        <a:graphic>
+          <a:graphicData uri="http://schemas.openxmlformats.org/drawingml/2006/table">
+            <a:tbl>
+              <a:tblPr>
+                <a:tableStyleId>{5C22544A-7EE6-4342-B048-85BDC9FD1C3A}</a:tableStyleId>
+              </a:tblPr>
+              <a:tblGrid>
+                <a:gridCol w="1645920"/>
+                <a:gridCol w="1188720"/>
+                <a:gridCol w="1463040"/>
+                <a:gridCol w="1371600"/>
+                <a:gridCol w="1097280"/>
+              </a:tblGrid>
+              <a:tr h="402336">
+                <a:tc>
+                  <a:txBody>
+                    <a:bodyPr/>
+                    <a:lstStyle/>
+                    <a:p>
+                      <a:pPr algn="l"/>
+                      <a:r>
+                        <a:rPr sz="850" b="1">
+                          <a:solidFill>
+                            <a:srgbClr val="FFFFFF"/>
+                          </a:solidFill>
+                          <a:latin typeface="Calibri"/>
+                        </a:rPr>
+                        <a:t>City</a:t>
+                      </a:r>
+                    </a:p>
+                  </a:txBody>
+                  <a:tcPr marL="54864" marR="54864" marT="27432" marB="27432">
+                    <a:solidFill>
+                      <a:srgbClr val="1E2761"/>
+                    </a:solidFill>
+                  </a:tcPr>
+                </a:tc>
+                <a:tc>
+                  <a:txBody>
+                    <a:bodyPr/>
+                    <a:lstStyle/>
+                    <a:p>
+                      <a:pPr algn="r"/>
+                      <a:r>
+                        <a:rPr sz="850" b="1">
+                          <a:solidFill>
+                            <a:srgbClr val="FFFFFF"/>
+                          </a:solidFill>
+                          <a:latin typeface="Calibri"/>
+                        </a:rPr>
+                        <a:t>Spend</a:t>
+                      </a:r>
+                    </a:p>
+                  </a:txBody>
+                  <a:tcPr marL="54864" marR="54864" marT="27432" marB="27432">
+                    <a:solidFill>
+                      <a:srgbClr val="1E2761"/>
+                    </a:solidFill>
+                  </a:tcPr>
+                </a:tc>
+                <a:tc>
+                  <a:txBody>
+                    <a:bodyPr/>
+                    <a:lstStyle/>
+                    <a:p>
+                      <a:pPr algn="r"/>
+                      <a:r>
+                        <a:rPr sz="850" b="1">
+                          <a:solidFill>
+                            <a:srgbClr val="FFFFFF"/>
+                          </a:solidFill>
+                          <a:latin typeface="Calibri"/>
+                        </a:rPr>
+                        <a:t>Impressions</a:t>
+                      </a:r>
+                    </a:p>
+                  </a:txBody>
+                  <a:tcPr marL="54864" marR="54864" marT="27432" marB="27432">
+                    <a:solidFill>
+                      <a:srgbClr val="1E2761"/>
+                    </a:solidFill>
+                  </a:tcPr>
+                </a:tc>
+                <a:tc>
+                  <a:txBody>
+                    <a:bodyPr/>
+                    <a:lstStyle/>
+                    <a:p>
+                      <a:pPr algn="r"/>
+                      <a:r>
+                        <a:rPr sz="850" b="1">
+                          <a:solidFill>
+                            <a:srgbClr val="FFFFFF"/>
+                          </a:solidFill>
+                          <a:latin typeface="Calibri"/>
+                        </a:rPr>
+                        <a:t>Est. reach</a:t>
+                      </a:r>
+                    </a:p>
+                  </a:txBody>
+                  <a:tcPr marL="54864" marR="54864" marT="27432" marB="27432">
+                    <a:solidFill>
+                      <a:srgbClr val="1E2761"/>
+                    </a:solidFill>
+                  </a:tcPr>
+                </a:tc>
+                <a:tc>
+                  <a:txBody>
+                    <a:bodyPr/>
+                    <a:lstStyle/>
+                    <a:p>
+                      <a:pPr algn="r"/>
+                      <a:r>
+                        <a:rPr sz="850" b="1">
+                          <a:solidFill>
+                            <a:srgbClr val="FFFFFF"/>
+                          </a:solidFill>
+                          <a:latin typeface="Calibri"/>
+                        </a:rPr>
+                        <a:t>Share</a:t>
+                      </a:r>
+                    </a:p>
+                  </a:txBody>
+                  <a:tcPr marL="54864" marR="54864" marT="27432" marB="27432">
+                    <a:solidFill>
+                      <a:srgbClr val="1E2761"/>
+                    </a:solidFill>
+                  </a:tcPr>
+                </a:tc>
+              </a:tr>
+              <a:tr h="402336">
+                <a:tc>
+                  <a:txBody>
+                    <a:bodyPr/>
+                    <a:lstStyle/>
+                    <a:p>
+                      <a:pPr algn="l"/>
+                      <a:r>
+                        <a:rPr sz="850" b="1">
+                          <a:solidFill>
+                            <a:srgbClr val="2B3147"/>
+                          </a:solidFill>
+                          <a:latin typeface="Calibri"/>
+                        </a:rPr>
+                        <a:t>Mexico City</a:t>
+                      </a:r>
+                    </a:p>
+                  </a:txBody>
+                  <a:tcPr marL="54864" marR="54864" marT="27432" marB="27432">
+                    <a:solidFill>
+                      <a:srgbClr val="FFFFFF"/>
+                    </a:solidFill>
+                  </a:tcPr>
+                </a:tc>
+                <a:tc>
+                  <a:txBody>
+                    <a:bodyPr/>
+                    <a:lstStyle/>
+                    <a:p>
+                      <a:pPr algn="r"/>
+                      <a:r>
+                        <a:rPr sz="850" b="0">
+                          <a:solidFill>
+                            <a:srgbClr val="2B3147"/>
+                          </a:solidFill>
+                          <a:latin typeface="Calibri"/>
+                        </a:rPr>
+                        <a:t>$15,724</a:t>
+                      </a:r>
+                    </a:p>
+                  </a:txBody>
+                  <a:tcPr marL="54864" marR="54864" marT="27432" marB="27432">
+                    <a:solidFill>
+                      <a:srgbClr val="FFFFFF"/>
+                    </a:solidFill>
+                  </a:tcPr>
+                </a:tc>
+                <a:tc>
+                  <a:txBody>
+                    <a:bodyPr/>
+                    <a:lstStyle/>
+                    <a:p>
+                      <a:pPr algn="r"/>
+                      <a:r>
+                        <a:rPr sz="850" b="0">
+                          <a:solidFill>
+                            <a:srgbClr val="2B3147"/>
+                          </a:solidFill>
+                          <a:latin typeface="Calibri"/>
+                        </a:rPr>
+                        <a:t>825,383</a:t>
+                      </a:r>
+                    </a:p>
+                  </a:txBody>
+                  <a:tcPr marL="54864" marR="54864" marT="27432" marB="27432">
+                    <a:solidFill>
+                      <a:srgbClr val="FFFFFF"/>
+                    </a:solidFill>
+                  </a:tcPr>
+                </a:tc>
+                <a:tc>
+                  <a:txBody>
+                    <a:bodyPr/>
+                    <a:lstStyle/>
+                    <a:p>
+                      <a:pPr algn="r"/>
+                      <a:r>
+                        <a:rPr sz="850" b="0">
+                          <a:solidFill>
+                            <a:srgbClr val="2B3147"/>
+                          </a:solidFill>
+                          <a:latin typeface="Calibri"/>
+                        </a:rPr>
+                        <a:t>458,546</a:t>
+                      </a:r>
+                    </a:p>
+                  </a:txBody>
+                  <a:tcPr marL="54864" marR="54864" marT="27432" marB="27432">
+                    <a:solidFill>
+                      <a:srgbClr val="FFFFFF"/>
+                    </a:solidFill>
+                  </a:tcPr>
+                </a:tc>
+                <a:tc>
+                  <a:txBody>
+                    <a:bodyPr/>
+                    <a:lstStyle/>
+                    <a:p>
+                      <a:pPr algn="r"/>
+                      <a:r>
+                        <a:rPr sz="850" b="0">
+                          <a:solidFill>
+                            <a:srgbClr val="2B3147"/>
+                          </a:solidFill>
+                          <a:latin typeface="Calibri"/>
+                        </a:rPr>
+                        <a:t>58.7%</a:t>
+                      </a:r>
+                    </a:p>
+                  </a:txBody>
+                  <a:tcPr marL="54864" marR="54864" marT="27432" marB="27432">
+                    <a:solidFill>
+                      <a:srgbClr val="FFFFFF"/>
+                    </a:solidFill>
+                  </a:tcPr>
+                </a:tc>
+              </a:tr>
+              <a:tr h="402336">
+                <a:tc>
+                  <a:txBody>
+                    <a:bodyPr/>
+                    <a:lstStyle/>
+                    <a:p>
+                      <a:pPr algn="l"/>
+                      <a:r>
+                        <a:rPr sz="850" b="1">
+                          <a:solidFill>
+                            <a:srgbClr val="2B3147"/>
+                          </a:solidFill>
+                          <a:latin typeface="Calibri"/>
+                        </a:rPr>
+                        <a:t>Guadalajara</a:t>
+                      </a:r>
+                    </a:p>
+                  </a:txBody>
+                  <a:tcPr marL="54864" marR="54864" marT="27432" marB="27432">
+                    <a:solidFill>
+                      <a:srgbClr val="F9FAFC"/>
+                    </a:solidFill>
+                  </a:tcPr>
+                </a:tc>
+                <a:tc>
+                  <a:txBody>
+                    <a:bodyPr/>
+                    <a:lstStyle/>
+                    <a:p>
+                      <a:pPr algn="r"/>
+                      <a:r>
+                        <a:rPr sz="850" b="0">
+                          <a:solidFill>
+                            <a:srgbClr val="2B3147"/>
+                          </a:solidFill>
+                          <a:latin typeface="Calibri"/>
+                        </a:rPr>
+                        <a:t>$6,040</a:t>
+                      </a:r>
+                    </a:p>
+                  </a:txBody>
+                  <a:tcPr marL="54864" marR="54864" marT="27432" marB="27432">
+                    <a:solidFill>
+                      <a:srgbClr val="F9FAFC"/>
+                    </a:solidFill>
+                  </a:tcPr>
+                </a:tc>
+                <a:tc>
+                  <a:txBody>
+                    <a:bodyPr/>
+                    <a:lstStyle/>
+                    <a:p>
+                      <a:pPr algn="r"/>
+                      <a:r>
+                        <a:rPr sz="850" b="0">
+                          <a:solidFill>
+                            <a:srgbClr val="2B3147"/>
+                          </a:solidFill>
+                          <a:latin typeface="Calibri"/>
+                        </a:rPr>
+                        <a:t>314,817</a:t>
+                      </a:r>
+                    </a:p>
+                  </a:txBody>
+                  <a:tcPr marL="54864" marR="54864" marT="27432" marB="27432">
+                    <a:solidFill>
+                      <a:srgbClr val="F9FAFC"/>
+                    </a:solidFill>
+                  </a:tcPr>
+                </a:tc>
+                <a:tc>
+                  <a:txBody>
+                    <a:bodyPr/>
+                    <a:lstStyle/>
+                    <a:p>
+                      <a:pPr algn="r"/>
+                      <a:r>
+                        <a:rPr sz="850" b="0">
+                          <a:solidFill>
+                            <a:srgbClr val="2B3147"/>
+                          </a:solidFill>
+                          <a:latin typeface="Calibri"/>
+                        </a:rPr>
+                        <a:t>174,898</a:t>
+                      </a:r>
+                    </a:p>
+                  </a:txBody>
+                  <a:tcPr marL="54864" marR="54864" marT="27432" marB="27432">
+                    <a:solidFill>
+                      <a:srgbClr val="F9FAFC"/>
+                    </a:solidFill>
+                  </a:tcPr>
+                </a:tc>
+                <a:tc>
+                  <a:txBody>
+                    <a:bodyPr/>
+                    <a:lstStyle/>
+                    <a:p>
+                      <a:pPr algn="r"/>
+                      <a:r>
+                        <a:rPr sz="850" b="0">
+                          <a:solidFill>
+                            <a:srgbClr val="2B3147"/>
+                          </a:solidFill>
+                          <a:latin typeface="Calibri"/>
+                        </a:rPr>
+                        <a:t>22.4%</a:t>
+                      </a:r>
+                    </a:p>
+                  </a:txBody>
+                  <a:tcPr marL="54864" marR="54864" marT="27432" marB="27432">
+                    <a:solidFill>
+                      <a:srgbClr val="F9FAFC"/>
+                    </a:solidFill>
+                  </a:tcPr>
+                </a:tc>
+              </a:tr>
+              <a:tr h="402336">
+                <a:tc>
+                  <a:txBody>
+                    <a:bodyPr/>
+                    <a:lstStyle/>
+                    <a:p>
+                      <a:pPr algn="l"/>
+                      <a:r>
+                        <a:rPr sz="850" b="1">
+                          <a:solidFill>
+                            <a:srgbClr val="2B3147"/>
+                          </a:solidFill>
+                          <a:latin typeface="Calibri"/>
+                        </a:rPr>
+                        <a:t>Monterrey</a:t>
+                      </a:r>
+                    </a:p>
+                  </a:txBody>
+                  <a:tcPr marL="54864" marR="54864" marT="27432" marB="27432">
+                    <a:solidFill>
+                      <a:srgbClr val="FFFFFF"/>
+                    </a:solidFill>
+                  </a:tcPr>
+                </a:tc>
+                <a:tc>
+                  <a:txBody>
+                    <a:bodyPr/>
+                    <a:lstStyle/>
+                    <a:p>
+                      <a:pPr algn="r"/>
+                      <a:r>
+                        <a:rPr sz="850" b="0">
+                          <a:solidFill>
+                            <a:srgbClr val="2B3147"/>
+                          </a:solidFill>
+                          <a:latin typeface="Calibri"/>
+                        </a:rPr>
+                        <a:t>$5,101</a:t>
+                      </a:r>
+                    </a:p>
+                  </a:txBody>
+                  <a:tcPr marL="54864" marR="54864" marT="27432" marB="27432">
+                    <a:solidFill>
+                      <a:srgbClr val="FFFFFF"/>
+                    </a:solidFill>
+                  </a:tcPr>
+                </a:tc>
+                <a:tc>
+                  <a:txBody>
+                    <a:bodyPr/>
+                    <a:lstStyle/>
+                    <a:p>
+                      <a:pPr algn="r"/>
+                      <a:r>
+                        <a:rPr sz="850" b="0">
+                          <a:solidFill>
+                            <a:srgbClr val="2B3147"/>
+                          </a:solidFill>
+                          <a:latin typeface="Calibri"/>
+                        </a:rPr>
+                        <a:t>265,905</a:t>
+                      </a:r>
+                    </a:p>
+                  </a:txBody>
+                  <a:tcPr marL="54864" marR="54864" marT="27432" marB="27432">
+                    <a:solidFill>
+                      <a:srgbClr val="FFFFFF"/>
+                    </a:solidFill>
+                  </a:tcPr>
+                </a:tc>
+                <a:tc>
+                  <a:txBody>
+                    <a:bodyPr/>
+                    <a:lstStyle/>
+                    <a:p>
+                      <a:pPr algn="r"/>
+                      <a:r>
+                        <a:rPr sz="850" b="0">
+                          <a:solidFill>
+                            <a:srgbClr val="2B3147"/>
+                          </a:solidFill>
+                          <a:latin typeface="Calibri"/>
+                        </a:rPr>
+                        <a:t>147,725</a:t>
+                      </a:r>
+                    </a:p>
+                  </a:txBody>
+                  <a:tcPr marL="54864" marR="54864" marT="27432" marB="27432">
+                    <a:solidFill>
+                      <a:srgbClr val="FFFFFF"/>
+                    </a:solidFill>
+                  </a:tcPr>
+                </a:tc>
+                <a:tc>
+                  <a:txBody>
+                    <a:bodyPr/>
+                    <a:lstStyle/>
+                    <a:p>
+                      <a:pPr algn="r"/>
+                      <a:r>
+                        <a:rPr sz="850" b="0">
+                          <a:solidFill>
+                            <a:srgbClr val="2B3147"/>
+                          </a:solidFill>
+                          <a:latin typeface="Calibri"/>
+                        </a:rPr>
+                        <a:t>18.9%</a:t>
+                      </a:r>
+                    </a:p>
+                  </a:txBody>
+                  <a:tcPr marL="54864" marR="54864" marT="27432" marB="27432">
+                    <a:solidFill>
+                      <a:srgbClr val="FFFFFF"/>
+                    </a:solidFill>
+                  </a:tcPr>
+                </a:tc>
+              </a:tr>
+              <a:tr h="402336">
+                <a:tc>
+                  <a:txBody>
+                    <a:bodyPr/>
+                    <a:lstStyle/>
+                    <a:p>
+                      <a:pPr algn="l"/>
+                      <a:r>
+                        <a:rPr sz="850" b="1">
+                          <a:solidFill>
+                            <a:srgbClr val="1E2761"/>
+                          </a:solidFill>
+                          <a:latin typeface="Calibri"/>
+                        </a:rPr>
+                        <a:t>Total</a:t>
+                      </a:r>
+                    </a:p>
+                  </a:txBody>
+                  <a:tcPr marL="54864" marR="54864" marT="27432" marB="27432">
+                    <a:solidFill>
+                      <a:srgbClr val="CADCFC"/>
+                    </a:solidFill>
+                  </a:tcPr>
+                </a:tc>
+                <a:tc>
+                  <a:txBody>
+                    <a:bodyPr/>
+                    <a:lstStyle/>
+                    <a:p>
+                      <a:pPr algn="r"/>
+                      <a:r>
+                        <a:rPr sz="850" b="1">
+                          <a:solidFill>
+                            <a:srgbClr val="1E2761"/>
+                          </a:solidFill>
+                          <a:latin typeface="Calibri"/>
+                        </a:rPr>
+                        <a:t>$26,865</a:t>
+                      </a:r>
+                    </a:p>
+                  </a:txBody>
+                  <a:tcPr marL="54864" marR="54864" marT="27432" marB="27432">
+                    <a:solidFill>
+                      <a:srgbClr val="CADCFC"/>
+                    </a:solidFill>
+                  </a:tcPr>
+                </a:tc>
+                <a:tc>
+                  <a:txBody>
+                    <a:bodyPr/>
+                    <a:lstStyle/>
+                    <a:p>
+                      <a:pPr algn="r"/>
+                      <a:r>
+                        <a:rPr sz="850" b="1">
+                          <a:solidFill>
+                            <a:srgbClr val="1E2761"/>
+                          </a:solidFill>
+                          <a:latin typeface="Calibri"/>
+                        </a:rPr>
+                        <a:t>1,406,105</a:t>
+                      </a:r>
+                    </a:p>
+                  </a:txBody>
+                  <a:tcPr marL="54864" marR="54864" marT="27432" marB="27432">
+                    <a:solidFill>
+                      <a:srgbClr val="CADCFC"/>
+                    </a:solidFill>
+                  </a:tcPr>
+                </a:tc>
+                <a:tc>
+                  <a:txBody>
+                    <a:bodyPr/>
+                    <a:lstStyle/>
+                    <a:p>
+                      <a:pPr algn="r"/>
+                      <a:r>
+                        <a:rPr sz="850" b="1">
+                          <a:solidFill>
+                            <a:srgbClr val="1E2761"/>
+                          </a:solidFill>
+                          <a:latin typeface="Calibri"/>
+                        </a:rPr>
+                        <a:t>781,169</a:t>
+                      </a:r>
+                    </a:p>
+                  </a:txBody>
+                  <a:tcPr marL="54864" marR="54864" marT="27432" marB="27432">
+                    <a:solidFill>
+                      <a:srgbClr val="CADCFC"/>
+                    </a:solidFill>
+                  </a:tcPr>
+                </a:tc>
+                <a:tc>
+                  <a:txBody>
+                    <a:bodyPr/>
+                    <a:lstStyle/>
+                    <a:p>
+                      <a:pPr algn="r"/>
+                      <a:r>
+                        <a:rPr sz="850" b="1">
+                          <a:solidFill>
+                            <a:srgbClr val="1E2761"/>
+                          </a:solidFill>
+                          <a:latin typeface="Calibri"/>
+                        </a:rPr>
+                        <a:t>100%</a:t>
+                      </a:r>
+                    </a:p>
+                  </a:txBody>
+                  <a:tcPr marL="54864" marR="54864" marT="27432" marB="27432">
+                    <a:solidFill>
+                      <a:srgbClr val="CADCFC"/>
+                    </a:solidFill>
+                  </a:tcPr>
+                </a:tc>
+              </a:tr>
+            </a:tbl>
+          </a:graphicData>
+        </a:graphic>
+      </p:graphicFrame>
+      <p:sp>
+        <p:nvSpPr>
+          <p:cNvPr id="31" name="TextBox 30"/>
+          <p:cNvSpPr txBox="1"/>
+          <p:nvPr/>
+        </p:nvSpPr>
+        <p:spPr>
+          <a:xfrm>
+            <a:off x="457200" y="5212080"/>
+            <a:ext cx="6766560" cy="457200"/>
+          </a:xfrm>
+          <a:prstGeom prst="rect">
+            <a:avLst/>
+          </a:prstGeom>
+          <a:noFill/>
+        </p:spPr>
+        <p:txBody>
+          <a:bodyPr wrap="square" anchor="t" lIns="0" rIns="0" tIns="0" bIns="0">
+            <a:spAutoFit/>
+          </a:bodyPr>
+          <a:lstStyle/>
+          <a:p>
+            <a:pPr algn="l"/>
+            <a:r>
+              <a:rPr sz="750" b="0">
+                <a:solidFill>
+                  <a:srgbClr val="5A6072"/>
+                </a:solidFill>
+                <a:latin typeface="Calibri"/>
+              </a:rPr>
+              <a:t>Impressions are opportunities to see. Estimated reach applies an average frequency of 1.8 to impressions, the same model as the June report. Spend per the client budget tracker; share is the impression share.</a:t>
+            </a:r>
+          </a:p>
+        </p:txBody>
+      </p:sp>
+      <p:sp>
+        <p:nvSpPr>
+          <p:cNvPr id="32" name="Rectangle 31"/>
+          <p:cNvSpPr/>
+          <p:nvPr/>
+        </p:nvSpPr>
+        <p:spPr>
+          <a:xfrm>
+            <a:off x="7406640" y="3063240"/>
+            <a:ext cx="4297680" cy="2606040"/>
+          </a:xfrm>
+          <a:prstGeom prst="rect">
+            <a:avLst/>
+          </a:prstGeom>
+          <a:solidFill>
+            <a:srgbClr val="FFFFFF"/>
+          </a:solidFill>
+          <a:ln w="9525">
+            <a:solidFill>
+              <a:srgbClr val="D0D4DC"/>
+            </a:solidFill>
+          </a:ln>
+          <a:effectLst/>
+        </p:spPr>
+        <p:style>
+          <a:lnRef idx="1">
+            <a:schemeClr val="accent1"/>
+          </a:lnRef>
+          <a:fillRef idx="3">
+            <a:schemeClr val="accent1"/>
+          </a:fillRef>
+          <a:effectRef idx="2">
+            <a:schemeClr val="accent1"/>
+          </a:effectRef>
+          <a:fontRef idx="minor">
+            <a:schemeClr val="lt1"/>
+          </a:fontRef>
+        </p:style>
+        <p:txBody>
+          <a:bodyPr rtlCol="0" anchor="ctr"/>
+          <a:lstStyle/>
+          <a:p>
+            <a:pPr algn="ctr"/>
+          </a:p>
+        </p:txBody>
+      </p:sp>
+      <p:sp>
+        <p:nvSpPr>
+          <p:cNvPr id="33" name="Rectangle 32"/>
+          <p:cNvSpPr/>
+          <p:nvPr/>
+        </p:nvSpPr>
+        <p:spPr>
+          <a:xfrm>
+            <a:off x="7406640" y="3063240"/>
+            <a:ext cx="64008" cy="2606040"/>
+          </a:xfrm>
+          <a:prstGeom prst="rect">
+            <a:avLst/>
+          </a:prstGeom>
+          <a:solidFill>
+            <a:srgbClr val="2E7D57"/>
+          </a:solidFill>
+          <a:ln>
+            <a:noFill/>
+          </a:ln>
+          <a:effectLst/>
+        </p:spPr>
+        <p:style>
+          <a:lnRef idx="1">
+            <a:schemeClr val="accent1"/>
+          </a:lnRef>
+          <a:fillRef idx="3">
+            <a:schemeClr val="accent1"/>
+          </a:fillRef>
+          <a:effectRef idx="2">
+            <a:schemeClr val="accent1"/>
+          </a:effectRef>
+          <a:fontRef idx="minor">
+            <a:schemeClr val="lt1"/>
+          </a:fontRef>
+        </p:style>
+        <p:txBody>
+          <a:bodyPr rtlCol="0" anchor="ctr"/>
+          <a:lstStyle/>
+          <a:p>
+            <a:pPr algn="ctr"/>
+          </a:p>
+        </p:txBody>
+      </p:sp>
+      <p:sp>
+        <p:nvSpPr>
+          <p:cNvPr id="34" name="TextBox 33"/>
+          <p:cNvSpPr txBox="1"/>
+          <p:nvPr/>
+        </p:nvSpPr>
+        <p:spPr>
+          <a:xfrm>
+            <a:off x="7626096" y="3227832"/>
+            <a:ext cx="3895344" cy="274320"/>
+          </a:xfrm>
+          <a:prstGeom prst="rect">
+            <a:avLst/>
+          </a:prstGeom>
+          <a:noFill/>
+        </p:spPr>
+        <p:txBody>
+          <a:bodyPr wrap="square" anchor="t" lIns="0" rIns="0" tIns="0" bIns="0">
+            <a:spAutoFit/>
+          </a:bodyPr>
+          <a:lstStyle/>
+          <a:p>
+            <a:pPr algn="l"/>
+            <a:r>
+              <a:rPr sz="1000" b="1">
+                <a:solidFill>
+                  <a:srgbClr val="1E2761"/>
+                </a:solidFill>
+                <a:latin typeface="Georgia"/>
+              </a:rPr>
+              <a:t>WHAT THE DATA SHOWS</a:t>
+            </a:r>
+          </a:p>
+        </p:txBody>
+      </p:sp>
+      <p:sp>
+        <p:nvSpPr>
+          <p:cNvPr id="35" name="TextBox 34"/>
+          <p:cNvSpPr txBox="1"/>
+          <p:nvPr/>
+        </p:nvSpPr>
+        <p:spPr>
+          <a:xfrm>
+            <a:off x="7626096" y="3566160"/>
+            <a:ext cx="3895344" cy="1920240"/>
+          </a:xfrm>
+          <a:prstGeom prst="rect">
+            <a:avLst/>
+          </a:prstGeom>
+          <a:noFill/>
+        </p:spPr>
+        <p:txBody>
+          <a:bodyPr wrap="square" anchor="t" lIns="0" rIns="0" tIns="0" bIns="0">
+            <a:spAutoFit/>
+          </a:bodyPr>
+          <a:lstStyle/>
+          <a:p>
+            <a:pPr algn="l"/>
+            <a:r>
+              <a:rPr sz="950" b="0">
+                <a:solidFill>
+                  <a:srgbClr val="2B3147"/>
+                </a:solidFill>
+                <a:latin typeface="Calibri"/>
+              </a:rPr>
+              <a:t>Delivery concentrated where the audience is largest: Mexico City took 59% of impressions at the same CPM as the other markets.</a:t>
+            </a:r>
+          </a:p>
+          <a:p>
+            <a:pPr algn="l">
+              <a:spcBef>
+                <a:spcPts val="600"/>
+              </a:spcBef>
+            </a:pPr>
+            <a:r>
+              <a:rPr sz="950" b="0">
+                <a:solidFill>
+                  <a:srgbClr val="2B3147"/>
+                </a:solidFill>
+                <a:latin typeface="Calibri"/>
+              </a:rPr>
+              <a:t>All three markets delivered the full month with no gaps in the daily record.</a:t>
+            </a:r>
+          </a:p>
+        </p:txBody>
+      </p:sp>
+    </p:spTree>
+  </p:cSld>
+  <p:clrMapOvr>
+    <a:masterClrMapping/>
+  </p:clrMapOvr>
+</p:sld>
+</file>
+
+<file path=ppt/slides/slide15.xml><?xml version="1.0" encoding="utf-8"?>
+<p:sld xmlns:a="http://schemas.openxmlformats.org/drawingml/2006/main" xmlns:p="http://schemas.openxmlformats.org/presentationml/2006/main" xmlns:r="http://schemas.openxmlformats.org/officeDocument/2006/relationships">
+  <p:cSld>
+    <p:spTree>
+      <p:nvGrpSpPr>
+        <p:cNvPr id="1" name=""/>
+        <p:cNvGrpSpPr/>
+        <p:nvPr/>
+      </p:nvGrpSpPr>
+      <p:grpSpPr/>
+      <p:sp>
+        <p:nvSpPr>
+          <p:cNvPr id="2" name="Rectangle 1"/>
+          <p:cNvSpPr/>
+          <p:nvPr/>
+        </p:nvSpPr>
+        <p:spPr>
+          <a:xfrm>
+            <a:off x="0" y="0"/>
+            <a:ext cx="12191695" cy="630936"/>
+          </a:xfrm>
+          <a:prstGeom prst="rect">
+            <a:avLst/>
+          </a:prstGeom>
+          <a:solidFill>
+            <a:srgbClr val="1E2761"/>
+          </a:solidFill>
+          <a:ln>
+            <a:noFill/>
+          </a:ln>
+          <a:effectLst/>
+        </p:spPr>
+        <p:style>
+          <a:lnRef idx="1">
+            <a:schemeClr val="accent1"/>
+          </a:lnRef>
+          <a:fillRef idx="3">
+            <a:schemeClr val="accent1"/>
+          </a:fillRef>
+          <a:effectRef idx="2">
+            <a:schemeClr val="accent1"/>
+          </a:effectRef>
+          <a:fontRef idx="minor">
+            <a:schemeClr val="lt1"/>
+          </a:fontRef>
+        </p:style>
+        <p:txBody>
+          <a:bodyPr rtlCol="0" anchor="ctr"/>
+          <a:lstStyle/>
+          <a:p>
+            <a:pPr algn="ctr"/>
+          </a:p>
+        </p:txBody>
+      </p:sp>
+      <p:sp>
+        <p:nvSpPr>
+          <p:cNvPr id="3" name="Rectangle 2"/>
+          <p:cNvSpPr/>
+          <p:nvPr/>
+        </p:nvSpPr>
+        <p:spPr>
+          <a:xfrm>
+            <a:off x="0" y="630936"/>
+            <a:ext cx="12191695" cy="45720"/>
+          </a:xfrm>
+          <a:prstGeom prst="rect">
+            <a:avLst/>
+          </a:prstGeom>
+          <a:solidFill>
+            <a:srgbClr val="F96167"/>
+          </a:solidFill>
+          <a:ln>
+            <a:noFill/>
+          </a:ln>
+          <a:effectLst/>
+        </p:spPr>
+        <p:style>
+          <a:lnRef idx="1">
+            <a:schemeClr val="accent1"/>
+          </a:lnRef>
+          <a:fillRef idx="3">
+            <a:schemeClr val="accent1"/>
+          </a:fillRef>
+          <a:effectRef idx="2">
+            <a:schemeClr val="accent1"/>
+          </a:effectRef>
+          <a:fontRef idx="minor">
+            <a:schemeClr val="lt1"/>
+          </a:fontRef>
+        </p:style>
+        <p:txBody>
+          <a:bodyPr rtlCol="0" anchor="ctr"/>
+          <a:lstStyle/>
+          <a:p>
+            <a:pPr algn="ctr"/>
+          </a:p>
+        </p:txBody>
+      </p:sp>
+      <p:sp>
+        <p:nvSpPr>
+          <p:cNvPr id="4" name="TextBox 3"/>
+          <p:cNvSpPr txBox="1"/>
+          <p:nvPr/>
+        </p:nvSpPr>
+        <p:spPr>
+          <a:xfrm>
+            <a:off x="457200" y="164592"/>
+            <a:ext cx="8229600" cy="320040"/>
+          </a:xfrm>
+          <a:prstGeom prst="rect">
+            <a:avLst/>
+          </a:prstGeom>
+          <a:noFill/>
+        </p:spPr>
+        <p:txBody>
+          <a:bodyPr wrap="square" anchor="t" lIns="0" rIns="0" tIns="0" bIns="0">
+            <a:spAutoFit/>
+          </a:bodyPr>
+          <a:lstStyle/>
+          <a:p>
+            <a:pPr algn="l"/>
+            <a:r>
+              <a:rPr sz="1100" b="1">
+                <a:solidFill>
+                  <a:srgbClr val="FFFFFF"/>
+                </a:solidFill>
+                <a:latin typeface="Georgia"/>
+              </a:rPr>
+              <a:t>SITE TRAFFIC  ·  GA4 (MEXICO)</a:t>
+            </a:r>
+          </a:p>
+        </p:txBody>
+      </p:sp>
+      <p:pic>
+        <p:nvPicPr>
+          <p:cNvPr id="5" name="Picture 4" descr="berelvant_logo.png"/>
+          <p:cNvPicPr>
+            <a:picLocks noChangeAspect="1"/>
+          </p:cNvPicPr>
+          <p:nvPr/>
+        </p:nvPicPr>
+        <p:blipFill>
+          <a:blip r:embed="rId2"/>
+          <a:stretch>
+            <a:fillRect/>
+          </a:stretch>
+        </p:blipFill>
+        <p:spPr>
+          <a:xfrm>
+            <a:off x="10728655" y="146304"/>
+            <a:ext cx="960120" cy="274320"/>
+          </a:xfrm>
+          <a:prstGeom prst="rect">
+            <a:avLst/>
+          </a:prstGeom>
+        </p:spPr>
+      </p:pic>
+      <p:sp>
+        <p:nvSpPr>
+          <p:cNvPr id="6" name="TextBox 5"/>
+          <p:cNvSpPr txBox="1"/>
+          <p:nvPr/>
+        </p:nvSpPr>
+        <p:spPr>
+          <a:xfrm>
+            <a:off x="457200" y="868680"/>
+            <a:ext cx="11247120" cy="685800"/>
+          </a:xfrm>
+          <a:prstGeom prst="rect">
+            <a:avLst/>
+          </a:prstGeom>
+          <a:noFill/>
+        </p:spPr>
+        <p:txBody>
+          <a:bodyPr wrap="square" anchor="t" lIns="0" rIns="0" tIns="0" bIns="0">
+            <a:spAutoFit/>
+          </a:bodyPr>
+          <a:lstStyle/>
+          <a:p>
+            <a:pPr algn="l"/>
+            <a:r>
+              <a:rPr sz="2000" b="1">
+                <a:solidFill>
+                  <a:srgbClr val="1E2761"/>
+                </a:solidFill>
+                <a:latin typeface="Georgia"/>
+              </a:rPr>
+              <a:t>Context this month. The measurement fix makes August the first fully measured month.</a:t>
+            </a:r>
+          </a:p>
+        </p:txBody>
+      </p:sp>
+      <p:sp>
+        <p:nvSpPr>
+          <p:cNvPr id="7" name="Rectangle 6"/>
+          <p:cNvSpPr/>
+          <p:nvPr/>
+        </p:nvSpPr>
+        <p:spPr>
+          <a:xfrm>
+            <a:off x="0" y="6583680"/>
+            <a:ext cx="12191695" cy="10972"/>
+          </a:xfrm>
+          <a:prstGeom prst="rect">
+            <a:avLst/>
+          </a:prstGeom>
+          <a:solidFill>
+            <a:srgbClr val="D0D4DC"/>
+          </a:solidFill>
+          <a:ln>
+            <a:noFill/>
+          </a:ln>
+          <a:effectLst/>
+        </p:spPr>
+        <p:style>
+          <a:lnRef idx="1">
+            <a:schemeClr val="accent1"/>
+          </a:lnRef>
+          <a:fillRef idx="3">
+            <a:schemeClr val="accent1"/>
+          </a:fillRef>
+          <a:effectRef idx="2">
+            <a:schemeClr val="accent1"/>
+          </a:effectRef>
+          <a:fontRef idx="minor">
+            <a:schemeClr val="lt1"/>
+          </a:fontRef>
+        </p:style>
+        <p:txBody>
+          <a:bodyPr rtlCol="0" anchor="ctr"/>
+          <a:lstStyle/>
+          <a:p>
+            <a:pPr algn="ctr"/>
+          </a:p>
+        </p:txBody>
+      </p:sp>
+      <p:sp>
+        <p:nvSpPr>
+          <p:cNvPr id="8" name="TextBox 7"/>
+          <p:cNvSpPr txBox="1"/>
+          <p:nvPr/>
+        </p:nvSpPr>
+        <p:spPr>
+          <a:xfrm>
+            <a:off x="457200" y="6656832"/>
+            <a:ext cx="7315200" cy="201168"/>
+          </a:xfrm>
+          <a:prstGeom prst="rect">
+            <a:avLst/>
+          </a:prstGeom>
+          <a:noFill/>
+        </p:spPr>
+        <p:txBody>
+          <a:bodyPr wrap="square" anchor="t" lIns="0" rIns="0" tIns="0" bIns="0">
+            <a:spAutoFit/>
+          </a:bodyPr>
+          <a:lstStyle/>
+          <a:p>
+            <a:pPr algn="l"/>
+            <a:r>
+              <a:rPr sz="800" b="0">
+                <a:solidFill>
+                  <a:srgbClr val="5A6072"/>
+                </a:solidFill>
+                <a:latin typeface="Calibri"/>
+              </a:rPr>
+              <a:t>GGMI (LATAM)   |   July 2026 Performance Review   |   Berelvant</a:t>
+            </a:r>
+          </a:p>
+        </p:txBody>
+      </p:sp>
+      <p:sp>
+        <p:nvSpPr>
+          <p:cNvPr id="9" name="TextBox 8"/>
+          <p:cNvSpPr txBox="1"/>
+          <p:nvPr/>
+        </p:nvSpPr>
+        <p:spPr>
+          <a:xfrm>
+            <a:off x="10820095" y="6656832"/>
+            <a:ext cx="914400" cy="201168"/>
+          </a:xfrm>
+          <a:prstGeom prst="rect">
+            <a:avLst/>
+          </a:prstGeom>
+          <a:noFill/>
+        </p:spPr>
+        <p:txBody>
+          <a:bodyPr wrap="square" anchor="t" lIns="0" rIns="0" tIns="0" bIns="0">
+            <a:spAutoFit/>
+          </a:bodyPr>
+          <a:lstStyle/>
+          <a:p>
+            <a:pPr algn="r"/>
+            <a:r>
+              <a:rPr sz="800" b="0">
+                <a:solidFill>
+                  <a:srgbClr val="5A6072"/>
+                </a:solidFill>
+                <a:latin typeface="Calibri"/>
+              </a:rPr>
+              <a:t>15 / 16</a:t>
+            </a:r>
+          </a:p>
+        </p:txBody>
+      </p:sp>
+      <p:sp>
+        <p:nvSpPr>
+          <p:cNvPr id="10" name="Rectangle 9"/>
+          <p:cNvSpPr/>
+          <p:nvPr/>
+        </p:nvSpPr>
+        <p:spPr>
+          <a:xfrm>
+            <a:off x="457200" y="1691640"/>
+            <a:ext cx="1783080" cy="1005840"/>
+          </a:xfrm>
+          <a:prstGeom prst="rect">
+            <a:avLst/>
+          </a:prstGeom>
+          <a:solidFill>
+            <a:srgbClr val="FFFFFF"/>
+          </a:solidFill>
+          <a:ln w="9525">
+            <a:solidFill>
+              <a:srgbClr val="D0D4DC"/>
+            </a:solidFill>
+          </a:ln>
+          <a:effectLst/>
+        </p:spPr>
+        <p:style>
+          <a:lnRef idx="1">
+            <a:schemeClr val="accent1"/>
+          </a:lnRef>
+          <a:fillRef idx="3">
+            <a:schemeClr val="accent1"/>
+          </a:fillRef>
+          <a:effectRef idx="2">
+            <a:schemeClr val="accent1"/>
+          </a:effectRef>
+          <a:fontRef idx="minor">
+            <a:schemeClr val="lt1"/>
+          </a:fontRef>
+        </p:style>
+        <p:txBody>
+          <a:bodyPr rtlCol="0" anchor="ctr"/>
+          <a:lstStyle/>
+          <a:p>
+            <a:pPr algn="ctr"/>
+          </a:p>
+        </p:txBody>
+      </p:sp>
+      <p:sp>
+        <p:nvSpPr>
+          <p:cNvPr id="11" name="Rectangle 10"/>
+          <p:cNvSpPr/>
+          <p:nvPr/>
+        </p:nvSpPr>
+        <p:spPr>
+          <a:xfrm>
+            <a:off x="457200" y="1691640"/>
+            <a:ext cx="54864" cy="1005840"/>
+          </a:xfrm>
+          <a:prstGeom prst="rect">
+            <a:avLst/>
+          </a:prstGeom>
+          <a:solidFill>
+            <a:srgbClr val="F96167"/>
+          </a:solidFill>
+          <a:ln>
+            <a:noFill/>
+          </a:ln>
+          <a:effectLst/>
+        </p:spPr>
+        <p:style>
+          <a:lnRef idx="1">
+            <a:schemeClr val="accent1"/>
+          </a:lnRef>
+          <a:fillRef idx="3">
+            <a:schemeClr val="accent1"/>
+          </a:fillRef>
+          <a:effectRef idx="2">
+            <a:schemeClr val="accent1"/>
+          </a:effectRef>
+          <a:fontRef idx="minor">
+            <a:schemeClr val="lt1"/>
+          </a:fontRef>
+        </p:style>
+        <p:txBody>
+          <a:bodyPr rtlCol="0" anchor="ctr"/>
+          <a:lstStyle/>
+          <a:p>
+            <a:pPr algn="ctr"/>
+          </a:p>
+        </p:txBody>
+      </p:sp>
+      <p:sp>
+        <p:nvSpPr>
+          <p:cNvPr id="12" name="TextBox 11"/>
+          <p:cNvSpPr txBox="1"/>
+          <p:nvPr/>
+        </p:nvSpPr>
+        <p:spPr>
+          <a:xfrm>
+            <a:off x="640080" y="1737360"/>
+            <a:ext cx="1508760" cy="274320"/>
+          </a:xfrm>
+          <a:prstGeom prst="rect">
+            <a:avLst/>
+          </a:prstGeom>
+          <a:noFill/>
+        </p:spPr>
+        <p:txBody>
+          <a:bodyPr wrap="square" anchor="t" lIns="0" rIns="0" tIns="0" bIns="0">
+            <a:spAutoFit/>
+          </a:bodyPr>
+          <a:lstStyle/>
+          <a:p>
+            <a:pPr algn="l"/>
+            <a:r>
+              <a:rPr sz="800" b="1">
+                <a:solidFill>
+                  <a:srgbClr val="5A6072"/>
+                </a:solidFill>
+                <a:latin typeface="Calibri"/>
+              </a:rPr>
+              <a:t>MEXICO SESSIONS</a:t>
+            </a:r>
+          </a:p>
+        </p:txBody>
+      </p:sp>
+      <p:sp>
+        <p:nvSpPr>
+          <p:cNvPr id="13" name="TextBox 12"/>
+          <p:cNvSpPr txBox="1"/>
+          <p:nvPr/>
+        </p:nvSpPr>
+        <p:spPr>
+          <a:xfrm>
+            <a:off x="640080" y="1984248"/>
+            <a:ext cx="1508760" cy="457200"/>
+          </a:xfrm>
+          <a:prstGeom prst="rect">
+            <a:avLst/>
+          </a:prstGeom>
+          <a:noFill/>
+        </p:spPr>
+        <p:txBody>
+          <a:bodyPr wrap="square" anchor="t" lIns="0" rIns="0" tIns="0" bIns="0">
+            <a:spAutoFit/>
+          </a:bodyPr>
+          <a:lstStyle/>
+          <a:p>
+            <a:pPr algn="l"/>
+            <a:r>
+              <a:rPr sz="1500" b="1">
+                <a:solidFill>
+                  <a:srgbClr val="1E2761"/>
+                </a:solidFill>
+                <a:latin typeface="Calibri"/>
+              </a:rPr>
+              <a:t>7,310</a:t>
+            </a:r>
+          </a:p>
+        </p:txBody>
+      </p:sp>
+      <p:sp>
+        <p:nvSpPr>
+          <p:cNvPr id="14" name="TextBox 13"/>
+          <p:cNvSpPr txBox="1"/>
+          <p:nvPr/>
+        </p:nvSpPr>
+        <p:spPr>
+          <a:xfrm>
+            <a:off x="640080" y="2441448"/>
+            <a:ext cx="1508760" cy="219456"/>
+          </a:xfrm>
+          <a:prstGeom prst="rect">
+            <a:avLst/>
+          </a:prstGeom>
+          <a:noFill/>
+        </p:spPr>
+        <p:txBody>
+          <a:bodyPr wrap="square" anchor="t" lIns="0" rIns="0" tIns="0" bIns="0">
+            <a:spAutoFit/>
+          </a:bodyPr>
+          <a:lstStyle/>
+          <a:p>
+            <a:pPr algn="l"/>
+            <a:r>
+              <a:rPr sz="800" b="0">
+                <a:solidFill>
+                  <a:srgbClr val="5A6072"/>
+                </a:solidFill>
+                <a:latin typeface="Calibri"/>
+              </a:rPr>
+              <a:t>June: 9,236</a:t>
+            </a:r>
+          </a:p>
+        </p:txBody>
+      </p:sp>
+      <p:sp>
+        <p:nvSpPr>
+          <p:cNvPr id="15" name="Rectangle 14"/>
+          <p:cNvSpPr/>
+          <p:nvPr/>
+        </p:nvSpPr>
+        <p:spPr>
+          <a:xfrm>
+            <a:off x="2359152" y="1691640"/>
+            <a:ext cx="1783080" cy="1005840"/>
+          </a:xfrm>
+          <a:prstGeom prst="rect">
+            <a:avLst/>
+          </a:prstGeom>
+          <a:solidFill>
+            <a:srgbClr val="FFFFFF"/>
+          </a:solidFill>
+          <a:ln w="9525">
+            <a:solidFill>
+              <a:srgbClr val="D0D4DC"/>
+            </a:solidFill>
+          </a:ln>
+          <a:effectLst/>
+        </p:spPr>
+        <p:style>
+          <a:lnRef idx="1">
+            <a:schemeClr val="accent1"/>
+          </a:lnRef>
+          <a:fillRef idx="3">
+            <a:schemeClr val="accent1"/>
+          </a:fillRef>
+          <a:effectRef idx="2">
+            <a:schemeClr val="accent1"/>
+          </a:effectRef>
+          <a:fontRef idx="minor">
+            <a:schemeClr val="lt1"/>
+          </a:fontRef>
+        </p:style>
+        <p:txBody>
+          <a:bodyPr rtlCol="0" anchor="ctr"/>
+          <a:lstStyle/>
+          <a:p>
+            <a:pPr algn="ctr"/>
+          </a:p>
+        </p:txBody>
+      </p:sp>
+      <p:sp>
+        <p:nvSpPr>
+          <p:cNvPr id="16" name="Rectangle 15"/>
+          <p:cNvSpPr/>
+          <p:nvPr/>
+        </p:nvSpPr>
+        <p:spPr>
+          <a:xfrm>
+            <a:off x="2359152" y="1691640"/>
+            <a:ext cx="54864" cy="1005840"/>
+          </a:xfrm>
+          <a:prstGeom prst="rect">
+            <a:avLst/>
+          </a:prstGeom>
+          <a:solidFill>
+            <a:srgbClr val="F96167"/>
+          </a:solidFill>
+          <a:ln>
+            <a:noFill/>
+          </a:ln>
+          <a:effectLst/>
+        </p:spPr>
+        <p:style>
+          <a:lnRef idx="1">
+            <a:schemeClr val="accent1"/>
+          </a:lnRef>
+          <a:fillRef idx="3">
+            <a:schemeClr val="accent1"/>
+          </a:fillRef>
+          <a:effectRef idx="2">
+            <a:schemeClr val="accent1"/>
+          </a:effectRef>
+          <a:fontRef idx="minor">
+            <a:schemeClr val="lt1"/>
+          </a:fontRef>
+        </p:style>
+        <p:txBody>
+          <a:bodyPr rtlCol="0" anchor="ctr"/>
+          <a:lstStyle/>
+          <a:p>
+            <a:pPr algn="ctr"/>
+          </a:p>
+        </p:txBody>
+      </p:sp>
+      <p:sp>
+        <p:nvSpPr>
+          <p:cNvPr id="17" name="TextBox 16"/>
+          <p:cNvSpPr txBox="1"/>
+          <p:nvPr/>
+        </p:nvSpPr>
+        <p:spPr>
+          <a:xfrm>
+            <a:off x="2542032" y="1737360"/>
+            <a:ext cx="1508760" cy="274320"/>
+          </a:xfrm>
+          <a:prstGeom prst="rect">
+            <a:avLst/>
+          </a:prstGeom>
+          <a:noFill/>
+        </p:spPr>
+        <p:txBody>
+          <a:bodyPr wrap="square" anchor="t" lIns="0" rIns="0" tIns="0" bIns="0">
+            <a:spAutoFit/>
+          </a:bodyPr>
+          <a:lstStyle/>
+          <a:p>
+            <a:pPr algn="l"/>
+            <a:r>
+              <a:rPr sz="800" b="1">
+                <a:solidFill>
+                  <a:srgbClr val="5A6072"/>
+                </a:solidFill>
+                <a:latin typeface="Calibri"/>
+              </a:rPr>
+              <a:t>UNIQUE VISITORS</a:t>
+            </a:r>
+          </a:p>
+        </p:txBody>
+      </p:sp>
+      <p:sp>
+        <p:nvSpPr>
+          <p:cNvPr id="18" name="TextBox 17"/>
+          <p:cNvSpPr txBox="1"/>
+          <p:nvPr/>
+        </p:nvSpPr>
+        <p:spPr>
+          <a:xfrm>
+            <a:off x="2542032" y="1984248"/>
+            <a:ext cx="1508760" cy="457200"/>
+          </a:xfrm>
+          <a:prstGeom prst="rect">
+            <a:avLst/>
+          </a:prstGeom>
+          <a:noFill/>
+        </p:spPr>
+        <p:txBody>
+          <a:bodyPr wrap="square" anchor="t" lIns="0" rIns="0" tIns="0" bIns="0">
+            <a:spAutoFit/>
+          </a:bodyPr>
+          <a:lstStyle/>
+          <a:p>
+            <a:pPr algn="l"/>
+            <a:r>
+              <a:rPr sz="1500" b="1">
+                <a:solidFill>
+                  <a:srgbClr val="1E2761"/>
+                </a:solidFill>
+                <a:latin typeface="Calibri"/>
+              </a:rPr>
+              <a:t>3,981</a:t>
+            </a:r>
+          </a:p>
+        </p:txBody>
+      </p:sp>
+      <p:sp>
+        <p:nvSpPr>
+          <p:cNvPr id="19" name="TextBox 18"/>
+          <p:cNvSpPr txBox="1"/>
+          <p:nvPr/>
+        </p:nvSpPr>
+        <p:spPr>
+          <a:xfrm>
+            <a:off x="2542032" y="2441448"/>
+            <a:ext cx="1508760" cy="219456"/>
+          </a:xfrm>
+          <a:prstGeom prst="rect">
+            <a:avLst/>
+          </a:prstGeom>
+          <a:noFill/>
+        </p:spPr>
+        <p:txBody>
+          <a:bodyPr wrap="square" anchor="t" lIns="0" rIns="0" tIns="0" bIns="0">
+            <a:spAutoFit/>
+          </a:bodyPr>
+          <a:lstStyle/>
+          <a:p>
+            <a:pPr algn="l"/>
+            <a:r>
+              <a:rPr sz="800" b="0">
+                <a:solidFill>
+                  <a:srgbClr val="5A6072"/>
+                </a:solidFill>
+                <a:latin typeface="Calibri"/>
+              </a:rPr>
+              <a:t>Mexico</a:t>
+            </a:r>
+          </a:p>
+        </p:txBody>
+      </p:sp>
+      <p:sp>
+        <p:nvSpPr>
+          <p:cNvPr id="20" name="Rectangle 19"/>
+          <p:cNvSpPr/>
+          <p:nvPr/>
+        </p:nvSpPr>
+        <p:spPr>
+          <a:xfrm>
+            <a:off x="4261104" y="1691640"/>
+            <a:ext cx="1783080" cy="1005840"/>
+          </a:xfrm>
+          <a:prstGeom prst="rect">
+            <a:avLst/>
+          </a:prstGeom>
+          <a:solidFill>
+            <a:srgbClr val="FFFFFF"/>
+          </a:solidFill>
+          <a:ln w="9525">
+            <a:solidFill>
+              <a:srgbClr val="D0D4DC"/>
+            </a:solidFill>
+          </a:ln>
+          <a:effectLst/>
+        </p:spPr>
+        <p:style>
+          <a:lnRef idx="1">
+            <a:schemeClr val="accent1"/>
+          </a:lnRef>
+          <a:fillRef idx="3">
+            <a:schemeClr val="accent1"/>
+          </a:fillRef>
+          <a:effectRef idx="2">
+            <a:schemeClr val="accent1"/>
+          </a:effectRef>
+          <a:fontRef idx="minor">
+            <a:schemeClr val="lt1"/>
+          </a:fontRef>
+        </p:style>
+        <p:txBody>
+          <a:bodyPr rtlCol="0" anchor="ctr"/>
+          <a:lstStyle/>
+          <a:p>
+            <a:pPr algn="ctr"/>
+          </a:p>
+        </p:txBody>
+      </p:sp>
+      <p:sp>
+        <p:nvSpPr>
+          <p:cNvPr id="21" name="Rectangle 20"/>
+          <p:cNvSpPr/>
+          <p:nvPr/>
+        </p:nvSpPr>
+        <p:spPr>
+          <a:xfrm>
+            <a:off x="4261104" y="1691640"/>
+            <a:ext cx="54864" cy="1005840"/>
+          </a:xfrm>
+          <a:prstGeom prst="rect">
+            <a:avLst/>
+          </a:prstGeom>
+          <a:solidFill>
+            <a:srgbClr val="F96167"/>
+          </a:solidFill>
+          <a:ln>
+            <a:noFill/>
+          </a:ln>
+          <a:effectLst/>
+        </p:spPr>
+        <p:style>
+          <a:lnRef idx="1">
+            <a:schemeClr val="accent1"/>
+          </a:lnRef>
+          <a:fillRef idx="3">
+            <a:schemeClr val="accent1"/>
+          </a:fillRef>
+          <a:effectRef idx="2">
+            <a:schemeClr val="accent1"/>
+          </a:effectRef>
+          <a:fontRef idx="minor">
+            <a:schemeClr val="lt1"/>
+          </a:fontRef>
+        </p:style>
+        <p:txBody>
+          <a:bodyPr rtlCol="0" anchor="ctr"/>
+          <a:lstStyle/>
+          <a:p>
+            <a:pPr algn="ctr"/>
+          </a:p>
+        </p:txBody>
+      </p:sp>
+      <p:sp>
+        <p:nvSpPr>
+          <p:cNvPr id="22" name="TextBox 21"/>
+          <p:cNvSpPr txBox="1"/>
+          <p:nvPr/>
+        </p:nvSpPr>
+        <p:spPr>
+          <a:xfrm>
+            <a:off x="4443984" y="1737360"/>
+            <a:ext cx="1508760" cy="274320"/>
+          </a:xfrm>
+          <a:prstGeom prst="rect">
+            <a:avLst/>
+          </a:prstGeom>
+          <a:noFill/>
+        </p:spPr>
+        <p:txBody>
+          <a:bodyPr wrap="square" anchor="t" lIns="0" rIns="0" tIns="0" bIns="0">
+            <a:spAutoFit/>
+          </a:bodyPr>
+          <a:lstStyle/>
+          <a:p>
+            <a:pPr algn="l"/>
+            <a:r>
+              <a:rPr sz="800" b="1">
+                <a:solidFill>
+                  <a:srgbClr val="5A6072"/>
+                </a:solidFill>
+                <a:latin typeface="Calibri"/>
+              </a:rPr>
+              <a:t>KEY-EVENT CAPTURE</a:t>
+            </a:r>
+          </a:p>
+        </p:txBody>
+      </p:sp>
+      <p:sp>
+        <p:nvSpPr>
+          <p:cNvPr id="23" name="TextBox 22"/>
+          <p:cNvSpPr txBox="1"/>
+          <p:nvPr/>
+        </p:nvSpPr>
+        <p:spPr>
+          <a:xfrm>
+            <a:off x="4443984" y="1984248"/>
+            <a:ext cx="1508760" cy="457200"/>
+          </a:xfrm>
+          <a:prstGeom prst="rect">
+            <a:avLst/>
+          </a:prstGeom>
+          <a:noFill/>
+        </p:spPr>
+        <p:txBody>
+          <a:bodyPr wrap="square" anchor="t" lIns="0" rIns="0" tIns="0" bIns="0">
+            <a:spAutoFit/>
+          </a:bodyPr>
+          <a:lstStyle/>
+          <a:p>
+            <a:pPr algn="l"/>
+            <a:r>
+              <a:rPr sz="1500" b="1">
+                <a:solidFill>
+                  <a:srgbClr val="1E2761"/>
+                </a:solidFill>
+                <a:latin typeface="Calibri"/>
+              </a:rPr>
+              <a:t>Fixed</a:t>
+            </a:r>
+          </a:p>
+        </p:txBody>
+      </p:sp>
+      <p:sp>
+        <p:nvSpPr>
+          <p:cNvPr id="24" name="TextBox 23"/>
+          <p:cNvSpPr txBox="1"/>
+          <p:nvPr/>
+        </p:nvSpPr>
+        <p:spPr>
+          <a:xfrm>
+            <a:off x="4443984" y="2441448"/>
+            <a:ext cx="1508760" cy="219456"/>
+          </a:xfrm>
+          <a:prstGeom prst="rect">
+            <a:avLst/>
+          </a:prstGeom>
+          <a:noFill/>
+        </p:spPr>
+        <p:txBody>
+          <a:bodyPr wrap="square" anchor="t" lIns="0" rIns="0" tIns="0" bIns="0">
+            <a:spAutoFit/>
+          </a:bodyPr>
+          <a:lstStyle/>
+          <a:p>
+            <a:pPr algn="l"/>
+            <a:r>
+              <a:rPr sz="800" b="0">
+                <a:solidFill>
+                  <a:srgbClr val="5A6072"/>
+                </a:solidFill>
+                <a:latin typeface="Calibri"/>
+              </a:rPr>
+              <a:t>live since Jul 31</a:t>
+            </a:r>
+          </a:p>
+        </p:txBody>
+      </p:sp>
+      <p:sp>
+        <p:nvSpPr>
+          <p:cNvPr id="25" name="Rectangle 24"/>
+          <p:cNvSpPr/>
+          <p:nvPr/>
+        </p:nvSpPr>
+        <p:spPr>
+          <a:xfrm>
+            <a:off x="6163056" y="1691640"/>
+            <a:ext cx="1783080" cy="1005840"/>
+          </a:xfrm>
+          <a:prstGeom prst="rect">
+            <a:avLst/>
+          </a:prstGeom>
+          <a:solidFill>
+            <a:srgbClr val="FFFFFF"/>
+          </a:solidFill>
+          <a:ln w="9525">
+            <a:solidFill>
+              <a:srgbClr val="D0D4DC"/>
+            </a:solidFill>
+          </a:ln>
+          <a:effectLst/>
+        </p:spPr>
+        <p:style>
+          <a:lnRef idx="1">
+            <a:schemeClr val="accent1"/>
+          </a:lnRef>
+          <a:fillRef idx="3">
+            <a:schemeClr val="accent1"/>
+          </a:fillRef>
+          <a:effectRef idx="2">
+            <a:schemeClr val="accent1"/>
+          </a:effectRef>
+          <a:fontRef idx="minor">
+            <a:schemeClr val="lt1"/>
+          </a:fontRef>
+        </p:style>
+        <p:txBody>
+          <a:bodyPr rtlCol="0" anchor="ctr"/>
+          <a:lstStyle/>
+          <a:p>
+            <a:pPr algn="ctr"/>
+          </a:p>
+        </p:txBody>
+      </p:sp>
+      <p:sp>
+        <p:nvSpPr>
+          <p:cNvPr id="26" name="Rectangle 25"/>
+          <p:cNvSpPr/>
+          <p:nvPr/>
+        </p:nvSpPr>
+        <p:spPr>
+          <a:xfrm>
+            <a:off x="6163056" y="1691640"/>
+            <a:ext cx="54864" cy="1005840"/>
+          </a:xfrm>
+          <a:prstGeom prst="rect">
+            <a:avLst/>
+          </a:prstGeom>
+          <a:solidFill>
+            <a:srgbClr val="F96167"/>
+          </a:solidFill>
+          <a:ln>
+            <a:noFill/>
+          </a:ln>
+          <a:effectLst/>
+        </p:spPr>
+        <p:style>
+          <a:lnRef idx="1">
+            <a:schemeClr val="accent1"/>
+          </a:lnRef>
+          <a:fillRef idx="3">
+            <a:schemeClr val="accent1"/>
+          </a:fillRef>
+          <a:effectRef idx="2">
+            <a:schemeClr val="accent1"/>
+          </a:effectRef>
+          <a:fontRef idx="minor">
+            <a:schemeClr val="lt1"/>
+          </a:fontRef>
+        </p:style>
+        <p:txBody>
+          <a:bodyPr rtlCol="0" anchor="ctr"/>
+          <a:lstStyle/>
+          <a:p>
+            <a:pPr algn="ctr"/>
+          </a:p>
+        </p:txBody>
+      </p:sp>
+      <p:sp>
+        <p:nvSpPr>
+          <p:cNvPr id="27" name="TextBox 26"/>
+          <p:cNvSpPr txBox="1"/>
+          <p:nvPr/>
+        </p:nvSpPr>
+        <p:spPr>
+          <a:xfrm>
+            <a:off x="6345936" y="1737360"/>
+            <a:ext cx="1508760" cy="274320"/>
+          </a:xfrm>
+          <a:prstGeom prst="rect">
+            <a:avLst/>
+          </a:prstGeom>
+          <a:noFill/>
+        </p:spPr>
+        <p:txBody>
+          <a:bodyPr wrap="square" anchor="t" lIns="0" rIns="0" tIns="0" bIns="0">
+            <a:spAutoFit/>
+          </a:bodyPr>
+          <a:lstStyle/>
+          <a:p>
+            <a:pPr algn="l"/>
+            <a:r>
+              <a:rPr sz="800" b="1">
+                <a:solidFill>
+                  <a:srgbClr val="5A6072"/>
+                </a:solidFill>
+                <a:latin typeface="Calibri"/>
+              </a:rPr>
+              <a:t>GA4 CORROBORATION</a:t>
+            </a:r>
+          </a:p>
+        </p:txBody>
+      </p:sp>
+      <p:sp>
+        <p:nvSpPr>
+          <p:cNvPr id="28" name="TextBox 27"/>
+          <p:cNvSpPr txBox="1"/>
+          <p:nvPr/>
+        </p:nvSpPr>
+        <p:spPr>
+          <a:xfrm>
+            <a:off x="6345936" y="1984248"/>
+            <a:ext cx="1508760" cy="457200"/>
+          </a:xfrm>
+          <a:prstGeom prst="rect">
+            <a:avLst/>
+          </a:prstGeom>
+          <a:noFill/>
+        </p:spPr>
+        <p:txBody>
+          <a:bodyPr wrap="square" anchor="t" lIns="0" rIns="0" tIns="0" bIns="0">
+            <a:spAutoFit/>
+          </a:bodyPr>
+          <a:lstStyle/>
+          <a:p>
+            <a:pPr algn="l"/>
+            <a:r>
+              <a:rPr sz="1500" b="1">
+                <a:solidFill>
+                  <a:srgbClr val="1E2761"/>
+                </a:solidFill>
+                <a:latin typeface="Calibri"/>
+              </a:rPr>
+              <a:t>August</a:t>
+            </a:r>
+          </a:p>
+        </p:txBody>
+      </p:sp>
+      <p:sp>
+        <p:nvSpPr>
+          <p:cNvPr id="29" name="TextBox 28"/>
+          <p:cNvSpPr txBox="1"/>
+          <p:nvPr/>
+        </p:nvSpPr>
+        <p:spPr>
+          <a:xfrm>
+            <a:off x="6345936" y="2441448"/>
+            <a:ext cx="1508760" cy="219456"/>
+          </a:xfrm>
+          <a:prstGeom prst="rect">
+            <a:avLst/>
+          </a:prstGeom>
+          <a:noFill/>
+        </p:spPr>
+        <p:txBody>
+          <a:bodyPr wrap="square" anchor="t" lIns="0" rIns="0" tIns="0" bIns="0">
+            <a:spAutoFit/>
+          </a:bodyPr>
+          <a:lstStyle/>
+          <a:p>
+            <a:pPr algn="l"/>
+            <a:r>
+              <a:rPr sz="800" b="0">
+                <a:solidFill>
+                  <a:srgbClr val="5A6072"/>
+                </a:solidFill>
+                <a:latin typeface="Calibri"/>
+              </a:rPr>
+              <a:t>first full month</a:t>
+            </a:r>
+          </a:p>
+        </p:txBody>
+      </p:sp>
+      <p:sp>
+        <p:nvSpPr>
+          <p:cNvPr id="30" name="Rectangle 29"/>
+          <p:cNvSpPr/>
+          <p:nvPr/>
+        </p:nvSpPr>
+        <p:spPr>
+          <a:xfrm>
+            <a:off x="457200" y="3017520"/>
+            <a:ext cx="5577840" cy="3108960"/>
+          </a:xfrm>
+          <a:prstGeom prst="rect">
+            <a:avLst/>
+          </a:prstGeom>
+          <a:solidFill>
+            <a:srgbClr val="FFFFFF"/>
+          </a:solidFill>
+          <a:ln w="9525">
+            <a:solidFill>
+              <a:srgbClr val="D0D4DC"/>
+            </a:solidFill>
+          </a:ln>
+          <a:effectLst/>
+        </p:spPr>
+        <p:style>
+          <a:lnRef idx="1">
+            <a:schemeClr val="accent1"/>
+          </a:lnRef>
+          <a:fillRef idx="3">
+            <a:schemeClr val="accent1"/>
+          </a:fillRef>
+          <a:effectRef idx="2">
+            <a:schemeClr val="accent1"/>
+          </a:effectRef>
+          <a:fontRef idx="minor">
+            <a:schemeClr val="lt1"/>
+          </a:fontRef>
+        </p:style>
+        <p:txBody>
+          <a:bodyPr rtlCol="0" anchor="ctr"/>
+          <a:lstStyle/>
+          <a:p>
+            <a:pPr algn="ctr"/>
+          </a:p>
+        </p:txBody>
+      </p:sp>
+      <p:sp>
+        <p:nvSpPr>
+          <p:cNvPr id="31" name="Rectangle 30"/>
+          <p:cNvSpPr/>
+          <p:nvPr/>
+        </p:nvSpPr>
+        <p:spPr>
+          <a:xfrm>
+            <a:off x="457200" y="3017520"/>
+            <a:ext cx="64008" cy="3108960"/>
+          </a:xfrm>
+          <a:prstGeom prst="rect">
+            <a:avLst/>
+          </a:prstGeom>
+          <a:solidFill>
+            <a:srgbClr val="2E7D57"/>
+          </a:solidFill>
+          <a:ln>
+            <a:noFill/>
+          </a:ln>
+          <a:effectLst/>
+        </p:spPr>
+        <p:style>
+          <a:lnRef idx="1">
+            <a:schemeClr val="accent1"/>
+          </a:lnRef>
+          <a:fillRef idx="3">
+            <a:schemeClr val="accent1"/>
+          </a:fillRef>
+          <a:effectRef idx="2">
+            <a:schemeClr val="accent1"/>
+          </a:effectRef>
+          <a:fontRef idx="minor">
+            <a:schemeClr val="lt1"/>
+          </a:fontRef>
+        </p:style>
+        <p:txBody>
+          <a:bodyPr rtlCol="0" anchor="ctr"/>
+          <a:lstStyle/>
+          <a:p>
+            <a:pPr algn="ctr"/>
+          </a:p>
+        </p:txBody>
+      </p:sp>
+      <p:sp>
+        <p:nvSpPr>
+          <p:cNvPr id="32" name="TextBox 31"/>
+          <p:cNvSpPr txBox="1"/>
+          <p:nvPr/>
+        </p:nvSpPr>
+        <p:spPr>
+          <a:xfrm>
+            <a:off x="676656" y="3182112"/>
+            <a:ext cx="5175503" cy="274320"/>
+          </a:xfrm>
+          <a:prstGeom prst="rect">
+            <a:avLst/>
+          </a:prstGeom>
+          <a:noFill/>
+        </p:spPr>
+        <p:txBody>
+          <a:bodyPr wrap="square" anchor="t" lIns="0" rIns="0" tIns="0" bIns="0">
+            <a:spAutoFit/>
+          </a:bodyPr>
+          <a:lstStyle/>
+          <a:p>
+            <a:pPr algn="l"/>
+            <a:r>
+              <a:rPr sz="1000" b="1">
+                <a:solidFill>
+                  <a:srgbClr val="1E2761"/>
+                </a:solidFill>
+                <a:latin typeface="Georgia"/>
+              </a:rPr>
+              <a:t>WHAT THE DATA SHOWS</a:t>
+            </a:r>
+          </a:p>
+        </p:txBody>
+      </p:sp>
+      <p:sp>
+        <p:nvSpPr>
+          <p:cNvPr id="33" name="TextBox 32"/>
+          <p:cNvSpPr txBox="1"/>
+          <p:nvPr/>
+        </p:nvSpPr>
+        <p:spPr>
+          <a:xfrm>
+            <a:off x="676656" y="3520439"/>
+            <a:ext cx="5175503" cy="2423160"/>
+          </a:xfrm>
+          <a:prstGeom prst="rect">
+            <a:avLst/>
+          </a:prstGeom>
+          <a:noFill/>
+        </p:spPr>
+        <p:txBody>
+          <a:bodyPr wrap="square" anchor="t" lIns="0" rIns="0" tIns="0" bIns="0">
+            <a:spAutoFit/>
+          </a:bodyPr>
+          <a:lstStyle/>
+          <a:p>
+            <a:pPr algn="l"/>
+            <a:r>
+              <a:rPr sz="950" b="0">
+                <a:solidFill>
+                  <a:srgbClr val="2B3147"/>
+                </a:solidFill>
+                <a:latin typeface="Calibri"/>
+              </a:rPr>
+              <a:t>A large share of July’s session dip tracks Bing’s own month: ten days of rebuild, then the transition window. Property-wide, sessions without source attribution (largely untagged paid search) fell sharply; attributed sessions grew.</a:t>
+            </a:r>
+          </a:p>
+          <a:p>
+            <a:pPr algn="l">
+              <a:spcBef>
+                <a:spcPts val="600"/>
+              </a:spcBef>
+            </a:pPr>
+            <a:r>
+              <a:rPr sz="950" b="0">
+                <a:solidFill>
+                  <a:srgbClr val="2B3147"/>
+                </a:solidFill>
+                <a:latin typeface="Calibri"/>
+              </a:rPr>
+              <a:t>Venezuela’s session volume fell sharply as the prior campaigns retired, the same campaign-mix effect behind Bing’s in-market concentration this month.</a:t>
+            </a:r>
+          </a:p>
+        </p:txBody>
+      </p:sp>
+      <p:sp>
+        <p:nvSpPr>
+          <p:cNvPr id="34" name="Rectangle 33"/>
+          <p:cNvSpPr/>
+          <p:nvPr/>
+        </p:nvSpPr>
+        <p:spPr>
+          <a:xfrm>
+            <a:off x="6309360" y="3017520"/>
+            <a:ext cx="5394960" cy="3108960"/>
+          </a:xfrm>
+          <a:prstGeom prst="rect">
+            <a:avLst/>
+          </a:prstGeom>
+          <a:solidFill>
+            <a:srgbClr val="FFFFFF"/>
+          </a:solidFill>
+          <a:ln w="9525">
+            <a:solidFill>
+              <a:srgbClr val="D0D4DC"/>
+            </a:solidFill>
+          </a:ln>
+          <a:effectLst/>
+        </p:spPr>
+        <p:style>
+          <a:lnRef idx="1">
+            <a:schemeClr val="accent1"/>
+          </a:lnRef>
+          <a:fillRef idx="3">
+            <a:schemeClr val="accent1"/>
+          </a:fillRef>
+          <a:effectRef idx="2">
+            <a:schemeClr val="accent1"/>
+          </a:effectRef>
+          <a:fontRef idx="minor">
+            <a:schemeClr val="lt1"/>
+          </a:fontRef>
+        </p:style>
+        <p:txBody>
+          <a:bodyPr rtlCol="0" anchor="ctr"/>
+          <a:lstStyle/>
+          <a:p>
+            <a:pPr algn="ctr"/>
+          </a:p>
+        </p:txBody>
+      </p:sp>
+      <p:sp>
+        <p:nvSpPr>
+          <p:cNvPr id="35" name="Rectangle 34"/>
+          <p:cNvSpPr/>
+          <p:nvPr/>
+        </p:nvSpPr>
+        <p:spPr>
+          <a:xfrm>
+            <a:off x="6309360" y="3017520"/>
+            <a:ext cx="64008" cy="3108960"/>
+          </a:xfrm>
+          <a:prstGeom prst="rect">
+            <a:avLst/>
+          </a:prstGeom>
+          <a:solidFill>
+            <a:srgbClr val="0F1535"/>
+          </a:solidFill>
+          <a:ln>
+            <a:noFill/>
+          </a:ln>
+          <a:effectLst/>
+        </p:spPr>
+        <p:style>
+          <a:lnRef idx="1">
+            <a:schemeClr val="accent1"/>
+          </a:lnRef>
+          <a:fillRef idx="3">
+            <a:schemeClr val="accent1"/>
+          </a:fillRef>
+          <a:effectRef idx="2">
+            <a:schemeClr val="accent1"/>
+          </a:effectRef>
+          <a:fontRef idx="minor">
+            <a:schemeClr val="lt1"/>
+          </a:fontRef>
+        </p:style>
+        <p:txBody>
+          <a:bodyPr rtlCol="0" anchor="ctr"/>
+          <a:lstStyle/>
+          <a:p>
+            <a:pPr algn="ctr"/>
+          </a:p>
+        </p:txBody>
+      </p:sp>
+      <p:sp>
+        <p:nvSpPr>
+          <p:cNvPr id="36" name="TextBox 35"/>
+          <p:cNvSpPr txBox="1"/>
+          <p:nvPr/>
+        </p:nvSpPr>
+        <p:spPr>
+          <a:xfrm>
+            <a:off x="6528816" y="3182112"/>
+            <a:ext cx="4992624" cy="274320"/>
+          </a:xfrm>
+          <a:prstGeom prst="rect">
+            <a:avLst/>
+          </a:prstGeom>
+          <a:noFill/>
+        </p:spPr>
+        <p:txBody>
+          <a:bodyPr wrap="square" anchor="t" lIns="0" rIns="0" tIns="0" bIns="0">
+            <a:spAutoFit/>
+          </a:bodyPr>
+          <a:lstStyle/>
+          <a:p>
+            <a:pPr algn="l"/>
+            <a:r>
+              <a:rPr sz="1000" b="1">
+                <a:solidFill>
+                  <a:srgbClr val="1E2761"/>
+                </a:solidFill>
+                <a:latin typeface="Georgia"/>
+              </a:rPr>
+              <a:t>MEASUREMENT TO CLOSE</a:t>
+            </a:r>
+          </a:p>
+        </p:txBody>
+      </p:sp>
+      <p:sp>
+        <p:nvSpPr>
+          <p:cNvPr id="37" name="TextBox 36"/>
+          <p:cNvSpPr txBox="1"/>
+          <p:nvPr/>
+        </p:nvSpPr>
+        <p:spPr>
+          <a:xfrm>
+            <a:off x="6528816" y="3520439"/>
+            <a:ext cx="4992624" cy="2423160"/>
+          </a:xfrm>
+          <a:prstGeom prst="rect">
+            <a:avLst/>
+          </a:prstGeom>
+          <a:noFill/>
+        </p:spPr>
+        <p:txBody>
+          <a:bodyPr wrap="square" anchor="t" lIns="0" rIns="0" tIns="0" bIns="0">
+            <a:spAutoFit/>
+          </a:bodyPr>
+          <a:lstStyle/>
+          <a:p>
+            <a:pPr algn="l"/>
+            <a:r>
+              <a:rPr sz="950" b="0">
+                <a:solidFill>
+                  <a:srgbClr val="2B3147"/>
+                </a:solidFill>
+                <a:latin typeface="Calibri"/>
+              </a:rPr>
+              <a:t>The submitted-application key event began counting correctly on July 31 and has held at full capture since. July is reported on the SA360 count; August is the first month GA4 can corroborate it independently.</a:t>
+            </a:r>
+          </a:p>
+          <a:p>
+            <a:pPr algn="l">
+              <a:spcBef>
+                <a:spcPts val="600"/>
+              </a:spcBef>
+            </a:pPr>
+            <a:r>
+              <a:rPr sz="950" b="0">
+                <a:solidFill>
+                  <a:srgbClr val="2B3147"/>
+                </a:solidFill>
+                <a:latin typeface="Calibri"/>
+              </a:rPr>
+              <a:t>Completion of the Bing-to-GA4 account link has not yet been verified; the paid-search restatement June’s deck flagged lands once it is, expected alongside August’s corroboration.</a:t>
+            </a:r>
+          </a:p>
+        </p:txBody>
+      </p:sp>
+    </p:spTree>
+  </p:cSld>
+  <p:clrMapOvr>
+    <a:masterClrMapping/>
+  </p:clrMapOvr>
+</p:sld>
+</file>
+
+<file path=ppt/slides/slide16.xml><?xml version="1.0" encoding="utf-8"?>
+<p:sld xmlns:a="http://schemas.openxmlformats.org/drawingml/2006/main" xmlns:p="http://schemas.openxmlformats.org/presentationml/2006/main" xmlns:r="http://schemas.openxmlformats.org/officeDocument/2006/relationships">
+  <p:cSld>
+    <p:spTree>
+      <p:nvGrpSpPr>
+        <p:cNvPr id="1" name=""/>
+        <p:cNvGrpSpPr/>
+        <p:nvPr/>
+      </p:nvGrpSpPr>
+      <p:grpSpPr/>
+      <p:sp>
+        <p:nvSpPr>
+          <p:cNvPr id="2" name="Rectangle 1"/>
+          <p:cNvSpPr/>
+          <p:nvPr/>
+        </p:nvSpPr>
+        <p:spPr>
+          <a:xfrm>
+            <a:off x="0" y="0"/>
+            <a:ext cx="12191695" cy="630936"/>
+          </a:xfrm>
+          <a:prstGeom prst="rect">
+            <a:avLst/>
+          </a:prstGeom>
+          <a:solidFill>
+            <a:srgbClr val="1E2761"/>
+          </a:solidFill>
+          <a:ln>
+            <a:noFill/>
+          </a:ln>
+          <a:effectLst/>
+        </p:spPr>
+        <p:style>
+          <a:lnRef idx="1">
+            <a:schemeClr val="accent1"/>
+          </a:lnRef>
+          <a:fillRef idx="3">
+            <a:schemeClr val="accent1"/>
+          </a:fillRef>
+          <a:effectRef idx="2">
+            <a:schemeClr val="accent1"/>
+          </a:effectRef>
+          <a:fontRef idx="minor">
+            <a:schemeClr val="lt1"/>
+          </a:fontRef>
+        </p:style>
+        <p:txBody>
+          <a:bodyPr rtlCol="0" anchor="ctr"/>
+          <a:lstStyle/>
+          <a:p>
+            <a:pPr algn="ctr"/>
+          </a:p>
+        </p:txBody>
+      </p:sp>
+      <p:sp>
+        <p:nvSpPr>
+          <p:cNvPr id="3" name="Rectangle 2"/>
+          <p:cNvSpPr/>
+          <p:nvPr/>
+        </p:nvSpPr>
+        <p:spPr>
+          <a:xfrm>
+            <a:off x="0" y="630936"/>
+            <a:ext cx="12191695" cy="45720"/>
+          </a:xfrm>
+          <a:prstGeom prst="rect">
+            <a:avLst/>
+          </a:prstGeom>
+          <a:solidFill>
+            <a:srgbClr val="F96167"/>
+          </a:solidFill>
+          <a:ln>
+            <a:noFill/>
+          </a:ln>
+          <a:effectLst/>
+        </p:spPr>
+        <p:style>
+          <a:lnRef idx="1">
+            <a:schemeClr val="accent1"/>
+          </a:lnRef>
+          <a:fillRef idx="3">
+            <a:schemeClr val="accent1"/>
+          </a:fillRef>
+          <a:effectRef idx="2">
+            <a:schemeClr val="accent1"/>
+          </a:effectRef>
+          <a:fontRef idx="minor">
+            <a:schemeClr val="lt1"/>
+          </a:fontRef>
+        </p:style>
+        <p:txBody>
+          <a:bodyPr rtlCol="0" anchor="ctr"/>
+          <a:lstStyle/>
+          <a:p>
+            <a:pPr algn="ctr"/>
+          </a:p>
+        </p:txBody>
+      </p:sp>
+      <p:sp>
+        <p:nvSpPr>
+          <p:cNvPr id="4" name="TextBox 3"/>
+          <p:cNvSpPr txBox="1"/>
+          <p:nvPr/>
+        </p:nvSpPr>
+        <p:spPr>
+          <a:xfrm>
+            <a:off x="457200" y="164592"/>
+            <a:ext cx="8229600" cy="320040"/>
+          </a:xfrm>
+          <a:prstGeom prst="rect">
+            <a:avLst/>
+          </a:prstGeom>
+          <a:noFill/>
+        </p:spPr>
+        <p:txBody>
+          <a:bodyPr wrap="square" anchor="t" lIns="0" rIns="0" tIns="0" bIns="0">
+            <a:spAutoFit/>
+          </a:bodyPr>
+          <a:lstStyle/>
+          <a:p>
+            <a:pPr algn="l"/>
+            <a:r>
+              <a:rPr sz="1100" b="1">
+                <a:solidFill>
+                  <a:srgbClr val="FFFFFF"/>
+                </a:solidFill>
+                <a:latin typeface="Georgia"/>
+              </a:rPr>
+              <a:t>CROSS-CHANNEL PRIORITIES + NEXT STEPS</a:t>
+            </a:r>
+          </a:p>
+        </p:txBody>
+      </p:sp>
+      <p:pic>
+        <p:nvPicPr>
+          <p:cNvPr id="5" name="Picture 4" descr="berelvant_logo.png"/>
+          <p:cNvPicPr>
+            <a:picLocks noChangeAspect="1"/>
+          </p:cNvPicPr>
+          <p:nvPr/>
+        </p:nvPicPr>
+        <p:blipFill>
+          <a:blip r:embed="rId2"/>
+          <a:stretch>
+            <a:fillRect/>
+          </a:stretch>
+        </p:blipFill>
+        <p:spPr>
+          <a:xfrm>
+            <a:off x="10728655" y="146304"/>
+            <a:ext cx="960120" cy="274320"/>
+          </a:xfrm>
+          <a:prstGeom prst="rect">
+            <a:avLst/>
+          </a:prstGeom>
+        </p:spPr>
+      </p:pic>
+      <p:sp>
+        <p:nvSpPr>
+          <p:cNvPr id="6" name="TextBox 5"/>
+          <p:cNvSpPr txBox="1"/>
+          <p:nvPr/>
+        </p:nvSpPr>
+        <p:spPr>
+          <a:xfrm>
+            <a:off x="457200" y="868680"/>
+            <a:ext cx="11247120" cy="685800"/>
+          </a:xfrm>
+          <a:prstGeom prst="rect">
+            <a:avLst/>
+          </a:prstGeom>
+          <a:noFill/>
+        </p:spPr>
+        <p:txBody>
+          <a:bodyPr wrap="square" anchor="t" lIns="0" rIns="0" tIns="0" bIns="0">
+            <a:spAutoFit/>
+          </a:bodyPr>
+          <a:lstStyle/>
+          <a:p>
+            <a:pPr algn="l"/>
+            <a:r>
+              <a:rPr sz="2000" b="1">
+                <a:solidFill>
+                  <a:srgbClr val="1E2761"/>
+                </a:solidFill>
+                <a:latin typeface="Georgia"/>
+              </a:rPr>
+              <a:t>August priorities: scale the rebuilt structure, complete measurement, hold inventory quality.</a:t>
+            </a:r>
+          </a:p>
+        </p:txBody>
+      </p:sp>
+      <p:sp>
+        <p:nvSpPr>
+          <p:cNvPr id="7" name="Rectangle 6"/>
+          <p:cNvSpPr/>
+          <p:nvPr/>
+        </p:nvSpPr>
+        <p:spPr>
+          <a:xfrm>
+            <a:off x="0" y="6583680"/>
+            <a:ext cx="12191695" cy="10972"/>
+          </a:xfrm>
+          <a:prstGeom prst="rect">
+            <a:avLst/>
+          </a:prstGeom>
+          <a:solidFill>
+            <a:srgbClr val="D0D4DC"/>
+          </a:solidFill>
+          <a:ln>
+            <a:noFill/>
+          </a:ln>
+          <a:effectLst/>
+        </p:spPr>
+        <p:style>
+          <a:lnRef idx="1">
+            <a:schemeClr val="accent1"/>
+          </a:lnRef>
+          <a:fillRef idx="3">
+            <a:schemeClr val="accent1"/>
+          </a:fillRef>
+          <a:effectRef idx="2">
+            <a:schemeClr val="accent1"/>
+          </a:effectRef>
+          <a:fontRef idx="minor">
+            <a:schemeClr val="lt1"/>
+          </a:fontRef>
+        </p:style>
+        <p:txBody>
+          <a:bodyPr rtlCol="0" anchor="ctr"/>
+          <a:lstStyle/>
+          <a:p>
+            <a:pPr algn="ctr"/>
+          </a:p>
+        </p:txBody>
+      </p:sp>
+      <p:sp>
+        <p:nvSpPr>
+          <p:cNvPr id="8" name="TextBox 7"/>
+          <p:cNvSpPr txBox="1"/>
+          <p:nvPr/>
+        </p:nvSpPr>
+        <p:spPr>
+          <a:xfrm>
+            <a:off x="457200" y="6656832"/>
+            <a:ext cx="7315200" cy="201168"/>
+          </a:xfrm>
+          <a:prstGeom prst="rect">
+            <a:avLst/>
+          </a:prstGeom>
+          <a:noFill/>
+        </p:spPr>
+        <p:txBody>
+          <a:bodyPr wrap="square" anchor="t" lIns="0" rIns="0" tIns="0" bIns="0">
+            <a:spAutoFit/>
+          </a:bodyPr>
+          <a:lstStyle/>
+          <a:p>
+            <a:pPr algn="l"/>
+            <a:r>
+              <a:rPr sz="800" b="0">
+                <a:solidFill>
+                  <a:srgbClr val="5A6072"/>
+                </a:solidFill>
+                <a:latin typeface="Calibri"/>
+              </a:rPr>
+              <a:t>GGMI (LATAM)   |   July 2026 Performance Review   |   Berelvant</a:t>
+            </a:r>
+          </a:p>
+        </p:txBody>
+      </p:sp>
+      <p:sp>
+        <p:nvSpPr>
+          <p:cNvPr id="9" name="TextBox 8"/>
+          <p:cNvSpPr txBox="1"/>
+          <p:nvPr/>
+        </p:nvSpPr>
+        <p:spPr>
+          <a:xfrm>
+            <a:off x="10820095" y="6656832"/>
+            <a:ext cx="914400" cy="201168"/>
+          </a:xfrm>
+          <a:prstGeom prst="rect">
+            <a:avLst/>
+          </a:prstGeom>
+          <a:noFill/>
+        </p:spPr>
+        <p:txBody>
+          <a:bodyPr wrap="square" anchor="t" lIns="0" rIns="0" tIns="0" bIns="0">
+            <a:spAutoFit/>
+          </a:bodyPr>
+          <a:lstStyle/>
+          <a:p>
+            <a:pPr algn="r"/>
+            <a:r>
+              <a:rPr sz="800" b="0">
+                <a:solidFill>
+                  <a:srgbClr val="5A6072"/>
+                </a:solidFill>
+                <a:latin typeface="Calibri"/>
+              </a:rPr>
+              <a:t>16 / 16</a:t>
             </a:r>
           </a:p>
         </p:txBody>
@@ -9899,7 +13615,7 @@
                 </a:solidFill>
                 <a:latin typeface="Calibri"/>
               </a:rPr>
-              <a:t>2 / 14</a:t>
+              <a:t>2 / 16</a:t>
             </a:r>
           </a:p>
         </p:txBody>
@@ -12663,7 +16379,7 @@
                 </a:solidFill>
                 <a:latin typeface="Calibri"/>
               </a:rPr>
-              <a:t>3 / 14</a:t>
+              <a:t>3 / 16</a:t>
             </a:r>
           </a:p>
         </p:txBody>
@@ -14514,7 +18230,7 @@
                 </a:solidFill>
                 <a:latin typeface="Calibri"/>
               </a:rPr>
-              <a:t>4 / 14</a:t>
+              <a:t>4 / 16</a:t>
             </a:r>
           </a:p>
         </p:txBody>
@@ -15058,7 +18774,7 @@
                 </a:solidFill>
                 <a:latin typeface="Calibri"/>
               </a:rPr>
-              <a:t>Both upper-funnel. Native reports spend and delivery with no conversion claim; DOOH reports spend only this cycle.</a:t>
+              <a:t>Both upper-funnel. Native reports spend and delivery with no conversion claim; DOOH reports delivery on its own slides.</a:t>
             </a:r>
           </a:p>
           <a:p>
@@ -15074,7 +18790,7 @@
                 </a:solidFill>
                 <a:latin typeface="Calibri"/>
               </a:rPr>
-              <a:t>Both report in full once a second month allows comparison.</a:t>
+              <a:t>Both gain a month-over-month read with a second month of data.</a:t>
             </a:r>
           </a:p>
         </p:txBody>
@@ -15467,7 +19183,7 @@
                 </a:solidFill>
                 <a:latin typeface="Calibri"/>
               </a:rPr>
-              <a:t>5 / 14</a:t>
+              <a:t>5 / 16</a:t>
             </a:r>
           </a:p>
         </p:txBody>
@@ -17513,7 +21229,7 @@
                 </a:solidFill>
                 <a:latin typeface="Calibri"/>
               </a:rPr>
-              <a:t>6 / 14</a:t>
+              <a:t>6 / 16</a:t>
             </a:r>
           </a:p>
         </p:txBody>
@@ -18195,7 +21911,7 @@
                 </a:solidFill>
                 <a:latin typeface="Calibri"/>
               </a:rPr>
-              <a:t>7 / 14</a:t>
+              <a:t>7 / 16</a:t>
             </a:r>
           </a:p>
         </p:txBody>
@@ -20047,7 +23763,7 @@
                 </a:solidFill>
                 <a:latin typeface="Calibri"/>
               </a:rPr>
-              <a:t>8 / 14</a:t>
+              <a:t>8 / 16</a:t>
             </a:r>
           </a:p>
         </p:txBody>
@@ -20729,7 +24445,7 @@
                 </a:solidFill>
                 <a:latin typeface="Calibri"/>
               </a:rPr>
-              <a:t>9 / 14</a:t>
+              <a:t>9 / 16</a:t>
             </a:r>
           </a:p>
         </p:txBody>

</xml_diff>

<commit_message>
DOOH venue-category table added with placeholders for vendor data
Co-Authored-By: Claude Fable 5 <noreply@anthropic.com>
</commit_message>
<xml_diff>
--- a/reports/forex/ggmi/2026-07/output/GGMI_LATAM_July_2026_Performance_Review.pptx
+++ b/reports/forex/ggmi/2026-07/output/GGMI_LATAM_July_2026_Performance_Review.pptx
@@ -9979,8 +9979,8 @@
           <p:nvPr/>
         </p:nvGraphicFramePr>
         <p:xfrm>
-          <a:off x="457200" y="3063240"/>
-          <a:ext cx="6766560" cy="2011680"/>
+          <a:off x="457200" y="2926080"/>
+          <a:ext cx="5669280" cy="1920240"/>
         </p:xfrm>
         <a:graphic>
           <a:graphicData uri="http://schemas.openxmlformats.org/drawingml/2006/table">
@@ -9989,13 +9989,13 @@
                 <a:tableStyleId>{5C22544A-7EE6-4342-B048-85BDC9FD1C3A}</a:tableStyleId>
               </a:tblPr>
               <a:tblGrid>
-                <a:gridCol w="1645920"/>
-                <a:gridCol w="1188720"/>
-                <a:gridCol w="1463040"/>
                 <a:gridCol w="1371600"/>
-                <a:gridCol w="1097280"/>
+                <a:gridCol w="960120"/>
+                <a:gridCol w="1234440"/>
+                <a:gridCol w="1143000"/>
+                <a:gridCol w="960120"/>
               </a:tblGrid>
-              <a:tr h="402336">
+              <a:tr h="384048">
                 <a:tc>
                   <a:txBody>
                     <a:bodyPr/>
@@ -10112,7 +10112,7 @@
                   </a:tcPr>
                 </a:tc>
               </a:tr>
-              <a:tr h="402336">
+              <a:tr h="384048">
                 <a:tc>
                   <a:txBody>
                     <a:bodyPr/>
@@ -10229,7 +10229,7 @@
                   </a:tcPr>
                 </a:tc>
               </a:tr>
-              <a:tr h="402336">
+              <a:tr h="384048">
                 <a:tc>
                   <a:txBody>
                     <a:bodyPr/>
@@ -10346,7 +10346,7 @@
                   </a:tcPr>
                 </a:tc>
               </a:tr>
-              <a:tr h="402336">
+              <a:tr h="384048">
                 <a:tc>
                   <a:txBody>
                     <a:bodyPr/>
@@ -10463,7 +10463,7 @@
                   </a:tcPr>
                 </a:tc>
               </a:tr>
-              <a:tr h="402336">
+              <a:tr h="384048">
                 <a:tc>
                   <a:txBody>
                     <a:bodyPr/>
@@ -10584,16 +10584,864 @@
           </a:graphicData>
         </a:graphic>
       </p:graphicFrame>
-      <p:sp>
-        <p:nvSpPr>
-          <p:cNvPr id="31" name="TextBox 30"/>
+      <p:graphicFrame>
+        <p:nvGraphicFramePr>
+          <p:cNvPr id="31" name="Table 30"/>
+          <p:cNvGraphicFramePr>
+            <a:graphicFrameLocks noGrp="1"/>
+          </p:cNvGraphicFramePr>
+          <p:nvPr/>
+        </p:nvGraphicFramePr>
+        <p:xfrm>
+          <a:off x="6400800" y="2926080"/>
+          <a:ext cx="5303520" cy="2240280"/>
+        </p:xfrm>
+        <a:graphic>
+          <a:graphicData uri="http://schemas.openxmlformats.org/drawingml/2006/table">
+            <a:tbl>
+              <a:tblPr>
+                <a:tableStyleId>{5C22544A-7EE6-4342-B048-85BDC9FD1C3A}</a:tableStyleId>
+              </a:tblPr>
+              <a:tblGrid>
+                <a:gridCol w="1828800"/>
+                <a:gridCol w="868680"/>
+                <a:gridCol w="868680"/>
+                <a:gridCol w="868680"/>
+                <a:gridCol w="868680"/>
+              </a:tblGrid>
+              <a:tr h="320040">
+                <a:tc>
+                  <a:txBody>
+                    <a:bodyPr/>
+                    <a:lstStyle/>
+                    <a:p>
+                      <a:pPr algn="l"/>
+                      <a:r>
+                        <a:rPr sz="850" b="1">
+                          <a:solidFill>
+                            <a:srgbClr val="FFFFFF"/>
+                          </a:solidFill>
+                          <a:latin typeface="Calibri"/>
+                        </a:rPr>
+                        <a:t>Category</a:t>
+                      </a:r>
+                    </a:p>
+                  </a:txBody>
+                  <a:tcPr marL="54864" marR="54864" marT="27432" marB="27432">
+                    <a:solidFill>
+                      <a:srgbClr val="1E2761"/>
+                    </a:solidFill>
+                  </a:tcPr>
+                </a:tc>
+                <a:tc>
+                  <a:txBody>
+                    <a:bodyPr/>
+                    <a:lstStyle/>
+                    <a:p>
+                      <a:pPr algn="r"/>
+                      <a:r>
+                        <a:rPr sz="850" b="1">
+                          <a:solidFill>
+                            <a:srgbClr val="FFFFFF"/>
+                          </a:solidFill>
+                          <a:latin typeface="Calibri"/>
+                        </a:rPr>
+                        <a:t>Mexico City</a:t>
+                      </a:r>
+                    </a:p>
+                  </a:txBody>
+                  <a:tcPr marL="54864" marR="54864" marT="27432" marB="27432">
+                    <a:solidFill>
+                      <a:srgbClr val="1E2761"/>
+                    </a:solidFill>
+                  </a:tcPr>
+                </a:tc>
+                <a:tc>
+                  <a:txBody>
+                    <a:bodyPr/>
+                    <a:lstStyle/>
+                    <a:p>
+                      <a:pPr algn="r"/>
+                      <a:r>
+                        <a:rPr sz="850" b="1">
+                          <a:solidFill>
+                            <a:srgbClr val="FFFFFF"/>
+                          </a:solidFill>
+                          <a:latin typeface="Calibri"/>
+                        </a:rPr>
+                        <a:t>Guadalajara</a:t>
+                      </a:r>
+                    </a:p>
+                  </a:txBody>
+                  <a:tcPr marL="54864" marR="54864" marT="27432" marB="27432">
+                    <a:solidFill>
+                      <a:srgbClr val="1E2761"/>
+                    </a:solidFill>
+                  </a:tcPr>
+                </a:tc>
+                <a:tc>
+                  <a:txBody>
+                    <a:bodyPr/>
+                    <a:lstStyle/>
+                    <a:p>
+                      <a:pPr algn="r"/>
+                      <a:r>
+                        <a:rPr sz="850" b="1">
+                          <a:solidFill>
+                            <a:srgbClr val="FFFFFF"/>
+                          </a:solidFill>
+                          <a:latin typeface="Calibri"/>
+                        </a:rPr>
+                        <a:t>Monterrey</a:t>
+                      </a:r>
+                    </a:p>
+                  </a:txBody>
+                  <a:tcPr marL="54864" marR="54864" marT="27432" marB="27432">
+                    <a:solidFill>
+                      <a:srgbClr val="1E2761"/>
+                    </a:solidFill>
+                  </a:tcPr>
+                </a:tc>
+                <a:tc>
+                  <a:txBody>
+                    <a:bodyPr/>
+                    <a:lstStyle/>
+                    <a:p>
+                      <a:pPr algn="r"/>
+                      <a:r>
+                        <a:rPr sz="850" b="1">
+                          <a:solidFill>
+                            <a:srgbClr val="FFFFFF"/>
+                          </a:solidFill>
+                          <a:latin typeface="Calibri"/>
+                        </a:rPr>
+                        <a:t>Total</a:t>
+                      </a:r>
+                    </a:p>
+                  </a:txBody>
+                  <a:tcPr marL="54864" marR="54864" marT="27432" marB="27432">
+                    <a:solidFill>
+                      <a:srgbClr val="1E2761"/>
+                    </a:solidFill>
+                  </a:tcPr>
+                </a:tc>
+              </a:tr>
+              <a:tr h="320040">
+                <a:tc>
+                  <a:txBody>
+                    <a:bodyPr/>
+                    <a:lstStyle/>
+                    <a:p>
+                      <a:pPr algn="l"/>
+                      <a:r>
+                        <a:rPr sz="850" b="1">
+                          <a:solidFill>
+                            <a:srgbClr val="2B3147"/>
+                          </a:solidFill>
+                          <a:latin typeface="Calibri"/>
+                        </a:rPr>
+                        <a:t>Airport</a:t>
+                      </a:r>
+                    </a:p>
+                  </a:txBody>
+                  <a:tcPr marL="54864" marR="54864" marT="27432" marB="27432">
+                    <a:solidFill>
+                      <a:srgbClr val="FFFFFF"/>
+                    </a:solidFill>
+                  </a:tcPr>
+                </a:tc>
+                <a:tc>
+                  <a:txBody>
+                    <a:bodyPr/>
+                    <a:lstStyle/>
+                    <a:p>
+                      <a:pPr algn="r"/>
+                      <a:r>
+                        <a:rPr sz="850" b="0">
+                          <a:solidFill>
+                            <a:srgbClr val="2B3147"/>
+                          </a:solidFill>
+                          <a:latin typeface="Calibri"/>
+                        </a:rPr>
+                        <a:t>—</a:t>
+                      </a:r>
+                    </a:p>
+                  </a:txBody>
+                  <a:tcPr marL="54864" marR="54864" marT="27432" marB="27432">
+                    <a:solidFill>
+                      <a:srgbClr val="FFFFFF"/>
+                    </a:solidFill>
+                  </a:tcPr>
+                </a:tc>
+                <a:tc>
+                  <a:txBody>
+                    <a:bodyPr/>
+                    <a:lstStyle/>
+                    <a:p>
+                      <a:pPr algn="r"/>
+                      <a:r>
+                        <a:rPr sz="850" b="0">
+                          <a:solidFill>
+                            <a:srgbClr val="2B3147"/>
+                          </a:solidFill>
+                          <a:latin typeface="Calibri"/>
+                        </a:rPr>
+                        <a:t>—</a:t>
+                      </a:r>
+                    </a:p>
+                  </a:txBody>
+                  <a:tcPr marL="54864" marR="54864" marT="27432" marB="27432">
+                    <a:solidFill>
+                      <a:srgbClr val="FFFFFF"/>
+                    </a:solidFill>
+                  </a:tcPr>
+                </a:tc>
+                <a:tc>
+                  <a:txBody>
+                    <a:bodyPr/>
+                    <a:lstStyle/>
+                    <a:p>
+                      <a:pPr algn="r"/>
+                      <a:r>
+                        <a:rPr sz="850" b="0">
+                          <a:solidFill>
+                            <a:srgbClr val="2B3147"/>
+                          </a:solidFill>
+                          <a:latin typeface="Calibri"/>
+                        </a:rPr>
+                        <a:t>—</a:t>
+                      </a:r>
+                    </a:p>
+                  </a:txBody>
+                  <a:tcPr marL="54864" marR="54864" marT="27432" marB="27432">
+                    <a:solidFill>
+                      <a:srgbClr val="FFFFFF"/>
+                    </a:solidFill>
+                  </a:tcPr>
+                </a:tc>
+                <a:tc>
+                  <a:txBody>
+                    <a:bodyPr/>
+                    <a:lstStyle/>
+                    <a:p>
+                      <a:pPr algn="r"/>
+                      <a:r>
+                        <a:rPr sz="850" b="0">
+                          <a:solidFill>
+                            <a:srgbClr val="2B3147"/>
+                          </a:solidFill>
+                          <a:latin typeface="Calibri"/>
+                        </a:rPr>
+                        <a:t>—</a:t>
+                      </a:r>
+                    </a:p>
+                  </a:txBody>
+                  <a:tcPr marL="54864" marR="54864" marT="27432" marB="27432">
+                    <a:solidFill>
+                      <a:srgbClr val="FFFFFF"/>
+                    </a:solidFill>
+                  </a:tcPr>
+                </a:tc>
+              </a:tr>
+              <a:tr h="320040">
+                <a:tc>
+                  <a:txBody>
+                    <a:bodyPr/>
+                    <a:lstStyle/>
+                    <a:p>
+                      <a:pPr algn="l"/>
+                      <a:r>
+                        <a:rPr sz="850" b="1">
+                          <a:solidFill>
+                            <a:srgbClr val="2B3147"/>
+                          </a:solidFill>
+                          <a:latin typeface="Calibri"/>
+                        </a:rPr>
+                        <a:t>Main Avenue / Roadside</a:t>
+                      </a:r>
+                    </a:p>
+                  </a:txBody>
+                  <a:tcPr marL="54864" marR="54864" marT="27432" marB="27432">
+                    <a:solidFill>
+                      <a:srgbClr val="F9FAFC"/>
+                    </a:solidFill>
+                  </a:tcPr>
+                </a:tc>
+                <a:tc>
+                  <a:txBody>
+                    <a:bodyPr/>
+                    <a:lstStyle/>
+                    <a:p>
+                      <a:pPr algn="r"/>
+                      <a:r>
+                        <a:rPr sz="850" b="0">
+                          <a:solidFill>
+                            <a:srgbClr val="2B3147"/>
+                          </a:solidFill>
+                          <a:latin typeface="Calibri"/>
+                        </a:rPr>
+                        <a:t>—</a:t>
+                      </a:r>
+                    </a:p>
+                  </a:txBody>
+                  <a:tcPr marL="54864" marR="54864" marT="27432" marB="27432">
+                    <a:solidFill>
+                      <a:srgbClr val="F9FAFC"/>
+                    </a:solidFill>
+                  </a:tcPr>
+                </a:tc>
+                <a:tc>
+                  <a:txBody>
+                    <a:bodyPr/>
+                    <a:lstStyle/>
+                    <a:p>
+                      <a:pPr algn="r"/>
+                      <a:r>
+                        <a:rPr sz="850" b="0">
+                          <a:solidFill>
+                            <a:srgbClr val="2B3147"/>
+                          </a:solidFill>
+                          <a:latin typeface="Calibri"/>
+                        </a:rPr>
+                        <a:t>—</a:t>
+                      </a:r>
+                    </a:p>
+                  </a:txBody>
+                  <a:tcPr marL="54864" marR="54864" marT="27432" marB="27432">
+                    <a:solidFill>
+                      <a:srgbClr val="F9FAFC"/>
+                    </a:solidFill>
+                  </a:tcPr>
+                </a:tc>
+                <a:tc>
+                  <a:txBody>
+                    <a:bodyPr/>
+                    <a:lstStyle/>
+                    <a:p>
+                      <a:pPr algn="r"/>
+                      <a:r>
+                        <a:rPr sz="850" b="0">
+                          <a:solidFill>
+                            <a:srgbClr val="2B3147"/>
+                          </a:solidFill>
+                          <a:latin typeface="Calibri"/>
+                        </a:rPr>
+                        <a:t>—</a:t>
+                      </a:r>
+                    </a:p>
+                  </a:txBody>
+                  <a:tcPr marL="54864" marR="54864" marT="27432" marB="27432">
+                    <a:solidFill>
+                      <a:srgbClr val="F9FAFC"/>
+                    </a:solidFill>
+                  </a:tcPr>
+                </a:tc>
+                <a:tc>
+                  <a:txBody>
+                    <a:bodyPr/>
+                    <a:lstStyle/>
+                    <a:p>
+                      <a:pPr algn="r"/>
+                      <a:r>
+                        <a:rPr sz="850" b="0">
+                          <a:solidFill>
+                            <a:srgbClr val="2B3147"/>
+                          </a:solidFill>
+                          <a:latin typeface="Calibri"/>
+                        </a:rPr>
+                        <a:t>—</a:t>
+                      </a:r>
+                    </a:p>
+                  </a:txBody>
+                  <a:tcPr marL="54864" marR="54864" marT="27432" marB="27432">
+                    <a:solidFill>
+                      <a:srgbClr val="F9FAFC"/>
+                    </a:solidFill>
+                  </a:tcPr>
+                </a:tc>
+              </a:tr>
+              <a:tr h="320040">
+                <a:tc>
+                  <a:txBody>
+                    <a:bodyPr/>
+                    <a:lstStyle/>
+                    <a:p>
+                      <a:pPr algn="l"/>
+                      <a:r>
+                        <a:rPr sz="850" b="1">
+                          <a:solidFill>
+                            <a:srgbClr val="2B3147"/>
+                          </a:solidFill>
+                          <a:latin typeface="Calibri"/>
+                        </a:rPr>
+                        <a:t>Shopping Mall / Retail</a:t>
+                      </a:r>
+                    </a:p>
+                  </a:txBody>
+                  <a:tcPr marL="54864" marR="54864" marT="27432" marB="27432">
+                    <a:solidFill>
+                      <a:srgbClr val="FFFFFF"/>
+                    </a:solidFill>
+                  </a:tcPr>
+                </a:tc>
+                <a:tc>
+                  <a:txBody>
+                    <a:bodyPr/>
+                    <a:lstStyle/>
+                    <a:p>
+                      <a:pPr algn="r"/>
+                      <a:r>
+                        <a:rPr sz="850" b="0">
+                          <a:solidFill>
+                            <a:srgbClr val="2B3147"/>
+                          </a:solidFill>
+                          <a:latin typeface="Calibri"/>
+                        </a:rPr>
+                        <a:t>—</a:t>
+                      </a:r>
+                    </a:p>
+                  </a:txBody>
+                  <a:tcPr marL="54864" marR="54864" marT="27432" marB="27432">
+                    <a:solidFill>
+                      <a:srgbClr val="FFFFFF"/>
+                    </a:solidFill>
+                  </a:tcPr>
+                </a:tc>
+                <a:tc>
+                  <a:txBody>
+                    <a:bodyPr/>
+                    <a:lstStyle/>
+                    <a:p>
+                      <a:pPr algn="r"/>
+                      <a:r>
+                        <a:rPr sz="850" b="0">
+                          <a:solidFill>
+                            <a:srgbClr val="2B3147"/>
+                          </a:solidFill>
+                          <a:latin typeface="Calibri"/>
+                        </a:rPr>
+                        <a:t>—</a:t>
+                      </a:r>
+                    </a:p>
+                  </a:txBody>
+                  <a:tcPr marL="54864" marR="54864" marT="27432" marB="27432">
+                    <a:solidFill>
+                      <a:srgbClr val="FFFFFF"/>
+                    </a:solidFill>
+                  </a:tcPr>
+                </a:tc>
+                <a:tc>
+                  <a:txBody>
+                    <a:bodyPr/>
+                    <a:lstStyle/>
+                    <a:p>
+                      <a:pPr algn="r"/>
+                      <a:r>
+                        <a:rPr sz="850" b="0">
+                          <a:solidFill>
+                            <a:srgbClr val="2B3147"/>
+                          </a:solidFill>
+                          <a:latin typeface="Calibri"/>
+                        </a:rPr>
+                        <a:t>—</a:t>
+                      </a:r>
+                    </a:p>
+                  </a:txBody>
+                  <a:tcPr marL="54864" marR="54864" marT="27432" marB="27432">
+                    <a:solidFill>
+                      <a:srgbClr val="FFFFFF"/>
+                    </a:solidFill>
+                  </a:tcPr>
+                </a:tc>
+                <a:tc>
+                  <a:txBody>
+                    <a:bodyPr/>
+                    <a:lstStyle/>
+                    <a:p>
+                      <a:pPr algn="r"/>
+                      <a:r>
+                        <a:rPr sz="850" b="0">
+                          <a:solidFill>
+                            <a:srgbClr val="2B3147"/>
+                          </a:solidFill>
+                          <a:latin typeface="Calibri"/>
+                        </a:rPr>
+                        <a:t>—</a:t>
+                      </a:r>
+                    </a:p>
+                  </a:txBody>
+                  <a:tcPr marL="54864" marR="54864" marT="27432" marB="27432">
+                    <a:solidFill>
+                      <a:srgbClr val="FFFFFF"/>
+                    </a:solidFill>
+                  </a:tcPr>
+                </a:tc>
+              </a:tr>
+              <a:tr h="320040">
+                <a:tc>
+                  <a:txBody>
+                    <a:bodyPr/>
+                    <a:lstStyle/>
+                    <a:p>
+                      <a:pPr algn="l"/>
+                      <a:r>
+                        <a:rPr sz="850" b="1">
+                          <a:solidFill>
+                            <a:srgbClr val="2B3147"/>
+                          </a:solidFill>
+                          <a:latin typeface="Calibri"/>
+                        </a:rPr>
+                        <a:t>Leisure &amp; Hospitality</a:t>
+                      </a:r>
+                    </a:p>
+                  </a:txBody>
+                  <a:tcPr marL="54864" marR="54864" marT="27432" marB="27432">
+                    <a:solidFill>
+                      <a:srgbClr val="F9FAFC"/>
+                    </a:solidFill>
+                  </a:tcPr>
+                </a:tc>
+                <a:tc>
+                  <a:txBody>
+                    <a:bodyPr/>
+                    <a:lstStyle/>
+                    <a:p>
+                      <a:pPr algn="r"/>
+                      <a:r>
+                        <a:rPr sz="850" b="0">
+                          <a:solidFill>
+                            <a:srgbClr val="2B3147"/>
+                          </a:solidFill>
+                          <a:latin typeface="Calibri"/>
+                        </a:rPr>
+                        <a:t>—</a:t>
+                      </a:r>
+                    </a:p>
+                  </a:txBody>
+                  <a:tcPr marL="54864" marR="54864" marT="27432" marB="27432">
+                    <a:solidFill>
+                      <a:srgbClr val="F9FAFC"/>
+                    </a:solidFill>
+                  </a:tcPr>
+                </a:tc>
+                <a:tc>
+                  <a:txBody>
+                    <a:bodyPr/>
+                    <a:lstStyle/>
+                    <a:p>
+                      <a:pPr algn="r"/>
+                      <a:r>
+                        <a:rPr sz="850" b="0">
+                          <a:solidFill>
+                            <a:srgbClr val="2B3147"/>
+                          </a:solidFill>
+                          <a:latin typeface="Calibri"/>
+                        </a:rPr>
+                        <a:t>—</a:t>
+                      </a:r>
+                    </a:p>
+                  </a:txBody>
+                  <a:tcPr marL="54864" marR="54864" marT="27432" marB="27432">
+                    <a:solidFill>
+                      <a:srgbClr val="F9FAFC"/>
+                    </a:solidFill>
+                  </a:tcPr>
+                </a:tc>
+                <a:tc>
+                  <a:txBody>
+                    <a:bodyPr/>
+                    <a:lstStyle/>
+                    <a:p>
+                      <a:pPr algn="r"/>
+                      <a:r>
+                        <a:rPr sz="850" b="0">
+                          <a:solidFill>
+                            <a:srgbClr val="2B3147"/>
+                          </a:solidFill>
+                          <a:latin typeface="Calibri"/>
+                        </a:rPr>
+                        <a:t>—</a:t>
+                      </a:r>
+                    </a:p>
+                  </a:txBody>
+                  <a:tcPr marL="54864" marR="54864" marT="27432" marB="27432">
+                    <a:solidFill>
+                      <a:srgbClr val="F9FAFC"/>
+                    </a:solidFill>
+                  </a:tcPr>
+                </a:tc>
+                <a:tc>
+                  <a:txBody>
+                    <a:bodyPr/>
+                    <a:lstStyle/>
+                    <a:p>
+                      <a:pPr algn="r"/>
+                      <a:r>
+                        <a:rPr sz="850" b="0">
+                          <a:solidFill>
+                            <a:srgbClr val="2B3147"/>
+                          </a:solidFill>
+                          <a:latin typeface="Calibri"/>
+                        </a:rPr>
+                        <a:t>—</a:t>
+                      </a:r>
+                    </a:p>
+                  </a:txBody>
+                  <a:tcPr marL="54864" marR="54864" marT="27432" marB="27432">
+                    <a:solidFill>
+                      <a:srgbClr val="F9FAFC"/>
+                    </a:solidFill>
+                  </a:tcPr>
+                </a:tc>
+              </a:tr>
+              <a:tr h="320040">
+                <a:tc>
+                  <a:txBody>
+                    <a:bodyPr/>
+                    <a:lstStyle/>
+                    <a:p>
+                      <a:pPr algn="l"/>
+                      <a:r>
+                        <a:rPr sz="850" b="1">
+                          <a:solidFill>
+                            <a:srgbClr val="2B3147"/>
+                          </a:solidFill>
+                          <a:latin typeface="Calibri"/>
+                        </a:rPr>
+                        <a:t>Other</a:t>
+                      </a:r>
+                    </a:p>
+                  </a:txBody>
+                  <a:tcPr marL="54864" marR="54864" marT="27432" marB="27432">
+                    <a:solidFill>
+                      <a:srgbClr val="FFFFFF"/>
+                    </a:solidFill>
+                  </a:tcPr>
+                </a:tc>
+                <a:tc>
+                  <a:txBody>
+                    <a:bodyPr/>
+                    <a:lstStyle/>
+                    <a:p>
+                      <a:pPr algn="r"/>
+                      <a:r>
+                        <a:rPr sz="850" b="0">
+                          <a:solidFill>
+                            <a:srgbClr val="2B3147"/>
+                          </a:solidFill>
+                          <a:latin typeface="Calibri"/>
+                        </a:rPr>
+                        <a:t>—</a:t>
+                      </a:r>
+                    </a:p>
+                  </a:txBody>
+                  <a:tcPr marL="54864" marR="54864" marT="27432" marB="27432">
+                    <a:solidFill>
+                      <a:srgbClr val="FFFFFF"/>
+                    </a:solidFill>
+                  </a:tcPr>
+                </a:tc>
+                <a:tc>
+                  <a:txBody>
+                    <a:bodyPr/>
+                    <a:lstStyle/>
+                    <a:p>
+                      <a:pPr algn="r"/>
+                      <a:r>
+                        <a:rPr sz="850" b="0">
+                          <a:solidFill>
+                            <a:srgbClr val="2B3147"/>
+                          </a:solidFill>
+                          <a:latin typeface="Calibri"/>
+                        </a:rPr>
+                        <a:t>—</a:t>
+                      </a:r>
+                    </a:p>
+                  </a:txBody>
+                  <a:tcPr marL="54864" marR="54864" marT="27432" marB="27432">
+                    <a:solidFill>
+                      <a:srgbClr val="FFFFFF"/>
+                    </a:solidFill>
+                  </a:tcPr>
+                </a:tc>
+                <a:tc>
+                  <a:txBody>
+                    <a:bodyPr/>
+                    <a:lstStyle/>
+                    <a:p>
+                      <a:pPr algn="r"/>
+                      <a:r>
+                        <a:rPr sz="850" b="0">
+                          <a:solidFill>
+                            <a:srgbClr val="2B3147"/>
+                          </a:solidFill>
+                          <a:latin typeface="Calibri"/>
+                        </a:rPr>
+                        <a:t>—</a:t>
+                      </a:r>
+                    </a:p>
+                  </a:txBody>
+                  <a:tcPr marL="54864" marR="54864" marT="27432" marB="27432">
+                    <a:solidFill>
+                      <a:srgbClr val="FFFFFF"/>
+                    </a:solidFill>
+                  </a:tcPr>
+                </a:tc>
+                <a:tc>
+                  <a:txBody>
+                    <a:bodyPr/>
+                    <a:lstStyle/>
+                    <a:p>
+                      <a:pPr algn="r"/>
+                      <a:r>
+                        <a:rPr sz="850" b="0">
+                          <a:solidFill>
+                            <a:srgbClr val="2B3147"/>
+                          </a:solidFill>
+                          <a:latin typeface="Calibri"/>
+                        </a:rPr>
+                        <a:t>—</a:t>
+                      </a:r>
+                    </a:p>
+                  </a:txBody>
+                  <a:tcPr marL="54864" marR="54864" marT="27432" marB="27432">
+                    <a:solidFill>
+                      <a:srgbClr val="FFFFFF"/>
+                    </a:solidFill>
+                  </a:tcPr>
+                </a:tc>
+              </a:tr>
+              <a:tr h="320040">
+                <a:tc>
+                  <a:txBody>
+                    <a:bodyPr/>
+                    <a:lstStyle/>
+                    <a:p>
+                      <a:pPr algn="l"/>
+                      <a:r>
+                        <a:rPr sz="850" b="1">
+                          <a:solidFill>
+                            <a:srgbClr val="1E2761"/>
+                          </a:solidFill>
+                          <a:latin typeface="Calibri"/>
+                        </a:rPr>
+                        <a:t>City impressions</a:t>
+                      </a:r>
+                    </a:p>
+                  </a:txBody>
+                  <a:tcPr marL="54864" marR="54864" marT="27432" marB="27432">
+                    <a:solidFill>
+                      <a:srgbClr val="CADCFC"/>
+                    </a:solidFill>
+                  </a:tcPr>
+                </a:tc>
+                <a:tc>
+                  <a:txBody>
+                    <a:bodyPr/>
+                    <a:lstStyle/>
+                    <a:p>
+                      <a:pPr algn="r"/>
+                      <a:r>
+                        <a:rPr sz="850" b="1">
+                          <a:solidFill>
+                            <a:srgbClr val="1E2761"/>
+                          </a:solidFill>
+                          <a:latin typeface="Calibri"/>
+                        </a:rPr>
+                        <a:t>825,383</a:t>
+                      </a:r>
+                    </a:p>
+                  </a:txBody>
+                  <a:tcPr marL="54864" marR="54864" marT="27432" marB="27432">
+                    <a:solidFill>
+                      <a:srgbClr val="CADCFC"/>
+                    </a:solidFill>
+                  </a:tcPr>
+                </a:tc>
+                <a:tc>
+                  <a:txBody>
+                    <a:bodyPr/>
+                    <a:lstStyle/>
+                    <a:p>
+                      <a:pPr algn="r"/>
+                      <a:r>
+                        <a:rPr sz="850" b="1">
+                          <a:solidFill>
+                            <a:srgbClr val="1E2761"/>
+                          </a:solidFill>
+                          <a:latin typeface="Calibri"/>
+                        </a:rPr>
+                        <a:t>314,817</a:t>
+                      </a:r>
+                    </a:p>
+                  </a:txBody>
+                  <a:tcPr marL="54864" marR="54864" marT="27432" marB="27432">
+                    <a:solidFill>
+                      <a:srgbClr val="CADCFC"/>
+                    </a:solidFill>
+                  </a:tcPr>
+                </a:tc>
+                <a:tc>
+                  <a:txBody>
+                    <a:bodyPr/>
+                    <a:lstStyle/>
+                    <a:p>
+                      <a:pPr algn="r"/>
+                      <a:r>
+                        <a:rPr sz="850" b="1">
+                          <a:solidFill>
+                            <a:srgbClr val="1E2761"/>
+                          </a:solidFill>
+                          <a:latin typeface="Calibri"/>
+                        </a:rPr>
+                        <a:t>265,905</a:t>
+                      </a:r>
+                    </a:p>
+                  </a:txBody>
+                  <a:tcPr marL="54864" marR="54864" marT="27432" marB="27432">
+                    <a:solidFill>
+                      <a:srgbClr val="CADCFC"/>
+                    </a:solidFill>
+                  </a:tcPr>
+                </a:tc>
+                <a:tc>
+                  <a:txBody>
+                    <a:bodyPr/>
+                    <a:lstStyle/>
+                    <a:p>
+                      <a:pPr algn="r"/>
+                      <a:r>
+                        <a:rPr sz="850" b="1">
+                          <a:solidFill>
+                            <a:srgbClr val="1E2761"/>
+                          </a:solidFill>
+                          <a:latin typeface="Calibri"/>
+                        </a:rPr>
+                        <a:t>1,406,105</a:t>
+                      </a:r>
+                    </a:p>
+                  </a:txBody>
+                  <a:tcPr marL="54864" marR="54864" marT="27432" marB="27432">
+                    <a:solidFill>
+                      <a:srgbClr val="CADCFC"/>
+                    </a:solidFill>
+                  </a:tcPr>
+                </a:tc>
+              </a:tr>
+            </a:tbl>
+          </a:graphicData>
+        </a:graphic>
+      </p:graphicFrame>
+      <p:sp>
+        <p:nvSpPr>
+          <p:cNvPr id="32" name="TextBox 31"/>
           <p:cNvSpPr txBox="1"/>
           <p:nvPr/>
         </p:nvSpPr>
         <p:spPr>
           <a:xfrm>
-            <a:off x="457200" y="5212080"/>
-            <a:ext cx="6766560" cy="457200"/>
+            <a:off x="457200" y="5440680"/>
+            <a:ext cx="11247120" cy="457200"/>
           </a:xfrm>
           <a:prstGeom prst="rect">
             <a:avLst/>
@@ -10614,183 +11462,7 @@
                 </a:solidFill>
                 <a:latin typeface="Calibri"/>
               </a:rPr>
-              <a:t>Impressions are opportunities to see. Estimated reach applies an average frequency of 1.8 to impressions, the same model as the June report. Spend per the client budget tracker; share is the impression share.</a:t>
-            </a:r>
-          </a:p>
-        </p:txBody>
-      </p:sp>
-      <p:sp>
-        <p:nvSpPr>
-          <p:cNvPr id="32" name="Rectangle 31"/>
-          <p:cNvSpPr/>
-          <p:nvPr/>
-        </p:nvSpPr>
-        <p:spPr>
-          <a:xfrm>
-            <a:off x="7406640" y="3063240"/>
-            <a:ext cx="4297680" cy="2606040"/>
-          </a:xfrm>
-          <a:prstGeom prst="rect">
-            <a:avLst/>
-          </a:prstGeom>
-          <a:solidFill>
-            <a:srgbClr val="FFFFFF"/>
-          </a:solidFill>
-          <a:ln w="9525">
-            <a:solidFill>
-              <a:srgbClr val="D0D4DC"/>
-            </a:solidFill>
-          </a:ln>
-          <a:effectLst/>
-        </p:spPr>
-        <p:style>
-          <a:lnRef idx="1">
-            <a:schemeClr val="accent1"/>
-          </a:lnRef>
-          <a:fillRef idx="3">
-            <a:schemeClr val="accent1"/>
-          </a:fillRef>
-          <a:effectRef idx="2">
-            <a:schemeClr val="accent1"/>
-          </a:effectRef>
-          <a:fontRef idx="minor">
-            <a:schemeClr val="lt1"/>
-          </a:fontRef>
-        </p:style>
-        <p:txBody>
-          <a:bodyPr rtlCol="0" anchor="ctr"/>
-          <a:lstStyle/>
-          <a:p>
-            <a:pPr algn="ctr"/>
-          </a:p>
-        </p:txBody>
-      </p:sp>
-      <p:sp>
-        <p:nvSpPr>
-          <p:cNvPr id="33" name="Rectangle 32"/>
-          <p:cNvSpPr/>
-          <p:nvPr/>
-        </p:nvSpPr>
-        <p:spPr>
-          <a:xfrm>
-            <a:off x="7406640" y="3063240"/>
-            <a:ext cx="64008" cy="2606040"/>
-          </a:xfrm>
-          <a:prstGeom prst="rect">
-            <a:avLst/>
-          </a:prstGeom>
-          <a:solidFill>
-            <a:srgbClr val="2E7D57"/>
-          </a:solidFill>
-          <a:ln>
-            <a:noFill/>
-          </a:ln>
-          <a:effectLst/>
-        </p:spPr>
-        <p:style>
-          <a:lnRef idx="1">
-            <a:schemeClr val="accent1"/>
-          </a:lnRef>
-          <a:fillRef idx="3">
-            <a:schemeClr val="accent1"/>
-          </a:fillRef>
-          <a:effectRef idx="2">
-            <a:schemeClr val="accent1"/>
-          </a:effectRef>
-          <a:fontRef idx="minor">
-            <a:schemeClr val="lt1"/>
-          </a:fontRef>
-        </p:style>
-        <p:txBody>
-          <a:bodyPr rtlCol="0" anchor="ctr"/>
-          <a:lstStyle/>
-          <a:p>
-            <a:pPr algn="ctr"/>
-          </a:p>
-        </p:txBody>
-      </p:sp>
-      <p:sp>
-        <p:nvSpPr>
-          <p:cNvPr id="34" name="TextBox 33"/>
-          <p:cNvSpPr txBox="1"/>
-          <p:nvPr/>
-        </p:nvSpPr>
-        <p:spPr>
-          <a:xfrm>
-            <a:off x="7626096" y="3227832"/>
-            <a:ext cx="3895344" cy="274320"/>
-          </a:xfrm>
-          <a:prstGeom prst="rect">
-            <a:avLst/>
-          </a:prstGeom>
-          <a:noFill/>
-        </p:spPr>
-        <p:txBody>
-          <a:bodyPr wrap="square" anchor="t" lIns="0" rIns="0" tIns="0" bIns="0">
-            <a:spAutoFit/>
-          </a:bodyPr>
-          <a:lstStyle/>
-          <a:p>
-            <a:pPr algn="l"/>
-            <a:r>
-              <a:rPr sz="1000" b="1">
-                <a:solidFill>
-                  <a:srgbClr val="1E2761"/>
-                </a:solidFill>
-                <a:latin typeface="Georgia"/>
-              </a:rPr>
-              <a:t>WHAT THE DATA SHOWS</a:t>
-            </a:r>
-          </a:p>
-        </p:txBody>
-      </p:sp>
-      <p:sp>
-        <p:nvSpPr>
-          <p:cNvPr id="35" name="TextBox 34"/>
-          <p:cNvSpPr txBox="1"/>
-          <p:nvPr/>
-        </p:nvSpPr>
-        <p:spPr>
-          <a:xfrm>
-            <a:off x="7626096" y="3566160"/>
-            <a:ext cx="3895344" cy="1920240"/>
-          </a:xfrm>
-          <a:prstGeom prst="rect">
-            <a:avLst/>
-          </a:prstGeom>
-          <a:noFill/>
-        </p:spPr>
-        <p:txBody>
-          <a:bodyPr wrap="square" anchor="t" lIns="0" rIns="0" tIns="0" bIns="0">
-            <a:spAutoFit/>
-          </a:bodyPr>
-          <a:lstStyle/>
-          <a:p>
-            <a:pPr algn="l"/>
-            <a:r>
-              <a:rPr sz="950" b="0">
-                <a:solidFill>
-                  <a:srgbClr val="2B3147"/>
-                </a:solidFill>
-                <a:latin typeface="Calibri"/>
-              </a:rPr>
-              <a:t>Delivery concentrated where the audience is largest: Mexico City took 59% of impressions at the same CPM as the other markets.</a:t>
-            </a:r>
-          </a:p>
-          <a:p>
-            <a:pPr algn="l">
-              <a:spcBef>
-                <a:spcPts val="600"/>
-              </a:spcBef>
-            </a:pPr>
-            <a:r>
-              <a:rPr sz="950" b="0">
-                <a:solidFill>
-                  <a:srgbClr val="2B3147"/>
-                </a:solidFill>
-                <a:latin typeface="Calibri"/>
-              </a:rPr>
-              <a:t>All three markets delivered the full month with no gaps in the daily record.</a:t>
+              <a:t>Impressions are opportunities to see. Estimated reach applies an average frequency of 1.8 to impressions, the same model as the June report. Spend per the client budget tracker; share is the impression share. Venue mix follows with the vendor placement detail.</a:t>
             </a:r>
           </a:p>
         </p:txBody>

</xml_diff>

<commit_message>
Headlines rewritten to June number-first voice per Renzo tone correction
Co-Authored-By: Claude Fable 5 <noreply@anthropic.com>
</commit_message>
<xml_diff>
--- a/reports/forex/ggmi/2026-07/output/GGMI_LATAM_July_2026_Performance_Review.pptx
+++ b/reports/forex/ggmi/2026-07/output/GGMI_LATAM_July_2026_Performance_Review.pptx
@@ -3939,7 +3939,7 @@
                 </a:solidFill>
                 <a:latin typeface="Georgia"/>
               </a:rPr>
-              <a:t>Judge the channel at the monthly level. Close out the vendor confirmation.</a:t>
+              <a:t>Hold the pace. Confirm the delivery detail.</a:t>
             </a:r>
           </a:p>
         </p:txBody>
@@ -4605,7 +4605,7 @@
                 </a:solidFill>
                 <a:latin typeface="Georgia"/>
               </a:rPr>
-              <a:t>Reported on spend and delivery this month. Instagram testing delivered.</a:t>
+              <a:t>Meta reported on spend and delivery: $8,027 and 74,489 link clicks. Conversion measurement remains the open item.</a:t>
             </a:r>
           </a:p>
         </p:txBody>
@@ -11662,7 +11662,7 @@
                 </a:solidFill>
                 <a:latin typeface="Georgia"/>
               </a:rPr>
-              <a:t>Context this month. The measurement fix makes August the first fully measured month.</a:t>
+              <a:t>Mexico sessions fell 21% to 7,310, tracking Bing’s rebuild month. Key-event capture is fixed as of July 31.</a:t>
             </a:r>
           </a:p>
         </p:txBody>
@@ -13108,7 +13108,7 @@
                 </a:solidFill>
                 <a:latin typeface="Georgia"/>
               </a:rPr>
-              <a:t>August priorities: scale the rebuilt structure, complete measurement, hold inventory quality.</a:t>
+              <a:t>Scale the rebuilt structure. Finish the measurement. Hold inventory quality.</a:t>
             </a:r>
           </a:p>
         </p:txBody>
@@ -14173,7 +14173,7 @@
                 </a:solidFill>
                 <a:latin typeface="Georgia"/>
               </a:rPr>
-              <a:t>Submitted applications held near June on a 24% larger media month.</a:t>
+              <a:t>Submitted applications fell 5% to 653 while media scaled to $149,896.</a:t>
             </a:r>
           </a:p>
         </p:txBody>
@@ -16937,7 +16937,7 @@
                 </a:solidFill>
                 <a:latin typeface="Georgia"/>
               </a:rPr>
-              <a:t>$149,896 deployed in July, up 24%, the biggest GGMI media month of 2026.</a:t>
+              <a:t>$149,896 deployed in July. Bing and Azerion produced 61 submitted applications at $789.08.</a:t>
             </a:r>
           </a:p>
         </p:txBody>
@@ -19741,7 +19741,7 @@
                 </a:solidFill>
                 <a:latin typeface="Georgia"/>
               </a:rPr>
-              <a:t>Three windows in one month. The rebuilt structure is the account’s current state.</a:t>
+              <a:t>20 submitted applications at $531.25; the rebuilt structure closed the month at $237.12.</a:t>
             </a:r>
           </a:p>
         </p:txBody>
@@ -21787,7 +21787,7 @@
                 </a:solidFill>
                 <a:latin typeface="Georgia"/>
               </a:rPr>
-              <a:t>The rebuild superseded June’s campaign picks. August scales what works.</a:t>
+              <a:t>Scale the rebuilt structure.</a:t>
             </a:r>
           </a:p>
         </p:txBody>
@@ -22469,7 +22469,7 @@
                 </a:solidFill>
                 <a:latin typeface="Georgia"/>
               </a:rPr>
-              <a:t>Reach delivered at scale, all in Mexico. Viewability is the bill to manage.</a:t>
+              <a:t>A reach month at a $0.78 CPM. Viewability is the bill to manage.</a:t>
             </a:r>
           </a:p>
         </p:txBody>
@@ -24321,7 +24321,7 @@
                 </a:solidFill>
                 <a:latin typeface="Georgia"/>
               </a:rPr>
-              <a:t>Apply the refreshed list, then hold quality with a floor.</a:t>
+              <a:t>Apply the disallow list. Hold the 70% standard.</a:t>
             </a:r>
           </a:p>
         </p:txBody>
@@ -25003,7 +25003,7 @@
                 </a:solidFill>
                 <a:latin typeface="Georgia"/>
               </a:rPr>
-              <a:t>41 vendor-reported applications; viewability now clear of the floor on both formats.</a:t>
+              <a:t>41 vendor-reported applications at $914.85, from 42 at $834 in June.</a:t>
             </a:r>
           </a:p>
         </p:txBody>

</xml_diff>

<commit_message>
Headlines neutralized: level declaratives, no drama in either direction; doctrine updated
Co-Authored-By: Claude Fable 5 <noreply@anthropic.com>
</commit_message>
<xml_diff>
--- a/reports/forex/ggmi/2026-07/output/GGMI_LATAM_July_2026_Performance_Review.pptx
+++ b/reports/forex/ggmi/2026-07/output/GGMI_LATAM_July_2026_Performance_Review.pptx
@@ -11662,7 +11662,7 @@
                 </a:solidFill>
                 <a:latin typeface="Georgia"/>
               </a:rPr>
-              <a:t>Mexico sessions fell 21% to 7,310, tracking Bing’s rebuild month. Key-event capture is fixed as of July 31.</a:t>
+              <a:t>Mexico sessions came in at 7,310, tracking Bing’s rebuild month. Key-event capture is in place as of July 31.</a:t>
             </a:r>
           </a:p>
         </p:txBody>
@@ -12716,7 +12716,7 @@
                 </a:solidFill>
                 <a:latin typeface="Calibri"/>
               </a:rPr>
-              <a:t>A large share of July’s session dip tracks Bing’s own month: ten days of rebuild, then the transition window. Property-wide, sessions without source attribution (largely untagged paid search) fell sharply; attributed sessions grew.</a:t>
+              <a:t>A large share of July’s session dip tracks Bing’s own month: ten days of rebuild, then the transition window. Property-wide, sessions without source attribution (largely untagged paid search) declined; attributed sessions grew.</a:t>
             </a:r>
           </a:p>
           <a:p>
@@ -12732,7 +12732,7 @@
                 </a:solidFill>
                 <a:latin typeface="Calibri"/>
               </a:rPr>
-              <a:t>Venezuela’s session volume fell sharply as the prior campaigns retired, the same campaign-mix effect behind Bing’s in-market concentration this month.</a:t>
+              <a:t>Venezuela’s session volume declined as the prior campaigns retired, the same campaign-mix effect behind Bing’s in-market concentration this month.</a:t>
             </a:r>
           </a:p>
         </p:txBody>
@@ -14173,7 +14173,7 @@
                 </a:solidFill>
                 <a:latin typeface="Georgia"/>
               </a:rPr>
-              <a:t>Submitted applications fell 5% to 653 while media scaled to $149,896.</a:t>
+              <a:t>Submitted applications came in at 653, with working media at $149,896.</a:t>
             </a:r>
           </a:p>
         </p:txBody>
@@ -14354,7 +14354,7 @@
                 </a:solidFill>
                 <a:latin typeface="Calibri"/>
               </a:rPr>
-              <a:t>•  Working media reached $149,896 in July, up 24% MoM and the biggest month of 2026. The growth sits in the new Native and DOOH lines; the four continuing channels spent $95,401 against June’s total of $120,393, and paid submitted applications with a measured source (Bing plus Azerion) came in at 61.</a:t>
+              <a:t>•  Working media reached $149,896 in July, up 24% MoM. The growth sits in the new Native and DOOH lines; the four continuing channels spent $95,401 against June’s total of $120,393, and paid submitted applications with a measured source (Bing plus Azerion) came in at 61.</a:t>
             </a:r>
           </a:p>
           <a:p>

</xml_diff>

<commit_message>
Permanent reporting rule: per-channel partner signals, combined metric retired, portfolio decisions table
Co-Authored-By: Claude Fable 5 <noreply@anthropic.com>
</commit_message>
<xml_diff>
--- a/reports/forex/ggmi/2026-07/output/GGMI_LATAM_July_2026_Performance_Review.pptx
+++ b/reports/forex/ggmi/2026-07/output/GGMI_LATAM_July_2026_Performance_Review.pptx
@@ -3939,7 +3939,7 @@
                 </a:solidFill>
                 <a:latin typeface="Georgia"/>
               </a:rPr>
-              <a:t>Hold the pace. Confirm the delivery detail.</a:t>
+              <a:t>Continue at the current level. Optimize toward a lower partner-reported CPA.</a:t>
             </a:r>
           </a:p>
         </p:txBody>
@@ -4213,7 +4213,7 @@
                 </a:solidFill>
                 <a:latin typeface="Calibri"/>
               </a:rPr>
-              <a:t>The channel figure is the stable read: $914.85 per vendor-reported application, against $834 in June.</a:t>
+              <a:t>Azerion produced 41 partner-attributed applications and remains an active acquisition channel: $914.85 per application, against $834 in June.</a:t>
             </a:r>
           </a:p>
           <a:p>
@@ -4389,7 +4389,7 @@
                 </a:solidFill>
                 <a:latin typeface="Calibri"/>
               </a:rPr>
-              <a:t>Hold the channel’s pace and judge it on the monthly figure rather than reallocating off one month’s ad-set data.</a:t>
+              <a:t>Continue at the current level; August focuses on improving efficiency toward a lower partner-reported CPA and maintaining Mexico delivery.</a:t>
             </a:r>
           </a:p>
           <a:p>
@@ -4405,7 +4405,23 @@
                 </a:solidFill>
                 <a:latin typeface="Calibri"/>
               </a:rPr>
-              <a:t>Follow up with the vendor on the country-level delivery detail requested in early July, in the August cycle, and hold certification of that detail until it lands.</a:t>
+              <a:t>Judge the channel on the monthly figure rather than reallocating off one month’s ad-set data.</a:t>
+            </a:r>
+          </a:p>
+          <a:p>
+            <a:pPr algn="l">
+              <a:spcBef>
+                <a:spcPts val="600"/>
+              </a:spcBef>
+            </a:pPr>
+            <a:r>
+              <a:rPr sz="950" b="0">
+                <a:solidFill>
+                  <a:srgbClr val="2B3147"/>
+                </a:solidFill>
+                <a:latin typeface="Calibri"/>
+              </a:rPr>
+              <a:t>Follow up with the vendor on the country-level delivery detail requested in early July, in the August cycle.</a:t>
             </a:r>
           </a:p>
         </p:txBody>
@@ -4605,7 +4621,7 @@
                 </a:solidFill>
                 <a:latin typeface="Georgia"/>
               </a:rPr>
-              <a:t>Meta reported on spend and delivery: $8,027 and 74,489 link clicks. Conversion measurement remains the open item.</a:t>
+              <a:t>Meta paid reported on July spend and delivery: $8,027 and 74,489 link clicks.</a:t>
             </a:r>
           </a:p>
         </p:txBody>
@@ -6190,7 +6206,7 @@
                 </a:solidFill>
                 <a:latin typeface="Georgia"/>
               </a:rPr>
-              <a:t>MEASUREMENT NOTE</a:t>
+              <a:t>REPORTING METHOD</a:t>
             </a:r>
           </a:p>
         </p:txBody>
@@ -6225,7 +6241,7 @@
                 </a:solidFill>
                 <a:latin typeface="Calibri"/>
               </a:rPr>
-              <a:t>July’s Meta reporting covers spend and delivery: impressions, reach, frequency, link clicks, CTR, CPC, CPM, landing-page views, placements and geo.</a:t>
+              <a:t>Meta paid has no current reliable paid reporting; the account is paused and resolution is owned by StoneX. July is reported on platform delivery.</a:t>
             </a:r>
           </a:p>
           <a:p>
@@ -6241,7 +6257,7 @@
                 </a:solidFill>
                 <a:latin typeface="Calibri"/>
               </a:rPr>
-              <a:t>The platform reports 117 submitted-application pixel fires; that figure is Meta-reported and unvalidated, is not compared to Bing’s SA360-reported count, and carries no cost-per-application figure.</a:t>
+              <a:t>Meta organic continues, reported on native organic analytics: reach, engagement and audience activity.</a:t>
             </a:r>
           </a:p>
         </p:txBody>
@@ -7060,7 +7076,7 @@
                 </a:solidFill>
                 <a:latin typeface="Calibri"/>
               </a:rPr>
-              <a:t>Both are upper-funnel. Native carries a spend and delivery line with no conversion claim; DOOH delivery is reported on the two slides that follow.</a:t>
+              <a:t>Native is read on engagement, traffic quality and partner-attributed actions; DOOH delivery is reported on the two slides that follow.</a:t>
             </a:r>
           </a:p>
           <a:p>
@@ -7076,7 +7092,7 @@
                 </a:solidFill>
                 <a:latin typeface="Calibri"/>
               </a:rPr>
-              <a:t>Both gain a month-over-month read with a second month of data.</a:t>
+              <a:t>Native completes its planned test in August; its FY2027 role is decided from partner-level results.</a:t>
             </a:r>
           </a:p>
         </p:txBody>
@@ -8871,7 +8887,7 @@
                 </a:solidFill>
                 <a:latin typeface="Calibri"/>
               </a:rPr>
-              <a:t>A second full month of delivery gives the line its first month-over-month read in the August report.</a:t>
+              <a:t>The line completes its remaining $6K in August and concludes, closing out the contracted activity.</a:t>
             </a:r>
           </a:p>
         </p:txBody>
@@ -12374,8 +12390,8 @@
         </p:nvSpPr>
         <p:spPr>
           <a:xfrm>
-            <a:off x="6163056" y="1691640"/>
-            <a:ext cx="1783080" cy="1005840"/>
+            <a:off x="457200" y="3017520"/>
+            <a:ext cx="5577840" cy="3108960"/>
           </a:xfrm>
           <a:prstGeom prst="rect">
             <a:avLst/>
@@ -12420,14 +12436,14 @@
         </p:nvSpPr>
         <p:spPr>
           <a:xfrm>
-            <a:off x="6163056" y="1691640"/>
-            <a:ext cx="54864" cy="1005840"/>
+            <a:off x="457200" y="3017520"/>
+            <a:ext cx="64008" cy="3108960"/>
           </a:xfrm>
           <a:prstGeom prst="rect">
             <a:avLst/>
           </a:prstGeom>
           <a:solidFill>
-            <a:srgbClr val="F96167"/>
+            <a:srgbClr val="2E7D57"/>
           </a:solidFill>
           <a:ln>
             <a:noFill/>
@@ -12464,8 +12480,8 @@
         </p:nvSpPr>
         <p:spPr>
           <a:xfrm>
-            <a:off x="6345936" y="1737360"/>
-            <a:ext cx="1508760" cy="274320"/>
+            <a:off x="676656" y="3182112"/>
+            <a:ext cx="5175503" cy="274320"/>
           </a:xfrm>
           <a:prstGeom prst="rect">
             <a:avLst/>
@@ -12480,13 +12496,13 @@
           <a:p>
             <a:pPr algn="l"/>
             <a:r>
-              <a:rPr sz="800" b="1">
-                <a:solidFill>
-                  <a:srgbClr val="5A6072"/>
-                </a:solidFill>
-                <a:latin typeface="Calibri"/>
+              <a:rPr sz="1000" b="1">
+                <a:solidFill>
+                  <a:srgbClr val="1E2761"/>
+                </a:solidFill>
+                <a:latin typeface="Georgia"/>
               </a:rPr>
-              <a:t>GA4 CORROBORATION</a:t>
+              <a:t>WHAT THE DATA SHOWS</a:t>
             </a:r>
           </a:p>
         </p:txBody>
@@ -12499,8 +12515,8 @@
         </p:nvSpPr>
         <p:spPr>
           <a:xfrm>
-            <a:off x="6345936" y="1984248"/>
-            <a:ext cx="1508760" cy="457200"/>
+            <a:off x="676656" y="3520439"/>
+            <a:ext cx="5175503" cy="2423160"/>
           </a:xfrm>
           <a:prstGeom prst="rect">
             <a:avLst/>
@@ -12515,62 +12531,43 @@
           <a:p>
             <a:pPr algn="l"/>
             <a:r>
-              <a:rPr sz="1500" b="1">
-                <a:solidFill>
-                  <a:srgbClr val="1E2761"/>
+              <a:rPr sz="950" b="0">
+                <a:solidFill>
+                  <a:srgbClr val="2B3147"/>
                 </a:solidFill>
                 <a:latin typeface="Calibri"/>
               </a:rPr>
-              <a:t>August</a:t>
-            </a:r>
-          </a:p>
-        </p:txBody>
-      </p:sp>
-      <p:sp>
-        <p:nvSpPr>
-          <p:cNvPr id="29" name="TextBox 28"/>
-          <p:cNvSpPr txBox="1"/>
-          <p:nvPr/>
-        </p:nvSpPr>
-        <p:spPr>
-          <a:xfrm>
-            <a:off x="6345936" y="2441448"/>
-            <a:ext cx="1508760" cy="219456"/>
-          </a:xfrm>
-          <a:prstGeom prst="rect">
-            <a:avLst/>
-          </a:prstGeom>
-          <a:noFill/>
-        </p:spPr>
-        <p:txBody>
-          <a:bodyPr wrap="square" anchor="t" lIns="0" rIns="0" tIns="0" bIns="0">
-            <a:spAutoFit/>
-          </a:bodyPr>
-          <a:lstStyle/>
-          <a:p>
-            <a:pPr algn="l"/>
-            <a:r>
-              <a:rPr sz="800" b="0">
-                <a:solidFill>
-                  <a:srgbClr val="5A6072"/>
+              <a:t>A large share of July’s session dip tracks Bing’s own month: ten days of rebuild, then the transition window. Property-wide, sessions without source attribution (largely untagged paid search) declined; attributed sessions grew.</a:t>
+            </a:r>
+          </a:p>
+          <a:p>
+            <a:pPr algn="l">
+              <a:spcBef>
+                <a:spcPts val="600"/>
+              </a:spcBef>
+            </a:pPr>
+            <a:r>
+              <a:rPr sz="950" b="0">
+                <a:solidFill>
+                  <a:srgbClr val="2B3147"/>
                 </a:solidFill>
                 <a:latin typeface="Calibri"/>
               </a:rPr>
-              <a:t>first full month</a:t>
-            </a:r>
-          </a:p>
-        </p:txBody>
-      </p:sp>
-      <p:sp>
-        <p:nvSpPr>
-          <p:cNvPr id="30" name="Rectangle 29"/>
+              <a:t>Venezuela’s session volume declined as the prior campaigns retired, the same campaign-mix effect behind Bing’s in-market concentration this month.</a:t>
+            </a:r>
+          </a:p>
+        </p:txBody>
+      </p:sp>
+      <p:sp>
+        <p:nvSpPr>
+          <p:cNvPr id="29" name="Rectangle 28"/>
           <p:cNvSpPr/>
           <p:nvPr/>
         </p:nvSpPr>
         <p:spPr>
           <a:xfrm>
-            <a:off x="457200" y="3017520"/>
-            <a:ext cx="5577840" cy="3108960"/>
+            <a:off x="6309360" y="3017520"/>
+            <a:ext cx="5394960" cy="3108960"/>
           </a:xfrm>
           <a:prstGeom prst="rect">
             <a:avLst/>
@@ -12609,183 +12606,7 @@
       </p:sp>
       <p:sp>
         <p:nvSpPr>
-          <p:cNvPr id="31" name="Rectangle 30"/>
-          <p:cNvSpPr/>
-          <p:nvPr/>
-        </p:nvSpPr>
-        <p:spPr>
-          <a:xfrm>
-            <a:off x="457200" y="3017520"/>
-            <a:ext cx="64008" cy="3108960"/>
-          </a:xfrm>
-          <a:prstGeom prst="rect">
-            <a:avLst/>
-          </a:prstGeom>
-          <a:solidFill>
-            <a:srgbClr val="2E7D57"/>
-          </a:solidFill>
-          <a:ln>
-            <a:noFill/>
-          </a:ln>
-          <a:effectLst/>
-        </p:spPr>
-        <p:style>
-          <a:lnRef idx="1">
-            <a:schemeClr val="accent1"/>
-          </a:lnRef>
-          <a:fillRef idx="3">
-            <a:schemeClr val="accent1"/>
-          </a:fillRef>
-          <a:effectRef idx="2">
-            <a:schemeClr val="accent1"/>
-          </a:effectRef>
-          <a:fontRef idx="minor">
-            <a:schemeClr val="lt1"/>
-          </a:fontRef>
-        </p:style>
-        <p:txBody>
-          <a:bodyPr rtlCol="0" anchor="ctr"/>
-          <a:lstStyle/>
-          <a:p>
-            <a:pPr algn="ctr"/>
-          </a:p>
-        </p:txBody>
-      </p:sp>
-      <p:sp>
-        <p:nvSpPr>
-          <p:cNvPr id="32" name="TextBox 31"/>
-          <p:cNvSpPr txBox="1"/>
-          <p:nvPr/>
-        </p:nvSpPr>
-        <p:spPr>
-          <a:xfrm>
-            <a:off x="676656" y="3182112"/>
-            <a:ext cx="5175503" cy="274320"/>
-          </a:xfrm>
-          <a:prstGeom prst="rect">
-            <a:avLst/>
-          </a:prstGeom>
-          <a:noFill/>
-        </p:spPr>
-        <p:txBody>
-          <a:bodyPr wrap="square" anchor="t" lIns="0" rIns="0" tIns="0" bIns="0">
-            <a:spAutoFit/>
-          </a:bodyPr>
-          <a:lstStyle/>
-          <a:p>
-            <a:pPr algn="l"/>
-            <a:r>
-              <a:rPr sz="1000" b="1">
-                <a:solidFill>
-                  <a:srgbClr val="1E2761"/>
-                </a:solidFill>
-                <a:latin typeface="Georgia"/>
-              </a:rPr>
-              <a:t>WHAT THE DATA SHOWS</a:t>
-            </a:r>
-          </a:p>
-        </p:txBody>
-      </p:sp>
-      <p:sp>
-        <p:nvSpPr>
-          <p:cNvPr id="33" name="TextBox 32"/>
-          <p:cNvSpPr txBox="1"/>
-          <p:nvPr/>
-        </p:nvSpPr>
-        <p:spPr>
-          <a:xfrm>
-            <a:off x="676656" y="3520439"/>
-            <a:ext cx="5175503" cy="2423160"/>
-          </a:xfrm>
-          <a:prstGeom prst="rect">
-            <a:avLst/>
-          </a:prstGeom>
-          <a:noFill/>
-        </p:spPr>
-        <p:txBody>
-          <a:bodyPr wrap="square" anchor="t" lIns="0" rIns="0" tIns="0" bIns="0">
-            <a:spAutoFit/>
-          </a:bodyPr>
-          <a:lstStyle/>
-          <a:p>
-            <a:pPr algn="l"/>
-            <a:r>
-              <a:rPr sz="950" b="0">
-                <a:solidFill>
-                  <a:srgbClr val="2B3147"/>
-                </a:solidFill>
-                <a:latin typeface="Calibri"/>
-              </a:rPr>
-              <a:t>A large share of July’s session dip tracks Bing’s own month: ten days of rebuild, then the transition window. Property-wide, sessions without source attribution (largely untagged paid search) declined; attributed sessions grew.</a:t>
-            </a:r>
-          </a:p>
-          <a:p>
-            <a:pPr algn="l">
-              <a:spcBef>
-                <a:spcPts val="600"/>
-              </a:spcBef>
-            </a:pPr>
-            <a:r>
-              <a:rPr sz="950" b="0">
-                <a:solidFill>
-                  <a:srgbClr val="2B3147"/>
-                </a:solidFill>
-                <a:latin typeface="Calibri"/>
-              </a:rPr>
-              <a:t>Venezuela’s session volume declined as the prior campaigns retired, the same campaign-mix effect behind Bing’s in-market concentration this month.</a:t>
-            </a:r>
-          </a:p>
-        </p:txBody>
-      </p:sp>
-      <p:sp>
-        <p:nvSpPr>
-          <p:cNvPr id="34" name="Rectangle 33"/>
-          <p:cNvSpPr/>
-          <p:nvPr/>
-        </p:nvSpPr>
-        <p:spPr>
-          <a:xfrm>
-            <a:off x="6309360" y="3017520"/>
-            <a:ext cx="5394960" cy="3108960"/>
-          </a:xfrm>
-          <a:prstGeom prst="rect">
-            <a:avLst/>
-          </a:prstGeom>
-          <a:solidFill>
-            <a:srgbClr val="FFFFFF"/>
-          </a:solidFill>
-          <a:ln w="9525">
-            <a:solidFill>
-              <a:srgbClr val="D0D4DC"/>
-            </a:solidFill>
-          </a:ln>
-          <a:effectLst/>
-        </p:spPr>
-        <p:style>
-          <a:lnRef idx="1">
-            <a:schemeClr val="accent1"/>
-          </a:lnRef>
-          <a:fillRef idx="3">
-            <a:schemeClr val="accent1"/>
-          </a:fillRef>
-          <a:effectRef idx="2">
-            <a:schemeClr val="accent1"/>
-          </a:effectRef>
-          <a:fontRef idx="minor">
-            <a:schemeClr val="lt1"/>
-          </a:fontRef>
-        </p:style>
-        <p:txBody>
-          <a:bodyPr rtlCol="0" anchor="ctr"/>
-          <a:lstStyle/>
-          <a:p>
-            <a:pPr algn="ctr"/>
-          </a:p>
-        </p:txBody>
-      </p:sp>
-      <p:sp>
-        <p:nvSpPr>
-          <p:cNvPr id="35" name="Rectangle 34"/>
+          <p:cNvPr id="30" name="Rectangle 29"/>
           <p:cNvSpPr/>
           <p:nvPr/>
         </p:nvSpPr>
@@ -12829,7 +12650,7 @@
       </p:sp>
       <p:sp>
         <p:nvSpPr>
-          <p:cNvPr id="36" name="TextBox 35"/>
+          <p:cNvPr id="31" name="TextBox 30"/>
           <p:cNvSpPr txBox="1"/>
           <p:nvPr/>
         </p:nvSpPr>
@@ -12857,14 +12678,14 @@
                 </a:solidFill>
                 <a:latin typeface="Georgia"/>
               </a:rPr>
-              <a:t>MEASUREMENT TO CLOSE</a:t>
-            </a:r>
-          </a:p>
-        </p:txBody>
-      </p:sp>
-      <p:sp>
-        <p:nvSpPr>
-          <p:cNvPr id="37" name="TextBox 36"/>
+              <a:t>REPORTING METHOD</a:t>
+            </a:r>
+          </a:p>
+        </p:txBody>
+      </p:sp>
+      <p:sp>
+        <p:nvSpPr>
+          <p:cNvPr id="32" name="TextBox 31"/>
           <p:cNvSpPr txBox="1"/>
           <p:nvPr/>
         </p:nvSpPr>
@@ -12892,7 +12713,7 @@
                 </a:solidFill>
                 <a:latin typeface="Calibri"/>
               </a:rPr>
-              <a:t>The submitted-application key event began counting correctly on July 31 and has held at full capture since. July is reported on the SA360 count; August is the first month GA4 can corroborate it independently.</a:t>
+              <a:t>GA4 is read as sitewide directional context: traffic and behavior trends, not channel attribution. Channel results come from each partner’s own reporting.</a:t>
             </a:r>
           </a:p>
           <a:p>
@@ -12908,7 +12729,7 @@
                 </a:solidFill>
                 <a:latin typeface="Calibri"/>
               </a:rPr>
-              <a:t>Completion of the Bing-to-GA4 account link has not yet been verified; the paid-search restatement June’s deck flagged lands once it is, expected alongside August’s corroboration.</a:t>
+              <a:t>The submitted-application key event records correctly as of July 31.</a:t>
             </a:r>
           </a:p>
         </p:txBody>
@@ -13049,7 +12870,7 @@
                 </a:solidFill>
                 <a:latin typeface="Georgia"/>
               </a:rPr>
-              <a:t>CROSS-CHANNEL PRIORITIES + NEXT STEPS</a:t>
+              <a:t>PORTFOLIO DECISIONS</a:t>
             </a:r>
           </a:p>
         </p:txBody>
@@ -13108,7 +12929,7 @@
                 </a:solidFill>
                 <a:latin typeface="Georgia"/>
               </a:rPr>
-              <a:t>Scale the rebuilt structure. Finish the measurement. Hold inventory quality.</a:t>
+              <a:t>Each channel is read on its own partner reporting. The decisions follow from it.</a:t>
             </a:r>
           </a:p>
         </p:txBody>
@@ -13227,106 +13048,426 @@
           </a:p>
         </p:txBody>
       </p:sp>
-      <p:sp>
-        <p:nvSpPr>
-          <p:cNvPr id="10" name="Rectangle 9"/>
-          <p:cNvSpPr/>
-          <p:nvPr/>
-        </p:nvSpPr>
-        <p:spPr>
-          <a:xfrm>
-            <a:off x="457200" y="1783080"/>
-            <a:ext cx="3703320" cy="2103120"/>
-          </a:xfrm>
-          <a:prstGeom prst="rect">
-            <a:avLst/>
-          </a:prstGeom>
-          <a:solidFill>
-            <a:srgbClr val="F9FAFC"/>
-          </a:solidFill>
-          <a:ln w="9525">
-            <a:solidFill>
-              <a:srgbClr val="D0D4DC"/>
-            </a:solidFill>
-          </a:ln>
-          <a:effectLst/>
-        </p:spPr>
-        <p:style>
-          <a:lnRef idx="1">
-            <a:schemeClr val="accent1"/>
-          </a:lnRef>
-          <a:fillRef idx="3">
-            <a:schemeClr val="accent1"/>
-          </a:fillRef>
-          <a:effectRef idx="2">
-            <a:schemeClr val="accent1"/>
-          </a:effectRef>
-          <a:fontRef idx="minor">
-            <a:schemeClr val="lt1"/>
-          </a:fontRef>
-        </p:style>
-        <p:txBody>
-          <a:bodyPr rtlCol="0" anchor="ctr"/>
-          <a:lstStyle/>
-          <a:p>
-            <a:pPr algn="ctr"/>
-          </a:p>
-        </p:txBody>
-      </p:sp>
-      <p:sp>
-        <p:nvSpPr>
-          <p:cNvPr id="11" name="Rectangle 10"/>
-          <p:cNvSpPr/>
-          <p:nvPr/>
-        </p:nvSpPr>
-        <p:spPr>
-          <a:xfrm>
-            <a:off x="457200" y="1783080"/>
-            <a:ext cx="3703320" cy="292608"/>
-          </a:xfrm>
-          <a:prstGeom prst="rect">
-            <a:avLst/>
-          </a:prstGeom>
-          <a:solidFill>
-            <a:srgbClr val="F96167"/>
-          </a:solidFill>
-          <a:ln>
-            <a:noFill/>
-          </a:ln>
-          <a:effectLst/>
-        </p:spPr>
-        <p:style>
-          <a:lnRef idx="1">
-            <a:schemeClr val="accent1"/>
-          </a:lnRef>
-          <a:fillRef idx="3">
-            <a:schemeClr val="accent1"/>
-          </a:fillRef>
-          <a:effectRef idx="2">
-            <a:schemeClr val="accent1"/>
-          </a:effectRef>
-          <a:fontRef idx="minor">
-            <a:schemeClr val="lt1"/>
-          </a:fontRef>
-        </p:style>
-        <p:txBody>
-          <a:bodyPr rtlCol="0" anchor="ctr"/>
-          <a:lstStyle/>
-          <a:p>
-            <a:pPr algn="ctr"/>
-          </a:p>
-        </p:txBody>
-      </p:sp>
-      <p:sp>
-        <p:nvSpPr>
-          <p:cNvPr id="12" name="TextBox 11"/>
+      <p:graphicFrame>
+        <p:nvGraphicFramePr>
+          <p:cNvPr id="10" name="Table 9"/>
+          <p:cNvGraphicFramePr>
+            <a:graphicFrameLocks noGrp="1"/>
+          </p:cNvGraphicFramePr>
+          <p:nvPr/>
+        </p:nvGraphicFramePr>
+        <p:xfrm>
+          <a:off x="457200" y="1828800"/>
+          <a:ext cx="11274552" cy="3840480"/>
+        </p:xfrm>
+        <a:graphic>
+          <a:graphicData uri="http://schemas.openxmlformats.org/drawingml/2006/table">
+            <a:tbl>
+              <a:tblPr>
+                <a:tableStyleId>{5C22544A-7EE6-4342-B048-85BDC9FD1C3A}</a:tableStyleId>
+              </a:tblPr>
+              <a:tblGrid>
+                <a:gridCol w="2103120"/>
+                <a:gridCol w="9171432"/>
+              </a:tblGrid>
+              <a:tr h="480060">
+                <a:tc>
+                  <a:txBody>
+                    <a:bodyPr/>
+                    <a:lstStyle/>
+                    <a:p>
+                      <a:pPr algn="l"/>
+                      <a:r>
+                        <a:rPr sz="850" b="1">
+                          <a:solidFill>
+                            <a:srgbClr val="FFFFFF"/>
+                          </a:solidFill>
+                          <a:latin typeface="Calibri"/>
+                        </a:rPr>
+                        <a:t>Channel</a:t>
+                      </a:r>
+                    </a:p>
+                  </a:txBody>
+                  <a:tcPr marL="54864" marR="54864" marT="27432" marB="27432">
+                    <a:solidFill>
+                      <a:srgbClr val="1E2761"/>
+                    </a:solidFill>
+                  </a:tcPr>
+                </a:tc>
+                <a:tc>
+                  <a:txBody>
+                    <a:bodyPr/>
+                    <a:lstStyle/>
+                    <a:p>
+                      <a:pPr algn="l"/>
+                      <a:r>
+                        <a:rPr sz="850" b="1">
+                          <a:solidFill>
+                            <a:srgbClr val="FFFFFF"/>
+                          </a:solidFill>
+                          <a:latin typeface="Calibri"/>
+                        </a:rPr>
+                        <a:t>August decision</a:t>
+                      </a:r>
+                    </a:p>
+                  </a:txBody>
+                  <a:tcPr marL="54864" marR="54864" marT="27432" marB="27432">
+                    <a:solidFill>
+                      <a:srgbClr val="1E2761"/>
+                    </a:solidFill>
+                  </a:tcPr>
+                </a:tc>
+              </a:tr>
+              <a:tr h="480060">
+                <a:tc>
+                  <a:txBody>
+                    <a:bodyPr/>
+                    <a:lstStyle/>
+                    <a:p>
+                      <a:pPr algn="l"/>
+                      <a:r>
+                        <a:rPr sz="850" b="1">
+                          <a:solidFill>
+                            <a:srgbClr val="2B3147"/>
+                          </a:solidFill>
+                          <a:latin typeface="Calibri"/>
+                        </a:rPr>
+                        <a:t>Bing</a:t>
+                      </a:r>
+                    </a:p>
+                  </a:txBody>
+                  <a:tcPr marL="54864" marR="54864" marT="27432" marB="27432">
+                    <a:solidFill>
+                      <a:srgbClr val="FFFFFF"/>
+                    </a:solidFill>
+                  </a:tcPr>
+                </a:tc>
+                <a:tc>
+                  <a:txBody>
+                    <a:bodyPr/>
+                    <a:lstStyle/>
+                    <a:p>
+                      <a:pPr algn="l"/>
+                      <a:r>
+                        <a:rPr sz="850" b="0">
+                          <a:solidFill>
+                            <a:srgbClr val="2B3147"/>
+                          </a:solidFill>
+                          <a:latin typeface="Calibri"/>
+                        </a:rPr>
+                        <a:t>Increase within CPA and delivery guardrails.</a:t>
+                      </a:r>
+                    </a:p>
+                  </a:txBody>
+                  <a:tcPr marL="54864" marR="54864" marT="27432" marB="27432">
+                    <a:solidFill>
+                      <a:srgbClr val="FFFFFF"/>
+                    </a:solidFill>
+                  </a:tcPr>
+                </a:tc>
+              </a:tr>
+              <a:tr h="480060">
+                <a:tc>
+                  <a:txBody>
+                    <a:bodyPr/>
+                    <a:lstStyle/>
+                    <a:p>
+                      <a:pPr algn="l"/>
+                      <a:r>
+                        <a:rPr sz="850" b="1">
+                          <a:solidFill>
+                            <a:srgbClr val="2B3147"/>
+                          </a:solidFill>
+                          <a:latin typeface="Calibri"/>
+                        </a:rPr>
+                        <a:t>Azerion</a:t>
+                      </a:r>
+                    </a:p>
+                  </a:txBody>
+                  <a:tcPr marL="54864" marR="54864" marT="27432" marB="27432">
+                    <a:solidFill>
+                      <a:srgbClr val="F9FAFC"/>
+                    </a:solidFill>
+                  </a:tcPr>
+                </a:tc>
+                <a:tc>
+                  <a:txBody>
+                    <a:bodyPr/>
+                    <a:lstStyle/>
+                    <a:p>
+                      <a:pPr algn="l"/>
+                      <a:r>
+                        <a:rPr sz="850" b="0">
+                          <a:solidFill>
+                            <a:srgbClr val="2B3147"/>
+                          </a:solidFill>
+                          <a:latin typeface="Calibri"/>
+                        </a:rPr>
+                        <a:t>Continue at the current level; optimize toward a lower partner-reported CPA.</a:t>
+                      </a:r>
+                    </a:p>
+                  </a:txBody>
+                  <a:tcPr marL="54864" marR="54864" marT="27432" marB="27432">
+                    <a:solidFill>
+                      <a:srgbClr val="F9FAFC"/>
+                    </a:solidFill>
+                  </a:tcPr>
+                </a:tc>
+              </a:tr>
+              <a:tr h="480060">
+                <a:tc>
+                  <a:txBody>
+                    <a:bodyPr/>
+                    <a:lstStyle/>
+                    <a:p>
+                      <a:pPr algn="l"/>
+                      <a:r>
+                        <a:rPr sz="850" b="1">
+                          <a:solidFill>
+                            <a:srgbClr val="2B3147"/>
+                          </a:solidFill>
+                          <a:latin typeface="Calibri"/>
+                        </a:rPr>
+                        <a:t>Quantcast</a:t>
+                      </a:r>
+                    </a:p>
+                  </a:txBody>
+                  <a:tcPr marL="54864" marR="54864" marT="27432" marB="27432">
+                    <a:solidFill>
+                      <a:srgbClr val="FFFFFF"/>
+                    </a:solidFill>
+                  </a:tcPr>
+                </a:tc>
+                <a:tc>
+                  <a:txBody>
+                    <a:bodyPr/>
+                    <a:lstStyle/>
+                    <a:p>
+                      <a:pPr algn="l"/>
+                      <a:r>
+                        <a:rPr sz="850" b="0">
+                          <a:solidFill>
+                            <a:srgbClr val="2B3147"/>
+                          </a:solidFill>
+                          <a:latin typeface="Calibri"/>
+                        </a:rPr>
+                        <a:t>Maintain a bounded role with explicit inventory and qualified-traffic expectations; apply the refreshed site list.</a:t>
+                      </a:r>
+                    </a:p>
+                  </a:txBody>
+                  <a:tcPr marL="54864" marR="54864" marT="27432" marB="27432">
+                    <a:solidFill>
+                      <a:srgbClr val="FFFFFF"/>
+                    </a:solidFill>
+                  </a:tcPr>
+                </a:tc>
+              </a:tr>
+              <a:tr h="480060">
+                <a:tc>
+                  <a:txBody>
+                    <a:bodyPr/>
+                    <a:lstStyle/>
+                    <a:p>
+                      <a:pPr algn="l"/>
+                      <a:r>
+                        <a:rPr sz="850" b="1">
+                          <a:solidFill>
+                            <a:srgbClr val="2B3147"/>
+                          </a:solidFill>
+                          <a:latin typeface="Calibri"/>
+                        </a:rPr>
+                        <a:t>Native</a:t>
+                      </a:r>
+                    </a:p>
+                  </a:txBody>
+                  <a:tcPr marL="54864" marR="54864" marT="27432" marB="27432">
+                    <a:solidFill>
+                      <a:srgbClr val="F9FAFC"/>
+                    </a:solidFill>
+                  </a:tcPr>
+                </a:tc>
+                <a:tc>
+                  <a:txBody>
+                    <a:bodyPr/>
+                    <a:lstStyle/>
+                    <a:p>
+                      <a:pPr algn="l"/>
+                      <a:r>
+                        <a:rPr sz="850" b="0">
+                          <a:solidFill>
+                            <a:srgbClr val="2B3147"/>
+                          </a:solidFill>
+                          <a:latin typeface="Calibri"/>
+                        </a:rPr>
+                        <a:t>Complete the planned test; decide its FY2027 role from partner-level results.</a:t>
+                      </a:r>
+                    </a:p>
+                  </a:txBody>
+                  <a:tcPr marL="54864" marR="54864" marT="27432" marB="27432">
+                    <a:solidFill>
+                      <a:srgbClr val="F9FAFC"/>
+                    </a:solidFill>
+                  </a:tcPr>
+                </a:tc>
+              </a:tr>
+              <a:tr h="480060">
+                <a:tc>
+                  <a:txBody>
+                    <a:bodyPr/>
+                    <a:lstStyle/>
+                    <a:p>
+                      <a:pPr algn="l"/>
+                      <a:r>
+                        <a:rPr sz="850" b="1">
+                          <a:solidFill>
+                            <a:srgbClr val="2B3147"/>
+                          </a:solidFill>
+                          <a:latin typeface="Calibri"/>
+                        </a:rPr>
+                        <a:t>Meta paid</a:t>
+                      </a:r>
+                    </a:p>
+                  </a:txBody>
+                  <a:tcPr marL="54864" marR="54864" marT="27432" marB="27432">
+                    <a:solidFill>
+                      <a:srgbClr val="FFFFFF"/>
+                    </a:solidFill>
+                  </a:tcPr>
+                </a:tc>
+                <a:tc>
+                  <a:txBody>
+                    <a:bodyPr/>
+                    <a:lstStyle/>
+                    <a:p>
+                      <a:pPr algn="l"/>
+                      <a:r>
+                        <a:rPr sz="850" b="0">
+                          <a:solidFill>
+                            <a:srgbClr val="2B3147"/>
+                          </a:solidFill>
+                          <a:latin typeface="Calibri"/>
+                        </a:rPr>
+                        <a:t>Paused; resolution owned by StoneX.</a:t>
+                      </a:r>
+                    </a:p>
+                  </a:txBody>
+                  <a:tcPr marL="54864" marR="54864" marT="27432" marB="27432">
+                    <a:solidFill>
+                      <a:srgbClr val="FFFFFF"/>
+                    </a:solidFill>
+                  </a:tcPr>
+                </a:tc>
+              </a:tr>
+              <a:tr h="480060">
+                <a:tc>
+                  <a:txBody>
+                    <a:bodyPr/>
+                    <a:lstStyle/>
+                    <a:p>
+                      <a:pPr algn="l"/>
+                      <a:r>
+                        <a:rPr sz="850" b="1">
+                          <a:solidFill>
+                            <a:srgbClr val="2B3147"/>
+                          </a:solidFill>
+                          <a:latin typeface="Calibri"/>
+                        </a:rPr>
+                        <a:t>Meta organic</a:t>
+                      </a:r>
+                    </a:p>
+                  </a:txBody>
+                  <a:tcPr marL="54864" marR="54864" marT="27432" marB="27432">
+                    <a:solidFill>
+                      <a:srgbClr val="F9FAFC"/>
+                    </a:solidFill>
+                  </a:tcPr>
+                </a:tc>
+                <a:tc>
+                  <a:txBody>
+                    <a:bodyPr/>
+                    <a:lstStyle/>
+                    <a:p>
+                      <a:pPr algn="l"/>
+                      <a:r>
+                        <a:rPr sz="850" b="0">
+                          <a:solidFill>
+                            <a:srgbClr val="2B3147"/>
+                          </a:solidFill>
+                          <a:latin typeface="Calibri"/>
+                        </a:rPr>
+                        <a:t>Continue.</a:t>
+                      </a:r>
+                    </a:p>
+                  </a:txBody>
+                  <a:tcPr marL="54864" marR="54864" marT="27432" marB="27432">
+                    <a:solidFill>
+                      <a:srgbClr val="F9FAFC"/>
+                    </a:solidFill>
+                  </a:tcPr>
+                </a:tc>
+              </a:tr>
+              <a:tr h="480060">
+                <a:tc>
+                  <a:txBody>
+                    <a:bodyPr/>
+                    <a:lstStyle/>
+                    <a:p>
+                      <a:pPr algn="l"/>
+                      <a:r>
+                        <a:rPr sz="850" b="1">
+                          <a:solidFill>
+                            <a:srgbClr val="2B3147"/>
+                          </a:solidFill>
+                          <a:latin typeface="Calibri"/>
+                        </a:rPr>
+                        <a:t>DOOH</a:t>
+                      </a:r>
+                    </a:p>
+                  </a:txBody>
+                  <a:tcPr marL="54864" marR="54864" marT="27432" marB="27432">
+                    <a:solidFill>
+                      <a:srgbClr val="FFFFFF"/>
+                    </a:solidFill>
+                  </a:tcPr>
+                </a:tc>
+                <a:tc>
+                  <a:txBody>
+                    <a:bodyPr/>
+                    <a:lstStyle/>
+                    <a:p>
+                      <a:pPr algn="l"/>
+                      <a:r>
+                        <a:rPr sz="850" b="0">
+                          <a:solidFill>
+                            <a:srgbClr val="2B3147"/>
+                          </a:solidFill>
+                          <a:latin typeface="Calibri"/>
+                        </a:rPr>
+                        <a:t>Complete the remaining $6K and conclude.</a:t>
+                      </a:r>
+                    </a:p>
+                  </a:txBody>
+                  <a:tcPr marL="54864" marR="54864" marT="27432" marB="27432">
+                    <a:solidFill>
+                      <a:srgbClr val="FFFFFF"/>
+                    </a:solidFill>
+                  </a:tcPr>
+                </a:tc>
+              </a:tr>
+            </a:tbl>
+          </a:graphicData>
+        </a:graphic>
+      </p:graphicFrame>
+      <p:sp>
+        <p:nvSpPr>
+          <p:cNvPr id="11" name="TextBox 10"/>
           <p:cNvSpPr txBox="1"/>
           <p:nvPr/>
         </p:nvSpPr>
         <p:spPr>
           <a:xfrm>
-            <a:off x="603504" y="1837943"/>
-            <a:ext cx="3410712" cy="219456"/>
+            <a:off x="457200" y="5806440"/>
+            <a:ext cx="11247120" cy="365760"/>
           </a:xfrm>
           <a:prstGeom prst="rect">
             <a:avLst/>
@@ -13341,639 +13482,13 @@
           <a:p>
             <a:pPr algn="l"/>
             <a:r>
-              <a:rPr sz="950" b="1">
-                <a:solidFill>
-                  <a:srgbClr val="FFFFFF"/>
-                </a:solidFill>
-                <a:latin typeface="Georgia"/>
-              </a:rPr>
-              <a:t>PRIORITY</a:t>
-            </a:r>
-          </a:p>
-        </p:txBody>
-      </p:sp>
-      <p:sp>
-        <p:nvSpPr>
-          <p:cNvPr id="13" name="TextBox 12"/>
-          <p:cNvSpPr txBox="1"/>
-          <p:nvPr/>
-        </p:nvSpPr>
-        <p:spPr>
-          <a:xfrm>
-            <a:off x="603504" y="2185416"/>
-            <a:ext cx="3410712" cy="1554479"/>
-          </a:xfrm>
-          <a:prstGeom prst="rect">
-            <a:avLst/>
-          </a:prstGeom>
-          <a:noFill/>
-        </p:spPr>
-        <p:txBody>
-          <a:bodyPr wrap="square" anchor="t" lIns="0" rIns="0" tIns="0" bIns="0">
-            <a:spAutoFit/>
-          </a:bodyPr>
-          <a:lstStyle/>
-          <a:p>
-            <a:pPr algn="l"/>
-            <a:r>
-              <a:rPr sz="900" b="0">
-                <a:solidFill>
-                  <a:srgbClr val="2B3147"/>
+              <a:rPr sz="750" b="0">
+                <a:solidFill>
+                  <a:srgbClr val="5A6072"/>
                 </a:solidFill>
                 <a:latin typeface="Calibri"/>
               </a:rPr>
-              <a:t>Scale the rebuilt Bing structure on the July close of $237.12; August is tracking at $243 across three products.</a:t>
-            </a:r>
-          </a:p>
-        </p:txBody>
-      </p:sp>
-      <p:sp>
-        <p:nvSpPr>
-          <p:cNvPr id="14" name="Rectangle 13"/>
-          <p:cNvSpPr/>
-          <p:nvPr/>
-        </p:nvSpPr>
-        <p:spPr>
-          <a:xfrm>
-            <a:off x="4343400" y="1783080"/>
-            <a:ext cx="3703320" cy="2103120"/>
-          </a:xfrm>
-          <a:prstGeom prst="rect">
-            <a:avLst/>
-          </a:prstGeom>
-          <a:solidFill>
-            <a:srgbClr val="F9FAFC"/>
-          </a:solidFill>
-          <a:ln w="9525">
-            <a:solidFill>
-              <a:srgbClr val="D0D4DC"/>
-            </a:solidFill>
-          </a:ln>
-          <a:effectLst/>
-        </p:spPr>
-        <p:style>
-          <a:lnRef idx="1">
-            <a:schemeClr val="accent1"/>
-          </a:lnRef>
-          <a:fillRef idx="3">
-            <a:schemeClr val="accent1"/>
-          </a:fillRef>
-          <a:effectRef idx="2">
-            <a:schemeClr val="accent1"/>
-          </a:effectRef>
-          <a:fontRef idx="minor">
-            <a:schemeClr val="lt1"/>
-          </a:fontRef>
-        </p:style>
-        <p:txBody>
-          <a:bodyPr rtlCol="0" anchor="ctr"/>
-          <a:lstStyle/>
-          <a:p>
-            <a:pPr algn="ctr"/>
-          </a:p>
-        </p:txBody>
-      </p:sp>
-      <p:sp>
-        <p:nvSpPr>
-          <p:cNvPr id="15" name="Rectangle 14"/>
-          <p:cNvSpPr/>
-          <p:nvPr/>
-        </p:nvSpPr>
-        <p:spPr>
-          <a:xfrm>
-            <a:off x="4343400" y="1783080"/>
-            <a:ext cx="3703320" cy="292608"/>
-          </a:xfrm>
-          <a:prstGeom prst="rect">
-            <a:avLst/>
-          </a:prstGeom>
-          <a:solidFill>
-            <a:srgbClr val="E9B44C"/>
-          </a:solidFill>
-          <a:ln>
-            <a:noFill/>
-          </a:ln>
-          <a:effectLst/>
-        </p:spPr>
-        <p:style>
-          <a:lnRef idx="1">
-            <a:schemeClr val="accent1"/>
-          </a:lnRef>
-          <a:fillRef idx="3">
-            <a:schemeClr val="accent1"/>
-          </a:fillRef>
-          <a:effectRef idx="2">
-            <a:schemeClr val="accent1"/>
-          </a:effectRef>
-          <a:fontRef idx="minor">
-            <a:schemeClr val="lt1"/>
-          </a:fontRef>
-        </p:style>
-        <p:txBody>
-          <a:bodyPr rtlCol="0" anchor="ctr"/>
-          <a:lstStyle/>
-          <a:p>
-            <a:pPr algn="ctr"/>
-          </a:p>
-        </p:txBody>
-      </p:sp>
-      <p:sp>
-        <p:nvSpPr>
-          <p:cNvPr id="16" name="TextBox 15"/>
-          <p:cNvSpPr txBox="1"/>
-          <p:nvPr/>
-        </p:nvSpPr>
-        <p:spPr>
-          <a:xfrm>
-            <a:off x="4489704" y="1837943"/>
-            <a:ext cx="3410712" cy="219456"/>
-          </a:xfrm>
-          <a:prstGeom prst="rect">
-            <a:avLst/>
-          </a:prstGeom>
-          <a:noFill/>
-        </p:spPr>
-        <p:txBody>
-          <a:bodyPr wrap="square" anchor="t" lIns="0" rIns="0" tIns="0" bIns="0">
-            <a:spAutoFit/>
-          </a:bodyPr>
-          <a:lstStyle/>
-          <a:p>
-            <a:pPr algn="l"/>
-            <a:r>
-              <a:rPr sz="950" b="1">
-                <a:solidFill>
-                  <a:srgbClr val="0F1535"/>
-                </a:solidFill>
-                <a:latin typeface="Georgia"/>
-              </a:rPr>
-              <a:t>HIGH</a:t>
-            </a:r>
-          </a:p>
-        </p:txBody>
-      </p:sp>
-      <p:sp>
-        <p:nvSpPr>
-          <p:cNvPr id="17" name="TextBox 16"/>
-          <p:cNvSpPr txBox="1"/>
-          <p:nvPr/>
-        </p:nvSpPr>
-        <p:spPr>
-          <a:xfrm>
-            <a:off x="4489704" y="2185416"/>
-            <a:ext cx="3410712" cy="1554479"/>
-          </a:xfrm>
-          <a:prstGeom prst="rect">
-            <a:avLst/>
-          </a:prstGeom>
-          <a:noFill/>
-        </p:spPr>
-        <p:txBody>
-          <a:bodyPr wrap="square" anchor="t" lIns="0" rIns="0" tIns="0" bIns="0">
-            <a:spAutoFit/>
-          </a:bodyPr>
-          <a:lstStyle/>
-          <a:p>
-            <a:pPr algn="l"/>
-            <a:r>
-              <a:rPr sz="900" b="0">
-                <a:solidFill>
-                  <a:srgbClr val="2B3147"/>
-                </a:solidFill>
-                <a:latin typeface="Calibri"/>
-              </a:rPr>
-              <a:t>Apply the refreshed 66-site Quantcast site list, led by tvazteca.com.</a:t>
-            </a:r>
-          </a:p>
-        </p:txBody>
-      </p:sp>
-      <p:sp>
-        <p:nvSpPr>
-          <p:cNvPr id="18" name="Rectangle 17"/>
-          <p:cNvSpPr/>
-          <p:nvPr/>
-        </p:nvSpPr>
-        <p:spPr>
-          <a:xfrm>
-            <a:off x="8229600" y="1783080"/>
-            <a:ext cx="3520440" cy="2103120"/>
-          </a:xfrm>
-          <a:prstGeom prst="rect">
-            <a:avLst/>
-          </a:prstGeom>
-          <a:solidFill>
-            <a:srgbClr val="F9FAFC"/>
-          </a:solidFill>
-          <a:ln w="9525">
-            <a:solidFill>
-              <a:srgbClr val="D0D4DC"/>
-            </a:solidFill>
-          </a:ln>
-          <a:effectLst/>
-        </p:spPr>
-        <p:style>
-          <a:lnRef idx="1">
-            <a:schemeClr val="accent1"/>
-          </a:lnRef>
-          <a:fillRef idx="3">
-            <a:schemeClr val="accent1"/>
-          </a:fillRef>
-          <a:effectRef idx="2">
-            <a:schemeClr val="accent1"/>
-          </a:effectRef>
-          <a:fontRef idx="minor">
-            <a:schemeClr val="lt1"/>
-          </a:fontRef>
-        </p:style>
-        <p:txBody>
-          <a:bodyPr rtlCol="0" anchor="ctr"/>
-          <a:lstStyle/>
-          <a:p>
-            <a:pPr algn="ctr"/>
-          </a:p>
-        </p:txBody>
-      </p:sp>
-      <p:sp>
-        <p:nvSpPr>
-          <p:cNvPr id="19" name="Rectangle 18"/>
-          <p:cNvSpPr/>
-          <p:nvPr/>
-        </p:nvSpPr>
-        <p:spPr>
-          <a:xfrm>
-            <a:off x="8229600" y="1783080"/>
-            <a:ext cx="3520440" cy="292608"/>
-          </a:xfrm>
-          <a:prstGeom prst="rect">
-            <a:avLst/>
-          </a:prstGeom>
-          <a:solidFill>
-            <a:srgbClr val="0F1535"/>
-          </a:solidFill>
-          <a:ln>
-            <a:noFill/>
-          </a:ln>
-          <a:effectLst/>
-        </p:spPr>
-        <p:style>
-          <a:lnRef idx="1">
-            <a:schemeClr val="accent1"/>
-          </a:lnRef>
-          <a:fillRef idx="3">
-            <a:schemeClr val="accent1"/>
-          </a:fillRef>
-          <a:effectRef idx="2">
-            <a:schemeClr val="accent1"/>
-          </a:effectRef>
-          <a:fontRef idx="minor">
-            <a:schemeClr val="lt1"/>
-          </a:fontRef>
-        </p:style>
-        <p:txBody>
-          <a:bodyPr rtlCol="0" anchor="ctr"/>
-          <a:lstStyle/>
-          <a:p>
-            <a:pPr algn="ctr"/>
-          </a:p>
-        </p:txBody>
-      </p:sp>
-      <p:sp>
-        <p:nvSpPr>
-          <p:cNvPr id="20" name="TextBox 19"/>
-          <p:cNvSpPr txBox="1"/>
-          <p:nvPr/>
-        </p:nvSpPr>
-        <p:spPr>
-          <a:xfrm>
-            <a:off x="8375904" y="1837943"/>
-            <a:ext cx="3227832" cy="219456"/>
-          </a:xfrm>
-          <a:prstGeom prst="rect">
-            <a:avLst/>
-          </a:prstGeom>
-          <a:noFill/>
-        </p:spPr>
-        <p:txBody>
-          <a:bodyPr wrap="square" anchor="t" lIns="0" rIns="0" tIns="0" bIns="0">
-            <a:spAutoFit/>
-          </a:bodyPr>
-          <a:lstStyle/>
-          <a:p>
-            <a:pPr algn="l"/>
-            <a:r>
-              <a:rPr sz="950" b="1">
-                <a:solidFill>
-                  <a:srgbClr val="FFFFFF"/>
-                </a:solidFill>
-                <a:latin typeface="Georgia"/>
-              </a:rPr>
-              <a:t>MEASUREMENT TO CLOSE</a:t>
-            </a:r>
-          </a:p>
-        </p:txBody>
-      </p:sp>
-      <p:sp>
-        <p:nvSpPr>
-          <p:cNvPr id="21" name="TextBox 20"/>
-          <p:cNvSpPr txBox="1"/>
-          <p:nvPr/>
-        </p:nvSpPr>
-        <p:spPr>
-          <a:xfrm>
-            <a:off x="8375904" y="2185416"/>
-            <a:ext cx="3227832" cy="1554479"/>
-          </a:xfrm>
-          <a:prstGeom prst="rect">
-            <a:avLst/>
-          </a:prstGeom>
-          <a:noFill/>
-        </p:spPr>
-        <p:txBody>
-          <a:bodyPr wrap="square" anchor="t" lIns="0" rIns="0" tIns="0" bIns="0">
-            <a:spAutoFit/>
-          </a:bodyPr>
-          <a:lstStyle/>
-          <a:p>
-            <a:pPr algn="l"/>
-            <a:r>
-              <a:rPr sz="900" b="0">
-                <a:solidFill>
-                  <a:srgbClr val="2B3147"/>
-                </a:solidFill>
-                <a:latin typeface="Calibri"/>
-              </a:rPr>
-              <a:t>August is the first month GA4 can corroborate the submitted-application count.</a:t>
-            </a:r>
-          </a:p>
-          <a:p>
-            <a:pPr algn="l">
-              <a:spcBef>
-                <a:spcPts val="600"/>
-              </a:spcBef>
-            </a:pPr>
-            <a:r>
-              <a:rPr sz="900" b="0">
-                <a:solidFill>
-                  <a:srgbClr val="2B3147"/>
-                </a:solidFill>
-                <a:latin typeface="Calibri"/>
-              </a:rPr>
-              <a:t>Close out Azerion’s country-level delivery confirmation with the vendor.</a:t>
-            </a:r>
-          </a:p>
-        </p:txBody>
-      </p:sp>
-      <p:sp>
-        <p:nvSpPr>
-          <p:cNvPr id="22" name="Rectangle 21"/>
-          <p:cNvSpPr/>
-          <p:nvPr/>
-        </p:nvSpPr>
-        <p:spPr>
-          <a:xfrm>
-            <a:off x="457200" y="4069080"/>
-            <a:ext cx="3703320" cy="1828800"/>
-          </a:xfrm>
-          <a:prstGeom prst="rect">
-            <a:avLst/>
-          </a:prstGeom>
-          <a:solidFill>
-            <a:srgbClr val="F9FAFC"/>
-          </a:solidFill>
-          <a:ln w="9525">
-            <a:solidFill>
-              <a:srgbClr val="D0D4DC"/>
-            </a:solidFill>
-          </a:ln>
-          <a:effectLst/>
-        </p:spPr>
-        <p:style>
-          <a:lnRef idx="1">
-            <a:schemeClr val="accent1"/>
-          </a:lnRef>
-          <a:fillRef idx="3">
-            <a:schemeClr val="accent1"/>
-          </a:fillRef>
-          <a:effectRef idx="2">
-            <a:schemeClr val="accent1"/>
-          </a:effectRef>
-          <a:fontRef idx="minor">
-            <a:schemeClr val="lt1"/>
-          </a:fontRef>
-        </p:style>
-        <p:txBody>
-          <a:bodyPr rtlCol="0" anchor="ctr"/>
-          <a:lstStyle/>
-          <a:p>
-            <a:pPr algn="ctr"/>
-          </a:p>
-        </p:txBody>
-      </p:sp>
-      <p:sp>
-        <p:nvSpPr>
-          <p:cNvPr id="23" name="Rectangle 22"/>
-          <p:cNvSpPr/>
-          <p:nvPr/>
-        </p:nvSpPr>
-        <p:spPr>
-          <a:xfrm>
-            <a:off x="457200" y="4069080"/>
-            <a:ext cx="3703320" cy="292608"/>
-          </a:xfrm>
-          <a:prstGeom prst="rect">
-            <a:avLst/>
-          </a:prstGeom>
-          <a:solidFill>
-            <a:srgbClr val="2E7D57"/>
-          </a:solidFill>
-          <a:ln>
-            <a:noFill/>
-          </a:ln>
-          <a:effectLst/>
-        </p:spPr>
-        <p:style>
-          <a:lnRef idx="1">
-            <a:schemeClr val="accent1"/>
-          </a:lnRef>
-          <a:fillRef idx="3">
-            <a:schemeClr val="accent1"/>
-          </a:fillRef>
-          <a:effectRef idx="2">
-            <a:schemeClr val="accent1"/>
-          </a:effectRef>
-          <a:fontRef idx="minor">
-            <a:schemeClr val="lt1"/>
-          </a:fontRef>
-        </p:style>
-        <p:txBody>
-          <a:bodyPr rtlCol="0" anchor="ctr"/>
-          <a:lstStyle/>
-          <a:p>
-            <a:pPr algn="ctr"/>
-          </a:p>
-        </p:txBody>
-      </p:sp>
-      <p:sp>
-        <p:nvSpPr>
-          <p:cNvPr id="24" name="TextBox 23"/>
-          <p:cNvSpPr txBox="1"/>
-          <p:nvPr/>
-        </p:nvSpPr>
-        <p:spPr>
-          <a:xfrm>
-            <a:off x="603504" y="4123944"/>
-            <a:ext cx="3410712" cy="219456"/>
-          </a:xfrm>
-          <a:prstGeom prst="rect">
-            <a:avLst/>
-          </a:prstGeom>
-          <a:noFill/>
-        </p:spPr>
-        <p:txBody>
-          <a:bodyPr wrap="square" anchor="t" lIns="0" rIns="0" tIns="0" bIns="0">
-            <a:spAutoFit/>
-          </a:bodyPr>
-          <a:lstStyle/>
-          <a:p>
-            <a:pPr algn="l"/>
-            <a:r>
-              <a:rPr sz="950" b="1">
-                <a:solidFill>
-                  <a:srgbClr val="FFFFFF"/>
-                </a:solidFill>
-                <a:latin typeface="Georgia"/>
-              </a:rPr>
-              <a:t>OPPORTUNITY</a:t>
-            </a:r>
-          </a:p>
-        </p:txBody>
-      </p:sp>
-      <p:sp>
-        <p:nvSpPr>
-          <p:cNvPr id="25" name="TextBox 24"/>
-          <p:cNvSpPr txBox="1"/>
-          <p:nvPr/>
-        </p:nvSpPr>
-        <p:spPr>
-          <a:xfrm>
-            <a:off x="603504" y="4471416"/>
-            <a:ext cx="3410712" cy="1280160"/>
-          </a:xfrm>
-          <a:prstGeom prst="rect">
-            <a:avLst/>
-          </a:prstGeom>
-          <a:noFill/>
-        </p:spPr>
-        <p:txBody>
-          <a:bodyPr wrap="square" anchor="t" lIns="0" rIns="0" tIns="0" bIns="0">
-            <a:spAutoFit/>
-          </a:bodyPr>
-          <a:lstStyle/>
-          <a:p>
-            <a:pPr algn="l"/>
-            <a:r>
-              <a:rPr sz="900" b="0">
-                <a:solidFill>
-                  <a:srgbClr val="2B3147"/>
-                </a:solidFill>
-                <a:latin typeface="Calibri"/>
-              </a:rPr>
-              <a:t>Hold Azerion’s pace; judge the channel monthly.</a:t>
-            </a:r>
-          </a:p>
-          <a:p>
-            <a:pPr algn="l">
-              <a:spcBef>
-                <a:spcPts val="600"/>
-              </a:spcBef>
-            </a:pPr>
-            <a:r>
-              <a:rPr sz="900" b="0">
-                <a:solidFill>
-                  <a:srgbClr val="2B3147"/>
-                </a:solidFill>
-                <a:latin typeface="Calibri"/>
-              </a:rPr>
-              <a:t>Native and DOOH report in full with a second month of data.</a:t>
-            </a:r>
-          </a:p>
-        </p:txBody>
-      </p:sp>
-      <p:sp>
-        <p:nvSpPr>
-          <p:cNvPr id="26" name="Rectangle 25"/>
-          <p:cNvSpPr/>
-          <p:nvPr/>
-        </p:nvSpPr>
-        <p:spPr>
-          <a:xfrm>
-            <a:off x="4343400" y="4069080"/>
-            <a:ext cx="7406640" cy="1828800"/>
-          </a:xfrm>
-          <a:prstGeom prst="rect">
-            <a:avLst/>
-          </a:prstGeom>
-          <a:solidFill>
-            <a:srgbClr val="0F1535"/>
-          </a:solidFill>
-          <a:ln>
-            <a:noFill/>
-          </a:ln>
-          <a:effectLst/>
-        </p:spPr>
-        <p:style>
-          <a:lnRef idx="1">
-            <a:schemeClr val="accent1"/>
-          </a:lnRef>
-          <a:fillRef idx="3">
-            <a:schemeClr val="accent1"/>
-          </a:fillRef>
-          <a:effectRef idx="2">
-            <a:schemeClr val="accent1"/>
-          </a:effectRef>
-          <a:fontRef idx="minor">
-            <a:schemeClr val="lt1"/>
-          </a:fontRef>
-        </p:style>
-        <p:txBody>
-          <a:bodyPr rtlCol="0" anchor="ctr"/>
-          <a:lstStyle/>
-          <a:p>
-            <a:pPr algn="ctr"/>
-          </a:p>
-        </p:txBody>
-      </p:sp>
-      <p:sp>
-        <p:nvSpPr>
-          <p:cNvPr id="27" name="TextBox 26"/>
-          <p:cNvSpPr txBox="1"/>
-          <p:nvPr/>
-        </p:nvSpPr>
-        <p:spPr>
-          <a:xfrm>
-            <a:off x="4617720" y="4069080"/>
-            <a:ext cx="6858000" cy="1828800"/>
-          </a:xfrm>
-          <a:prstGeom prst="rect">
-            <a:avLst/>
-          </a:prstGeom>
-          <a:noFill/>
-        </p:spPr>
-        <p:txBody>
-          <a:bodyPr wrap="square" anchor="ctr" lIns="0" rIns="0" tIns="0" bIns="0">
-            <a:spAutoFit/>
-          </a:bodyPr>
-          <a:lstStyle/>
-          <a:p>
-            <a:pPr algn="l"/>
-            <a:r>
-              <a:rPr sz="1200" b="1">
-                <a:solidFill>
-                  <a:srgbClr val="FFFFFF"/>
-                </a:solidFill>
-                <a:latin typeface="Georgia"/>
-              </a:rPr>
-              <a:t>The rebuilt structure converted at $237.12 in July. August scales it, holds programmatic quality, and brings GA4 corroboration online.</a:t>
+              <a:t>Decisions are made per channel from each partner’s own reporting, per the methodology note on the executive summary.</a:t>
             </a:r>
           </a:p>
         </p:txBody>
@@ -14354,7 +13869,7 @@
                 </a:solidFill>
                 <a:latin typeface="Calibri"/>
               </a:rPr>
-              <a:t>•  Working media reached $149,896 in July, up 24% MoM. The growth sits in the new Native and DOOH lines; the four continuing channels spent $95,401 against June’s total of $120,393, and paid submitted applications with a measured source (Bing plus Azerion) came in at 61.</a:t>
+              <a:t>•  Working media reached $149,896 in July, up 24% MoM. The growth sits in the new Native and DOOH lines; the four continuing channels spent $95,401 against June’s total of $120,393.</a:t>
             </a:r>
           </a:p>
           <a:p>
@@ -16937,7 +16452,7 @@
                 </a:solidFill>
                 <a:latin typeface="Georgia"/>
               </a:rPr>
-              <a:t>$149,896 deployed in July. Bing and Azerion produced 61 submitted applications at $789.08.</a:t>
+              <a:t>$149,896 deployed in July across seven lines.</a:t>
             </a:r>
           </a:p>
         </p:txBody>
@@ -17608,7 +17123,7 @@
                           </a:solidFill>
                           <a:latin typeface="Calibri"/>
                         </a:rPr>
-                        <a:t>41*</a:t>
+                        <a:t>41</a:t>
                       </a:r>
                     </a:p>
                   </a:txBody>
@@ -17631,7 +17146,7 @@
                           </a:solidFill>
                           <a:latin typeface="Calibri"/>
                         </a:rPr>
-                        <a:t>$914.85*</a:t>
+                        <a:t>$914.85</a:t>
                       </a:r>
                     </a:p>
                   </a:txBody>
@@ -18236,7 +17751,7 @@
                 </a:solidFill>
                 <a:latin typeface="Calibri"/>
               </a:rPr>
-              <a:t>* Azerion applications are vendor-reported; Bing applications are SA360-reported, the account’s conversion source of record. Conversions come from different systems per channel and are never summed; the combined Bing + Azerion view is the one sanctioned pairing. Meta clicks are link clicks. Spend per the client budget tracker.</a:t>
+              <a:t>Channel results reflect each platform or partner’s reporting methodology and should be interpreted independently. Cross-channel totals and blended acquisition costs are not used because attribution systems are not directly comparable. Meta clicks are link clicks. Spend per the client budget tracker.</a:t>
             </a:r>
           </a:p>
         </p:txBody>
@@ -18361,7 +17876,7 @@
                 </a:solidFill>
                 <a:latin typeface="Georgia"/>
               </a:rPr>
-              <a:t>THE SCORECARD</a:t>
+              <a:t>THE SCORECARD, BY CHANNEL</a:t>
             </a:r>
           </a:p>
         </p:txBody>
@@ -18396,7 +17911,7 @@
                 </a:solidFill>
                 <a:latin typeface="Calibri"/>
               </a:rPr>
-              <a:t>Bing and Azerion, the two channels with a submitted-application figure behind them, produced 61 applications combined at $789.08 (June: 92 at $660.00).</a:t>
+              <a:t>Bing: 20 submitted applications at $531.25, on SA360 reporting.</a:t>
             </a:r>
           </a:p>
           <a:p>
@@ -18412,7 +17927,23 @@
                 </a:solidFill>
                 <a:latin typeface="Calibri"/>
               </a:rPr>
-              <a:t>The rise traces to Bing, which spent the first third of July rebuilding its campaign structure and the next third transitioning to it, not to Azerion, which held steady.</a:t>
+              <a:t>Azerion: 41 partner-attributed applications at $914.85, steady on June.</a:t>
+            </a:r>
+          </a:p>
+          <a:p>
+            <a:pPr algn="l">
+              <a:spcBef>
+                <a:spcPts val="600"/>
+              </a:spcBef>
+            </a:pPr>
+            <a:r>
+              <a:rPr sz="950" b="0">
+                <a:solidFill>
+                  <a:srgbClr val="2B3147"/>
+                </a:solidFill>
+                <a:latin typeface="Calibri"/>
+              </a:rPr>
+              <a:t>Quantcast: 15 partner-attributed results, from 11 in June.</a:t>
             </a:r>
           </a:p>
         </p:txBody>
@@ -19446,7 +18977,7 @@
                 </a:solidFill>
                 <a:latin typeface="Calibri"/>
               </a:rPr>
-              <a:t>Both upper-funnel. Native reports spend and delivery with no conversion claim; DOOH reports delivery on its own slides.</a:t>
+              <a:t>Native is read on engagement and traffic quality; DOOH reports delivery on its own slides.</a:t>
             </a:r>
           </a:p>
           <a:p>
@@ -22253,7 +21784,7 @@
                 </a:solidFill>
                 <a:latin typeface="Calibri"/>
               </a:rPr>
-              <a:t>Scale the rebuilt structure behind the TradingView theme, holding the July close of $237.12 as volume grows. August’s first days track at $243, with three products converting.</a:t>
+              <a:t>Increase Bing within CPA and delivery guardrails, scaling the rebuilt structure behind the TradingView theme from the July close of $237.12. August’s first days track at $243.</a:t>
             </a:r>
           </a:p>
           <a:p>
@@ -23753,7 +23284,7 @@
                 </a:solidFill>
                 <a:latin typeface="Calibri"/>
               </a:rPr>
-              <a:t>directional only</a:t>
+              <a:t>partner-attributed</a:t>
             </a:r>
           </a:p>
         </p:txBody>
@@ -23929,7 +23460,7 @@
                 </a:solidFill>
                 <a:latin typeface="Calibri"/>
               </a:rPr>
-              <a:t>Result volume (15) is too low to support a cost-per-result figure; the channel reads as an awareness and reach story this month.</a:t>
+              <a:t>Partner-attributed results came in at 15, from 11 in June, including the first click-through results of the year.</a:t>
             </a:r>
           </a:p>
           <a:p>
@@ -24787,7 +24318,7 @@
                 </a:solidFill>
                 <a:latin typeface="Calibri"/>
               </a:rPr>
-              <a:t>Keep the channel judged on reach and cost of reach until result volume supports more.</a:t>
+              <a:t>Maintain a bounded role with explicit inventory and qualified-traffic expectations.</a:t>
             </a:r>
           </a:p>
         </p:txBody>
@@ -24987,7 +24518,7 @@
                 </a:solidFill>
                 <a:latin typeface="Georgia"/>
               </a:rPr>
-              <a:t>41 vendor-reported applications at $914.85, from 42 at $834 in June.</a:t>
+              <a:t>41 partner-attributed applications at $914.85, from 42 at $834 in June.</a:t>
             </a:r>
           </a:p>
         </p:txBody>
@@ -25881,7 +25412,7 @@
                 </a:solidFill>
                 <a:latin typeface="Calibri"/>
               </a:rPr>
-              <a:t>vendor-reported</a:t>
+              <a:t>partner-attributed</a:t>
             </a:r>
           </a:p>
         </p:txBody>
@@ -26076,7 +25607,7 @@
                 </a:solidFill>
                 <a:latin typeface="Calibri"/>
               </a:rPr>
-              <a:t>vendor-reported</a:t>
+              <a:t>partner-attributed</a:t>
             </a:r>
           </a:p>
         </p:txBody>
@@ -26431,7 +25962,7 @@
                 </a:solidFill>
                 <a:latin typeface="Calibri"/>
               </a:rPr>
-              <a:t>Applications are reported by the vendor’s own tracking rather than by SA360, the source of record behind Bing’s count; the distinction travels with the number.</a:t>
+              <a:t>Applications are partner-attributed, per Azerion’s reporting framework.</a:t>
             </a:r>
           </a:p>
           <a:p>

</xml_diff>